<commit_message>
cierre_base.pptx: slide2 fondo correcto + titulo atraso + eventualidades CSV
</commit_message>
<xml_diff>
--- a/cierre_base.pptx
+++ b/cierre_base.pptx
@@ -9683,7 +9683,7 @@
               <a:rPr lang="es-MX" b="1" dirty="0">
                 <a:latin typeface="Aptos (cuerpo)"/>
               </a:rPr>
-              <a:t>Eventualidades de proyectos con retraso</a:t>
+              <a:t>Eventualidades de proyectos con atraso</a:t>
             </a:r>
             <a:endParaRPr lang="es-MX" b="1" dirty="0">
               <a:highlight>
@@ -9751,14 +9751,12 @@
                         <a:buNone/>
                       </a:pPr>
                       <a:r>
-                        <a:rPr lang="es-MX" sz="1100" u="none" strike="noStrike" kern="1200">
+                        <a:rPr lang="es-MX" sz="1100" b="1" u="none" strike="noStrike" kern="1200">
                           <a:solidFill>
                             <a:schemeClr val="tx1"/>
                           </a:solidFill>
                           <a:effectLst/>
                           <a:latin typeface="Aptos (cuerpo)"/>
-                          <a:ea typeface="+mn-ea"/>
-                          <a:cs typeface="+mn-cs"/>
                         </a:rPr>
                         <a:t>No</a:t>
                       </a:r>
@@ -9770,36 +9768,24 @@
                         <a:schemeClr val="tx1"/>
                       </a:solidFill>
                       <a:prstDash val="solid"/>
-                      <a:round/>
-                      <a:headEnd type="none" w="med" len="med"/>
-                      <a:tailEnd type="none" w="med" len="med"/>
                     </a:lnL>
                     <a:lnR w="12700" cap="flat" cmpd="sng" algn="ctr">
                       <a:solidFill>
                         <a:schemeClr val="tx1"/>
                       </a:solidFill>
                       <a:prstDash val="solid"/>
-                      <a:round/>
-                      <a:headEnd type="none" w="med" len="med"/>
-                      <a:tailEnd type="none" w="med" len="med"/>
                     </a:lnR>
                     <a:lnT w="12700" cap="flat" cmpd="sng" algn="ctr">
                       <a:solidFill>
                         <a:schemeClr val="tx1"/>
                       </a:solidFill>
                       <a:prstDash val="solid"/>
-                      <a:round/>
-                      <a:headEnd type="none" w="med" len="med"/>
-                      <a:tailEnd type="none" w="med" len="med"/>
                     </a:lnT>
                     <a:lnB w="12700" cap="flat" cmpd="sng" algn="ctr">
                       <a:solidFill>
                         <a:schemeClr val="tx1"/>
                       </a:solidFill>
                       <a:prstDash val="solid"/>
-                      <a:round/>
-                      <a:headEnd type="none" w="med" len="med"/>
-                      <a:tailEnd type="none" w="med" len="med"/>
                     </a:lnB>
                     <a:noFill/>
                   </a:tcPr>
@@ -9813,14 +9799,12 @@
                         <a:buNone/>
                       </a:pPr>
                       <a:r>
-                        <a:rPr lang="es-MX" sz="1100" u="none" strike="noStrike" kern="1200">
+                        <a:rPr lang="es-MX" sz="1100" b="1" u="none" strike="noStrike" kern="1200">
                           <a:solidFill>
                             <a:schemeClr val="tx1"/>
                           </a:solidFill>
                           <a:effectLst/>
                           <a:latin typeface="Aptos (cuerpo)"/>
-                          <a:ea typeface="+mn-ea"/>
-                          <a:cs typeface="+mn-cs"/>
                         </a:rPr>
                         <a:t>Proyecto</a:t>
                       </a:r>
@@ -9832,36 +9816,24 @@
                         <a:schemeClr val="tx1"/>
                       </a:solidFill>
                       <a:prstDash val="solid"/>
-                      <a:round/>
-                      <a:headEnd type="none" w="med" len="med"/>
-                      <a:tailEnd type="none" w="med" len="med"/>
                     </a:lnL>
                     <a:lnR w="12700" cap="flat" cmpd="sng" algn="ctr">
                       <a:solidFill>
                         <a:schemeClr val="tx1"/>
                       </a:solidFill>
                       <a:prstDash val="solid"/>
-                      <a:round/>
-                      <a:headEnd type="none" w="med" len="med"/>
-                      <a:tailEnd type="none" w="med" len="med"/>
                     </a:lnR>
                     <a:lnT w="12700" cap="flat" cmpd="sng" algn="ctr">
                       <a:solidFill>
                         <a:schemeClr val="tx1"/>
                       </a:solidFill>
                       <a:prstDash val="solid"/>
-                      <a:round/>
-                      <a:headEnd type="none" w="med" len="med"/>
-                      <a:tailEnd type="none" w="med" len="med"/>
                     </a:lnT>
                     <a:lnB w="12700" cap="flat" cmpd="sng" algn="ctr">
                       <a:solidFill>
                         <a:schemeClr val="tx1"/>
                       </a:solidFill>
                       <a:prstDash val="solid"/>
-                      <a:round/>
-                      <a:headEnd type="none" w="med" len="med"/>
-                      <a:tailEnd type="none" w="med" len="med"/>
                     </a:lnB>
                     <a:noFill/>
                   </a:tcPr>
@@ -9871,18 +9843,16 @@
                     <a:bodyPr/>
                     <a:lstStyle/>
                     <a:p>
-                      <a:pPr algn="ctr" fontAlgn="b">
+                      <a:pPr marL="0" algn="ctr" defTabSz="457200" rtl="0" eaLnBrk="1" fontAlgn="b" latinLnBrk="0" hangingPunct="1">
                         <a:buNone/>
                       </a:pPr>
                       <a:r>
-                        <a:rPr lang="es-MX" sz="1100" u="none" strike="noStrike" kern="1200">
+                        <a:rPr lang="es-MX" sz="1100" b="1" u="none" strike="noStrike" kern="1200">
                           <a:solidFill>
                             <a:schemeClr val="tx1"/>
                           </a:solidFill>
                           <a:effectLst/>
                           <a:latin typeface="Aptos (cuerpo)"/>
-                          <a:ea typeface="+mn-ea"/>
-                          <a:cs typeface="+mn-cs"/>
                         </a:rPr>
                         <a:t>Eventualidades</a:t>
                       </a:r>
@@ -9894,57 +9864,40 @@
                         <a:schemeClr val="tx1"/>
                       </a:solidFill>
                       <a:prstDash val="solid"/>
-                      <a:round/>
-                      <a:headEnd type="none" w="med" len="med"/>
-                      <a:tailEnd type="none" w="med" len="med"/>
                     </a:lnL>
                     <a:lnR w="12700" cap="flat" cmpd="sng" algn="ctr">
                       <a:solidFill>
                         <a:schemeClr val="tx1"/>
                       </a:solidFill>
                       <a:prstDash val="solid"/>
-                      <a:round/>
-                      <a:headEnd type="none" w="med" len="med"/>
-                      <a:tailEnd type="none" w="med" len="med"/>
                     </a:lnR>
                     <a:lnT w="12700" cap="flat" cmpd="sng" algn="ctr">
                       <a:solidFill>
                         <a:schemeClr val="tx1"/>
                       </a:solidFill>
                       <a:prstDash val="solid"/>
-                      <a:round/>
-                      <a:headEnd type="none" w="med" len="med"/>
-                      <a:tailEnd type="none" w="med" len="med"/>
                     </a:lnT>
                     <a:lnB w="12700" cap="flat" cmpd="sng" algn="ctr">
                       <a:solidFill>
                         <a:schemeClr val="tx1"/>
                       </a:solidFill>
                       <a:prstDash val="solid"/>
-                      <a:round/>
-                      <a:headEnd type="none" w="med" len="med"/>
-                      <a:tailEnd type="none" w="med" len="med"/>
                     </a:lnB>
                     <a:noFill/>
                   </a:tcPr>
                 </a:tc>
-                <a:extLst>
-                  <a:ext uri="{0D108BD9-81ED-4DB2-BD59-A6C34878D82A}">
-                    <a16:rowId xmlns:a16="http://schemas.microsoft.com/office/drawing/2014/main" val="4174057675"/>
-                  </a:ext>
-                </a:extLst>
               </a:tr>
-              <a:tr h="349144">
+              <a:tr h="420000">
                 <a:tc>
                   <a:txBody>
                     <a:bodyPr/>
                     <a:lstStyle/>
                     <a:p>
-                      <a:pPr algn="ctr" fontAlgn="b">
+                      <a:pPr marL="0" algn="ctr" defTabSz="457200" rtl="0" eaLnBrk="1" fontAlgn="b" latinLnBrk="0" hangingPunct="1">
                         <a:buNone/>
                       </a:pPr>
                       <a:r>
-                        <a:rPr lang="es-MX" sz="1100" b="0" i="0" u="none" strike="noStrike">
+                        <a:rPr lang="es-MX" sz="1000" u="none" strike="noStrike" kern="1200">
                           <a:solidFill>
                             <a:schemeClr val="tx1"/>
                           </a:solidFill>
@@ -9961,36 +9914,24 @@
                         <a:schemeClr val="tx1"/>
                       </a:solidFill>
                       <a:prstDash val="solid"/>
-                      <a:round/>
-                      <a:headEnd type="none" w="med" len="med"/>
-                      <a:tailEnd type="none" w="med" len="med"/>
                     </a:lnL>
                     <a:lnR w="12700" cap="flat" cmpd="sng" algn="ctr">
                       <a:solidFill>
                         <a:schemeClr val="tx1"/>
                       </a:solidFill>
                       <a:prstDash val="solid"/>
-                      <a:round/>
-                      <a:headEnd type="none" w="med" len="med"/>
-                      <a:tailEnd type="none" w="med" len="med"/>
                     </a:lnR>
                     <a:lnT w="12700" cap="flat" cmpd="sng" algn="ctr">
                       <a:solidFill>
                         <a:schemeClr val="tx1"/>
                       </a:solidFill>
                       <a:prstDash val="solid"/>
-                      <a:round/>
-                      <a:headEnd type="none" w="med" len="med"/>
-                      <a:tailEnd type="none" w="med" len="med"/>
                     </a:lnT>
                     <a:lnB w="12700" cap="flat" cmpd="sng" algn="ctr">
                       <a:solidFill>
                         <a:schemeClr val="tx1"/>
                       </a:solidFill>
                       <a:prstDash val="solid"/>
-                      <a:round/>
-                      <a:headEnd type="none" w="med" len="med"/>
-                      <a:tailEnd type="none" w="med" len="med"/>
                     </a:lnB>
                     <a:noFill/>
                   </a:tcPr>
@@ -10000,40 +9941,19 @@
                     <a:bodyPr/>
                     <a:lstStyle/>
                     <a:p>
-                      <a:pPr marL="0" marR="0" lvl="0" indent="0" algn="l" defTabSz="685800" rtl="0" eaLnBrk="1" fontAlgn="b" latinLnBrk="0" hangingPunct="1">
-                        <a:lnSpc>
-                          <a:spcPct val="100000"/>
-                        </a:lnSpc>
-                        <a:spcBef>
-                          <a:spcPts val="0"/>
-                        </a:spcBef>
-                        <a:spcAft>
-                          <a:spcPts val="0"/>
-                        </a:spcAft>
-                        <a:buClrTx/>
-                        <a:buSzTx/>
-                        <a:buFontTx/>
+                      <a:pPr marL="0" algn="l" defTabSz="457200" rtl="0" eaLnBrk="1" fontAlgn="b" latinLnBrk="0" hangingPunct="1">
                         <a:buNone/>
-                        <a:tabLst/>
-                        <a:defRPr/>
                       </a:pPr>
                       <a:r>
-                        <a:rPr lang="es-MX" sz="1100" u="none" strike="noStrike">
+                        <a:rPr lang="es-MX" sz="1000" u="none" strike="noStrike" kern="1200">
                           <a:solidFill>
                             <a:schemeClr val="tx1"/>
                           </a:solidFill>
                           <a:effectLst/>
                           <a:latin typeface="Aptos (cuerpo)"/>
                         </a:rPr>
-                        <a:t>Cartera || Cambio de PAC de timbrado (ATEB)</a:t>
-                      </a:r>
-                      <a:endParaRPr lang="es-MX" sz="1100" b="0" i="0" u="none" strike="noStrike">
-                        <a:solidFill>
-                          <a:schemeClr val="tx1"/>
-                        </a:solidFill>
-                        <a:effectLst/>
-                        <a:latin typeface="Aptos (cuerpo)"/>
-                      </a:endParaRPr>
+                        <a:t>Tesoreria || Adcontent H2H</a:t>
+                      </a:r>
                     </a:p>
                   </a:txBody>
                   <a:tcPr marL="6244" marR="6244" marT="6244" marB="0" anchor="ctr">
@@ -10042,36 +9962,24 @@
                         <a:schemeClr val="tx1"/>
                       </a:solidFill>
                       <a:prstDash val="solid"/>
-                      <a:round/>
-                      <a:headEnd type="none" w="med" len="med"/>
-                      <a:tailEnd type="none" w="med" len="med"/>
                     </a:lnL>
                     <a:lnR w="12700" cap="flat" cmpd="sng" algn="ctr">
                       <a:solidFill>
                         <a:schemeClr val="tx1"/>
                       </a:solidFill>
                       <a:prstDash val="solid"/>
-                      <a:round/>
-                      <a:headEnd type="none" w="med" len="med"/>
-                      <a:tailEnd type="none" w="med" len="med"/>
                     </a:lnR>
                     <a:lnT w="12700" cap="flat" cmpd="sng" algn="ctr">
                       <a:solidFill>
                         <a:schemeClr val="tx1"/>
                       </a:solidFill>
                       <a:prstDash val="solid"/>
-                      <a:round/>
-                      <a:headEnd type="none" w="med" len="med"/>
-                      <a:tailEnd type="none" w="med" len="med"/>
                     </a:lnT>
                     <a:lnB w="12700" cap="flat" cmpd="sng" algn="ctr">
                       <a:solidFill>
                         <a:schemeClr val="tx1"/>
                       </a:solidFill>
                       <a:prstDash val="solid"/>
-                      <a:round/>
-                      <a:headEnd type="none" w="med" len="med"/>
-                      <a:tailEnd type="none" w="med" len="med"/>
                     </a:lnB>
                     <a:noFill/>
                   </a:tcPr>
@@ -10081,18 +9989,18 @@
                     <a:bodyPr/>
                     <a:lstStyle/>
                     <a:p>
-                      <a:pPr algn="l" fontAlgn="b">
+                      <a:pPr marL="0" algn="l" defTabSz="457200" rtl="0" eaLnBrk="1" fontAlgn="b" latinLnBrk="0" hangingPunct="1">
                         <a:buNone/>
                       </a:pPr>
                       <a:r>
-                        <a:rPr lang="es-MX" sz="1100" b="0" i="0" u="none" strike="noStrike">
+                        <a:rPr lang="es-MX" sz="1000" u="none" strike="noStrike" kern="1200">
                           <a:solidFill>
                             <a:schemeClr val="tx1"/>
                           </a:solidFill>
                           <a:effectLst/>
                           <a:latin typeface="Aptos (cuerpo)"/>
                         </a:rPr>
-                        <a:t>Pendiente de Firma de convenio de Lumo, Firma de AyO pendiente de firma de Representante Legal</a:t>
+                        <a:t>eventualdiad</a:t>
                       </a:r>
                     </a:p>
                   </a:txBody>
@@ -10102,57 +10010,40 @@
                         <a:schemeClr val="tx1"/>
                       </a:solidFill>
                       <a:prstDash val="solid"/>
-                      <a:round/>
-                      <a:headEnd type="none" w="med" len="med"/>
-                      <a:tailEnd type="none" w="med" len="med"/>
                     </a:lnL>
                     <a:lnR w="12700" cap="flat" cmpd="sng" algn="ctr">
                       <a:solidFill>
                         <a:schemeClr val="tx1"/>
                       </a:solidFill>
                       <a:prstDash val="solid"/>
-                      <a:round/>
-                      <a:headEnd type="none" w="med" len="med"/>
-                      <a:tailEnd type="none" w="med" len="med"/>
                     </a:lnR>
                     <a:lnT w="12700" cap="flat" cmpd="sng" algn="ctr">
                       <a:solidFill>
                         <a:schemeClr val="tx1"/>
                       </a:solidFill>
                       <a:prstDash val="solid"/>
-                      <a:round/>
-                      <a:headEnd type="none" w="med" len="med"/>
-                      <a:tailEnd type="none" w="med" len="med"/>
                     </a:lnT>
                     <a:lnB w="12700" cap="flat" cmpd="sng" algn="ctr">
                       <a:solidFill>
                         <a:schemeClr val="tx1"/>
                       </a:solidFill>
                       <a:prstDash val="solid"/>
-                      <a:round/>
-                      <a:headEnd type="none" w="med" len="med"/>
-                      <a:tailEnd type="none" w="med" len="med"/>
                     </a:lnB>
                     <a:noFill/>
                   </a:tcPr>
                 </a:tc>
-                <a:extLst>
-                  <a:ext uri="{0D108BD9-81ED-4DB2-BD59-A6C34878D82A}">
-                    <a16:rowId xmlns:a16="http://schemas.microsoft.com/office/drawing/2014/main" val="3248437908"/>
-                  </a:ext>
-                </a:extLst>
               </a:tr>
-              <a:tr h="520594">
+              <a:tr h="420000">
                 <a:tc>
                   <a:txBody>
                     <a:bodyPr/>
                     <a:lstStyle/>
                     <a:p>
-                      <a:pPr algn="ctr" fontAlgn="b">
+                      <a:pPr marL="0" algn="ctr" defTabSz="457200" rtl="0" eaLnBrk="1" fontAlgn="b" latinLnBrk="0" hangingPunct="1">
                         <a:buNone/>
                       </a:pPr>
                       <a:r>
-                        <a:rPr lang="es-ES" sz="1100" b="0" i="0" u="none" strike="noStrike">
+                        <a:rPr lang="es-MX" sz="1000" u="none" strike="noStrike" kern="1200">
                           <a:solidFill>
                             <a:schemeClr val="tx1"/>
                           </a:solidFill>
@@ -10161,13 +10052,6 @@
                         </a:rPr>
                         <a:t>2</a:t>
                       </a:r>
-                      <a:endParaRPr lang="es-MX" sz="1100" b="0" i="0" u="none" strike="noStrike">
-                        <a:solidFill>
-                          <a:schemeClr val="tx1"/>
-                        </a:solidFill>
-                        <a:effectLst/>
-                        <a:latin typeface="Aptos (cuerpo)"/>
-                      </a:endParaRPr>
                     </a:p>
                   </a:txBody>
                   <a:tcPr marL="6244" marR="6244" marT="6244" marB="0" anchor="ctr">
@@ -10176,36 +10060,24 @@
                         <a:schemeClr val="tx1"/>
                       </a:solidFill>
                       <a:prstDash val="solid"/>
-                      <a:round/>
-                      <a:headEnd type="none" w="med" len="med"/>
-                      <a:tailEnd type="none" w="med" len="med"/>
                     </a:lnL>
                     <a:lnR w="12700" cap="flat" cmpd="sng" algn="ctr">
                       <a:solidFill>
                         <a:schemeClr val="tx1"/>
                       </a:solidFill>
                       <a:prstDash val="solid"/>
-                      <a:round/>
-                      <a:headEnd type="none" w="med" len="med"/>
-                      <a:tailEnd type="none" w="med" len="med"/>
                     </a:lnR>
                     <a:lnT w="12700" cap="flat" cmpd="sng" algn="ctr">
                       <a:solidFill>
                         <a:schemeClr val="tx1"/>
                       </a:solidFill>
                       <a:prstDash val="solid"/>
-                      <a:round/>
-                      <a:headEnd type="none" w="med" len="med"/>
-                      <a:tailEnd type="none" w="med" len="med"/>
                     </a:lnT>
                     <a:lnB w="12700" cap="flat" cmpd="sng" algn="ctr">
                       <a:solidFill>
                         <a:schemeClr val="tx1"/>
                       </a:solidFill>
                       <a:prstDash val="solid"/>
-                      <a:round/>
-                      <a:headEnd type="none" w="med" len="med"/>
-                      <a:tailEnd type="none" w="med" len="med"/>
                     </a:lnB>
                     <a:noFill/>
                   </a:tcPr>
@@ -10215,20 +10087,18 @@
                     <a:bodyPr/>
                     <a:lstStyle/>
                     <a:p>
-                      <a:pPr algn="l" fontAlgn="b">
+                      <a:pPr marL="0" algn="l" defTabSz="457200" rtl="0" eaLnBrk="1" fontAlgn="b" latinLnBrk="0" hangingPunct="1">
                         <a:buNone/>
                       </a:pPr>
                       <a:r>
-                        <a:rPr lang="es-MX" sz="1100" b="0" i="0" u="none" strike="noStrike" kern="1200" dirty="0">
+                        <a:rPr lang="es-MX" sz="1000" u="none" strike="noStrike" kern="1200">
                           <a:solidFill>
                             <a:schemeClr val="tx1"/>
                           </a:solidFill>
                           <a:effectLst/>
                           <a:latin typeface="Aptos (cuerpo)"/>
-                          <a:ea typeface="+mn-ea"/>
-                          <a:cs typeface="+mn-cs"/>
-                        </a:rPr>
-                        <a:t>Contabilidad || Integración Mecánica – SAE (Fase 1-2)</a:t>
+                        </a:rPr>
+                        <a:t>Operaciones Fleet || Data Lab</a:t>
                       </a:r>
                     </a:p>
                   </a:txBody>
@@ -10238,36 +10108,24 @@
                         <a:schemeClr val="tx1"/>
                       </a:solidFill>
                       <a:prstDash val="solid"/>
-                      <a:round/>
-                      <a:headEnd type="none" w="med" len="med"/>
-                      <a:tailEnd type="none" w="med" len="med"/>
                     </a:lnL>
                     <a:lnR w="12700" cap="flat" cmpd="sng" algn="ctr">
                       <a:solidFill>
                         <a:schemeClr val="tx1"/>
                       </a:solidFill>
                       <a:prstDash val="solid"/>
-                      <a:round/>
-                      <a:headEnd type="none" w="med" len="med"/>
-                      <a:tailEnd type="none" w="med" len="med"/>
                     </a:lnR>
                     <a:lnT w="12700" cap="flat" cmpd="sng" algn="ctr">
                       <a:solidFill>
                         <a:schemeClr val="tx1"/>
                       </a:solidFill>
                       <a:prstDash val="solid"/>
-                      <a:round/>
-                      <a:headEnd type="none" w="med" len="med"/>
-                      <a:tailEnd type="none" w="med" len="med"/>
                     </a:lnT>
                     <a:lnB w="12700" cap="flat" cmpd="sng" algn="ctr">
                       <a:solidFill>
                         <a:schemeClr val="tx1"/>
                       </a:solidFill>
                       <a:prstDash val="solid"/>
-                      <a:round/>
-                      <a:headEnd type="none" w="med" len="med"/>
-                      <a:tailEnd type="none" w="med" len="med"/>
                     </a:lnB>
                     <a:noFill/>
                   </a:tcPr>
@@ -10277,65 +10135,19 @@
                     <a:bodyPr/>
                     <a:lstStyle/>
                     <a:p>
-                      <a:pPr marL="0" lvl="0" indent="0" algn="l">
-                        <a:lnSpc>
-                          <a:spcPct val="100000"/>
-                        </a:lnSpc>
-                        <a:spcBef>
-                          <a:spcPts val="0"/>
-                        </a:spcBef>
-                        <a:spcAft>
-                          <a:spcPts val="0"/>
-                        </a:spcAft>
+                      <a:pPr marL="0" algn="l" defTabSz="457200" rtl="0" eaLnBrk="1" fontAlgn="b" latinLnBrk="0" hangingPunct="1">
                         <a:buNone/>
                       </a:pPr>
                       <a:r>
-                        <a:rPr lang="es-MX" sz="1100" b="0" i="0" u="none" strike="noStrike" kern="1200" noProof="0">
+                        <a:rPr lang="es-MX" sz="1000" u="none" strike="noStrike" kern="1200">
                           <a:solidFill>
                             <a:schemeClr val="tx1"/>
                           </a:solidFill>
                           <a:effectLst/>
                           <a:latin typeface="Aptos (cuerpo)"/>
-                          <a:ea typeface="+mn-ea"/>
-                          <a:cs typeface="+mn-cs"/>
-                        </a:rPr>
-                        <a:t>Se tuvieron imprevistos en la carga del catálogo de refacciones en Mecanica Mx</a:t>
-                      </a:r>
-                    </a:p>
-                    <a:p>
-                      <a:pPr marL="0" lvl="0" indent="0" algn="l">
-                        <a:lnSpc>
-                          <a:spcPct val="100000"/>
-                        </a:lnSpc>
-                        <a:spcBef>
-                          <a:spcPts val="0"/>
-                        </a:spcBef>
-                        <a:spcAft>
-                          <a:spcPts val="0"/>
-                        </a:spcAft>
-                        <a:buNone/>
-                      </a:pPr>
-                      <a:r>
-                        <a:rPr lang="es-MX" sz="1100" b="0" i="0" u="none" strike="noStrike" kern="1200" noProof="0">
-                          <a:solidFill>
-                            <a:schemeClr val="tx1"/>
-                          </a:solidFill>
-                          <a:effectLst/>
-                          <a:latin typeface="Aptos (cuerpo)"/>
-                          <a:ea typeface="+mn-ea"/>
-                          <a:cs typeface="+mn-cs"/>
-                        </a:rPr>
-                        <a:t>Actualización del catálogo de proveedores.</a:t>
-                      </a:r>
-                      <a:endParaRPr lang="es-MX" sz="1100" b="0" i="0" u="none" strike="noStrike" kern="1200">
-                        <a:solidFill>
-                          <a:schemeClr val="tx1"/>
-                        </a:solidFill>
-                        <a:effectLst/>
-                        <a:latin typeface="Aptos (cuerpo)"/>
-                        <a:ea typeface="+mn-ea"/>
-                        <a:cs typeface="+mn-cs"/>
-                      </a:endParaRPr>
+                        </a:rPr>
+                        <a:t>dasdasdasdasd</a:t>
+                      </a:r>
                     </a:p>
                   </a:txBody>
                   <a:tcPr marL="6244" marR="6244" marT="6244" marB="0" anchor="ctr">
@@ -10344,57 +10156,40 @@
                         <a:schemeClr val="tx1"/>
                       </a:solidFill>
                       <a:prstDash val="solid"/>
-                      <a:round/>
-                      <a:headEnd type="none" w="med" len="med"/>
-                      <a:tailEnd type="none" w="med" len="med"/>
                     </a:lnL>
                     <a:lnR w="12700" cap="flat" cmpd="sng" algn="ctr">
                       <a:solidFill>
                         <a:schemeClr val="tx1"/>
                       </a:solidFill>
                       <a:prstDash val="solid"/>
-                      <a:round/>
-                      <a:headEnd type="none" w="med" len="med"/>
-                      <a:tailEnd type="none" w="med" len="med"/>
                     </a:lnR>
                     <a:lnT w="12700" cap="flat" cmpd="sng" algn="ctr">
                       <a:solidFill>
                         <a:schemeClr val="tx1"/>
                       </a:solidFill>
                       <a:prstDash val="solid"/>
-                      <a:round/>
-                      <a:headEnd type="none" w="med" len="med"/>
-                      <a:tailEnd type="none" w="med" len="med"/>
                     </a:lnT>
                     <a:lnB w="12700" cap="flat" cmpd="sng" algn="ctr">
                       <a:solidFill>
                         <a:schemeClr val="tx1"/>
                       </a:solidFill>
                       <a:prstDash val="solid"/>
-                      <a:round/>
-                      <a:headEnd type="none" w="med" len="med"/>
-                      <a:tailEnd type="none" w="med" len="med"/>
                     </a:lnB>
                     <a:noFill/>
                   </a:tcPr>
                 </a:tc>
-                <a:extLst>
-                  <a:ext uri="{0D108BD9-81ED-4DB2-BD59-A6C34878D82A}">
-                    <a16:rowId xmlns:a16="http://schemas.microsoft.com/office/drawing/2014/main" val="1382980361"/>
-                  </a:ext>
-                </a:extLst>
               </a:tr>
-              <a:tr h="718457">
+              <a:tr h="420000">
                 <a:tc>
                   <a:txBody>
                     <a:bodyPr/>
                     <a:lstStyle/>
                     <a:p>
-                      <a:pPr algn="ctr" fontAlgn="b">
+                      <a:pPr marL="0" algn="ctr" defTabSz="457200" rtl="0" eaLnBrk="1" fontAlgn="b" latinLnBrk="0" hangingPunct="1">
                         <a:buNone/>
                       </a:pPr>
                       <a:r>
-                        <a:rPr lang="es-MX" sz="1100" b="0" i="0" u="none" strike="noStrike">
+                        <a:rPr lang="es-MX" sz="1000" u="none" strike="noStrike" kern="1200">
                           <a:solidFill>
                             <a:schemeClr val="tx1"/>
                           </a:solidFill>
@@ -10411,36 +10206,24 @@
                         <a:schemeClr val="tx1"/>
                       </a:solidFill>
                       <a:prstDash val="solid"/>
-                      <a:round/>
-                      <a:headEnd type="none" w="med" len="med"/>
-                      <a:tailEnd type="none" w="med" len="med"/>
                     </a:lnL>
                     <a:lnR w="12700" cap="flat" cmpd="sng" algn="ctr">
                       <a:solidFill>
                         <a:schemeClr val="tx1"/>
                       </a:solidFill>
                       <a:prstDash val="solid"/>
-                      <a:round/>
-                      <a:headEnd type="none" w="med" len="med"/>
-                      <a:tailEnd type="none" w="med" len="med"/>
                     </a:lnR>
                     <a:lnT w="12700" cap="flat" cmpd="sng" algn="ctr">
                       <a:solidFill>
                         <a:schemeClr val="tx1"/>
                       </a:solidFill>
                       <a:prstDash val="solid"/>
-                      <a:round/>
-                      <a:headEnd type="none" w="med" len="med"/>
-                      <a:tailEnd type="none" w="med" len="med"/>
                     </a:lnT>
                     <a:lnB w="12700" cap="flat" cmpd="sng" algn="ctr">
                       <a:solidFill>
                         <a:schemeClr val="tx1"/>
                       </a:solidFill>
                       <a:prstDash val="solid"/>
-                      <a:round/>
-                      <a:headEnd type="none" w="med" len="med"/>
-                      <a:tailEnd type="none" w="med" len="med"/>
                     </a:lnB>
                     <a:noFill/>
                   </a:tcPr>
@@ -10450,26 +10233,19 @@
                     <a:bodyPr/>
                     <a:lstStyle/>
                     <a:p>
-                      <a:pPr lvl="0" algn="l">
+                      <a:pPr marL="0" algn="l" defTabSz="457200" rtl="0" eaLnBrk="1" fontAlgn="b" latinLnBrk="0" hangingPunct="1">
                         <a:buNone/>
                       </a:pPr>
                       <a:r>
-                        <a:rPr lang="es-MX" sz="1100" u="none" strike="noStrike">
+                        <a:rPr lang="es-MX" sz="1000" u="none" strike="noStrike" kern="1200">
                           <a:solidFill>
                             <a:schemeClr val="tx1"/>
                           </a:solidFill>
                           <a:effectLst/>
                           <a:latin typeface="Aptos (cuerpo)"/>
                         </a:rPr>
-                        <a:t>TRIM || MarketPlace || Caddi</a:t>
-                      </a:r>
-                      <a:endParaRPr lang="es-MX" sz="1100" b="0" i="0" u="none" strike="noStrike">
-                        <a:solidFill>
-                          <a:schemeClr val="tx1"/>
-                        </a:solidFill>
-                        <a:effectLst/>
-                        <a:latin typeface="Aptos (cuerpo)"/>
-                      </a:endParaRPr>
+                        <a:t>Operaciones Fleet || Nueva Instancia</a:t>
+                      </a:r>
                     </a:p>
                   </a:txBody>
                   <a:tcPr marL="6244" marR="6244" marT="6244" marB="0" anchor="ctr">
@@ -10478,36 +10254,24 @@
                         <a:schemeClr val="tx1"/>
                       </a:solidFill>
                       <a:prstDash val="solid"/>
-                      <a:round/>
-                      <a:headEnd type="none" w="med" len="med"/>
-                      <a:tailEnd type="none" w="med" len="med"/>
                     </a:lnL>
                     <a:lnR w="12700" cap="flat" cmpd="sng" algn="ctr">
                       <a:solidFill>
                         <a:schemeClr val="tx1"/>
                       </a:solidFill>
                       <a:prstDash val="solid"/>
-                      <a:round/>
-                      <a:headEnd type="none" w="med" len="med"/>
-                      <a:tailEnd type="none" w="med" len="med"/>
                     </a:lnR>
                     <a:lnT w="12700" cap="flat" cmpd="sng" algn="ctr">
                       <a:solidFill>
                         <a:schemeClr val="tx1"/>
                       </a:solidFill>
                       <a:prstDash val="solid"/>
-                      <a:round/>
-                      <a:headEnd type="none" w="med" len="med"/>
-                      <a:tailEnd type="none" w="med" len="med"/>
                     </a:lnT>
                     <a:lnB w="12700" cap="flat" cmpd="sng" algn="ctr">
                       <a:solidFill>
                         <a:schemeClr val="tx1"/>
                       </a:solidFill>
                       <a:prstDash val="solid"/>
-                      <a:round/>
-                      <a:headEnd type="none" w="med" len="med"/>
-                      <a:tailEnd type="none" w="med" len="med"/>
                     </a:lnB>
                     <a:noFill/>
                   </a:tcPr>
@@ -10517,85 +10281,19 @@
                     <a:bodyPr/>
                     <a:lstStyle/>
                     <a:p>
-                      <a:pPr marL="0" lvl="0" indent="0" algn="l">
-                        <a:lnSpc>
-                          <a:spcPct val="100000"/>
-                        </a:lnSpc>
-                        <a:spcBef>
-                          <a:spcPts val="0"/>
-                        </a:spcBef>
-                        <a:spcAft>
-                          <a:spcPts val="0"/>
-                        </a:spcAft>
+                      <a:pPr marL="0" algn="l" defTabSz="457200" rtl="0" eaLnBrk="1" fontAlgn="b" latinLnBrk="0" hangingPunct="1">
                         <a:buNone/>
                       </a:pPr>
                       <a:r>
-                        <a:rPr lang="es-MX" sz="800" b="0" i="0" u="none" strike="noStrike" noProof="0">
-                          <a:solidFill>
-                            <a:schemeClr val="tx1"/>
-                          </a:solidFill>
-                          <a:effectLst/>
-                          <a:latin typeface="Segoe UI"/>
-                          <a:cs typeface="Segoe UI"/>
-                        </a:rPr>
-                        <a:t>E</a:t>
-                      </a:r>
-                      <a:r>
-                        <a:rPr lang="es-MX" sz="1100" u="none" strike="noStrike" kern="1200" noProof="0">
+                        <a:rPr lang="es-MX" sz="1000" u="none" strike="noStrike" kern="1200">
                           <a:solidFill>
                             <a:schemeClr val="tx1"/>
                           </a:solidFill>
                           <a:effectLst/>
                           <a:latin typeface="Aptos (cuerpo)"/>
-                          <a:ea typeface="+mn-ea"/>
-                          <a:cs typeface="+mn-cs"/>
-                        </a:rPr>
-                        <a:t>xistió un retraso en la carga del código AMI en Intelimotor.</a:t>
-                      </a:r>
-                      <a:endParaRPr lang="es-ES" sz="1100" u="none" strike="noStrike" kern="1200" noProof="0">
-                        <a:solidFill>
-                          <a:schemeClr val="tx1"/>
-                        </a:solidFill>
-                        <a:effectLst/>
-                        <a:latin typeface="Aptos (cuerpo)"/>
-                        <a:ea typeface="+mn-ea"/>
-                        <a:cs typeface="+mn-cs"/>
-                      </a:endParaRPr>
-                    </a:p>
-                    <a:p>
-                      <a:pPr marL="0" lvl="0" indent="0" algn="l">
-                        <a:lnSpc>
-                          <a:spcPct val="100000"/>
-                        </a:lnSpc>
-                        <a:spcBef>
-                          <a:spcPts val="0"/>
-                        </a:spcBef>
-                        <a:spcAft>
-                          <a:spcPts val="0"/>
-                        </a:spcAft>
-                        <a:buNone/>
-                      </a:pPr>
-                      <a:r>
-                        <a:rPr lang="es-MX" sz="1100" u="none" strike="noStrike" kern="1200" noProof="0">
-                          <a:solidFill>
-                            <a:schemeClr val="tx1"/>
-                          </a:solidFill>
-                          <a:effectLst/>
-                          <a:latin typeface="Aptos (cuerpo)"/>
-                          <a:ea typeface="+mn-ea"/>
-                          <a:cs typeface="+mn-cs"/>
-                        </a:rPr>
-                        <a:t>Seguros Ana tardó en realizar la validación de los XML de prueba.</a:t>
-                      </a:r>
-                      <a:endParaRPr lang="es-MX" sz="1100" u="none" strike="noStrike" kern="1200">
-                        <a:solidFill>
-                          <a:schemeClr val="tx1"/>
-                        </a:solidFill>
-                        <a:effectLst/>
-                        <a:latin typeface="Aptos (cuerpo)"/>
-                        <a:ea typeface="+mn-ea"/>
-                        <a:cs typeface="+mn-cs"/>
-                      </a:endParaRPr>
+                        </a:rPr>
+                        <a:t>ggdgsefreheh</a:t>
+                      </a:r>
                     </a:p>
                   </a:txBody>
                   <a:tcPr marL="6244" marR="6244" marT="6244" marB="0" anchor="ctr">
@@ -10604,57 +10302,40 @@
                         <a:schemeClr val="tx1"/>
                       </a:solidFill>
                       <a:prstDash val="solid"/>
-                      <a:round/>
-                      <a:headEnd type="none" w="med" len="med"/>
-                      <a:tailEnd type="none" w="med" len="med"/>
                     </a:lnL>
                     <a:lnR w="12700" cap="flat" cmpd="sng" algn="ctr">
                       <a:solidFill>
                         <a:schemeClr val="tx1"/>
                       </a:solidFill>
                       <a:prstDash val="solid"/>
-                      <a:round/>
-                      <a:headEnd type="none" w="med" len="med"/>
-                      <a:tailEnd type="none" w="med" len="med"/>
                     </a:lnR>
                     <a:lnT w="12700" cap="flat" cmpd="sng" algn="ctr">
                       <a:solidFill>
                         <a:schemeClr val="tx1"/>
                       </a:solidFill>
                       <a:prstDash val="solid"/>
-                      <a:round/>
-                      <a:headEnd type="none" w="med" len="med"/>
-                      <a:tailEnd type="none" w="med" len="med"/>
                     </a:lnT>
                     <a:lnB w="12700" cap="flat" cmpd="sng" algn="ctr">
                       <a:solidFill>
                         <a:schemeClr val="tx1"/>
                       </a:solidFill>
                       <a:prstDash val="solid"/>
-                      <a:round/>
-                      <a:headEnd type="none" w="med" len="med"/>
-                      <a:tailEnd type="none" w="med" len="med"/>
                     </a:lnB>
                     <a:noFill/>
                   </a:tcPr>
                 </a:tc>
-                <a:extLst>
-                  <a:ext uri="{0D108BD9-81ED-4DB2-BD59-A6C34878D82A}">
-                    <a16:rowId xmlns:a16="http://schemas.microsoft.com/office/drawing/2014/main" val="2986911556"/>
-                  </a:ext>
-                </a:extLst>
               </a:tr>
-              <a:tr h="594360">
+              <a:tr h="420000">
                 <a:tc>
                   <a:txBody>
                     <a:bodyPr/>
                     <a:lstStyle/>
                     <a:p>
-                      <a:pPr algn="ctr" fontAlgn="b">
+                      <a:pPr marL="0" algn="ctr" defTabSz="457200" rtl="0" eaLnBrk="1" fontAlgn="b" latinLnBrk="0" hangingPunct="1">
                         <a:buNone/>
                       </a:pPr>
                       <a:r>
-                        <a:rPr lang="es-ES" sz="1100" b="0" i="0" u="none" strike="noStrike">
+                        <a:rPr lang="es-MX" sz="1000" u="none" strike="noStrike" kern="1200">
                           <a:solidFill>
                             <a:schemeClr val="tx1"/>
                           </a:solidFill>
@@ -10663,13 +10344,6 @@
                         </a:rPr>
                         <a:t>4</a:t>
                       </a:r>
-                      <a:endParaRPr lang="es-MX" sz="1100" b="0" i="0" u="none" strike="noStrike">
-                        <a:solidFill>
-                          <a:schemeClr val="tx1"/>
-                        </a:solidFill>
-                        <a:effectLst/>
-                        <a:latin typeface="Aptos (cuerpo)"/>
-                      </a:endParaRPr>
                     </a:p>
                   </a:txBody>
                   <a:tcPr marL="6244" marR="6244" marT="6244" marB="0" anchor="ctr">
@@ -10678,36 +10352,24 @@
                         <a:schemeClr val="tx1"/>
                       </a:solidFill>
                       <a:prstDash val="solid"/>
-                      <a:round/>
-                      <a:headEnd type="none" w="med" len="med"/>
-                      <a:tailEnd type="none" w="med" len="med"/>
                     </a:lnL>
                     <a:lnR w="12700" cap="flat" cmpd="sng" algn="ctr">
                       <a:solidFill>
                         <a:schemeClr val="tx1"/>
                       </a:solidFill>
                       <a:prstDash val="solid"/>
-                      <a:round/>
-                      <a:headEnd type="none" w="med" len="med"/>
-                      <a:tailEnd type="none" w="med" len="med"/>
                     </a:lnR>
                     <a:lnT w="12700" cap="flat" cmpd="sng" algn="ctr">
                       <a:solidFill>
                         <a:schemeClr val="tx1"/>
                       </a:solidFill>
                       <a:prstDash val="solid"/>
-                      <a:round/>
-                      <a:headEnd type="none" w="med" len="med"/>
-                      <a:tailEnd type="none" w="med" len="med"/>
                     </a:lnT>
                     <a:lnB w="12700" cap="flat" cmpd="sng" algn="ctr">
                       <a:solidFill>
                         <a:schemeClr val="tx1"/>
                       </a:solidFill>
                       <a:prstDash val="solid"/>
-                      <a:round/>
-                      <a:headEnd type="none" w="med" len="med"/>
-                      <a:tailEnd type="none" w="med" len="med"/>
                     </a:lnB>
                     <a:noFill/>
                   </a:tcPr>
@@ -10717,18 +10379,18 @@
                     <a:bodyPr/>
                     <a:lstStyle/>
                     <a:p>
-                      <a:pPr algn="l" fontAlgn="b">
+                      <a:pPr marL="0" algn="l" defTabSz="457200" rtl="0" eaLnBrk="1" fontAlgn="b" latinLnBrk="0" hangingPunct="1">
                         <a:buNone/>
                       </a:pPr>
                       <a:r>
-                        <a:rPr lang="es-MX" sz="1100" b="0" i="0" u="none" strike="noStrike">
+                        <a:rPr lang="es-MX" sz="1000" u="none" strike="noStrike" kern="1200">
                           <a:solidFill>
                             <a:schemeClr val="tx1"/>
                           </a:solidFill>
                           <a:effectLst/>
                           <a:latin typeface="Aptos (cuerpo)"/>
                         </a:rPr>
-                        <a:t>Operaciones Fleet || Desarrollos</a:t>
+                        <a:t>Migración oficinas Tlalnepantla</a:t>
                       </a:r>
                     </a:p>
                   </a:txBody>
@@ -10738,36 +10400,24 @@
                         <a:schemeClr val="tx1"/>
                       </a:solidFill>
                       <a:prstDash val="solid"/>
-                      <a:round/>
-                      <a:headEnd type="none" w="med" len="med"/>
-                      <a:tailEnd type="none" w="med" len="med"/>
                     </a:lnL>
                     <a:lnR w="12700" cap="flat" cmpd="sng" algn="ctr">
                       <a:solidFill>
                         <a:schemeClr val="tx1"/>
                       </a:solidFill>
                       <a:prstDash val="solid"/>
-                      <a:round/>
-                      <a:headEnd type="none" w="med" len="med"/>
-                      <a:tailEnd type="none" w="med" len="med"/>
                     </a:lnR>
                     <a:lnT w="12700" cap="flat" cmpd="sng" algn="ctr">
                       <a:solidFill>
                         <a:schemeClr val="tx1"/>
                       </a:solidFill>
                       <a:prstDash val="solid"/>
-                      <a:round/>
-                      <a:headEnd type="none" w="med" len="med"/>
-                      <a:tailEnd type="none" w="med" len="med"/>
                     </a:lnT>
                     <a:lnB w="12700" cap="flat" cmpd="sng" algn="ctr">
                       <a:solidFill>
                         <a:schemeClr val="tx1"/>
                       </a:solidFill>
                       <a:prstDash val="solid"/>
-                      <a:round/>
-                      <a:headEnd type="none" w="med" len="med"/>
-                      <a:tailEnd type="none" w="med" len="med"/>
                     </a:lnB>
                     <a:noFill/>
                   </a:tcPr>
@@ -10777,27 +10427,19 @@
                     <a:bodyPr/>
                     <a:lstStyle/>
                     <a:p>
-                      <a:pPr marL="0" indent="0" algn="l" fontAlgn="b">
-                        <a:buFont typeface="Arial" panose="020B0604020202020204" pitchFamily="34" charset="0"/>
+                      <a:pPr marL="0" algn="l" defTabSz="457200" rtl="0" eaLnBrk="1" fontAlgn="b" latinLnBrk="0" hangingPunct="1">
                         <a:buNone/>
                       </a:pPr>
                       <a:r>
-                        <a:rPr lang="es-ES" sz="1100" b="0" i="0" u="none" strike="noStrike">
+                        <a:rPr lang="es-MX" sz="1000" u="none" strike="noStrike" kern="1200">
                           <a:solidFill>
                             <a:schemeClr val="tx1"/>
                           </a:solidFill>
                           <a:effectLst/>
                           <a:latin typeface="Aptos (cuerpo)"/>
                         </a:rPr>
-                        <a:t>Por cargas de trabajo el usuario no ha podido concluir con las pruebas de certificación de Roles y Permisos</a:t>
-                      </a:r>
-                      <a:endParaRPr lang="es-MX" sz="1100" b="0" i="0" u="none" strike="noStrike">
-                        <a:solidFill>
-                          <a:schemeClr val="tx1"/>
-                        </a:solidFill>
-                        <a:effectLst/>
-                        <a:latin typeface="Aptos (cuerpo)"/>
-                      </a:endParaRPr>
+                        <a:t>documetacnion</a:t>
+                      </a:r>
                     </a:p>
                   </a:txBody>
                   <a:tcPr marL="6244" marR="6244" marT="6244" marB="0" anchor="ctr">
@@ -10806,233 +10448,28 @@
                         <a:schemeClr val="tx1"/>
                       </a:solidFill>
                       <a:prstDash val="solid"/>
-                      <a:round/>
-                      <a:headEnd type="none" w="med" len="med"/>
-                      <a:tailEnd type="none" w="med" len="med"/>
                     </a:lnL>
                     <a:lnR w="12700" cap="flat" cmpd="sng" algn="ctr">
                       <a:solidFill>
                         <a:schemeClr val="tx1"/>
                       </a:solidFill>
                       <a:prstDash val="solid"/>
-                      <a:round/>
-                      <a:headEnd type="none" w="med" len="med"/>
-                      <a:tailEnd type="none" w="med" len="med"/>
                     </a:lnR>
                     <a:lnT w="12700" cap="flat" cmpd="sng" algn="ctr">
                       <a:solidFill>
                         <a:schemeClr val="tx1"/>
                       </a:solidFill>
                       <a:prstDash val="solid"/>
-                      <a:round/>
-                      <a:headEnd type="none" w="med" len="med"/>
-                      <a:tailEnd type="none" w="med" len="med"/>
                     </a:lnT>
                     <a:lnB w="12700" cap="flat" cmpd="sng" algn="ctr">
                       <a:solidFill>
                         <a:schemeClr val="tx1"/>
                       </a:solidFill>
                       <a:prstDash val="solid"/>
-                      <a:round/>
-                      <a:headEnd type="none" w="med" len="med"/>
-                      <a:tailEnd type="none" w="med" len="med"/>
                     </a:lnB>
                     <a:noFill/>
                   </a:tcPr>
                 </a:tc>
-                <a:extLst>
-                  <a:ext uri="{0D108BD9-81ED-4DB2-BD59-A6C34878D82A}">
-                    <a16:rowId xmlns:a16="http://schemas.microsoft.com/office/drawing/2014/main" val="1272086280"/>
-                  </a:ext>
-                </a:extLst>
-              </a:tr>
-              <a:tr h="594360">
-                <a:tc>
-                  <a:txBody>
-                    <a:bodyPr/>
-                    <a:lstStyle/>
-                    <a:p>
-                      <a:pPr algn="ctr" fontAlgn="b">
-                        <a:buNone/>
-                      </a:pPr>
-                      <a:r>
-                        <a:rPr lang="es-MX" sz="1100" b="0" i="0" u="none" strike="noStrike">
-                          <a:solidFill>
-                            <a:schemeClr val="tx1"/>
-                          </a:solidFill>
-                          <a:effectLst/>
-                          <a:latin typeface="Aptos (cuerpo)"/>
-                        </a:rPr>
-                        <a:t>5</a:t>
-                      </a:r>
-                    </a:p>
-                  </a:txBody>
-                  <a:tcPr marL="6244" marR="6244" marT="6244" marB="0" anchor="ctr">
-                    <a:lnL w="12700" cap="flat" cmpd="sng" algn="ctr">
-                      <a:solidFill>
-                        <a:schemeClr val="tx1"/>
-                      </a:solidFill>
-                      <a:prstDash val="solid"/>
-                      <a:round/>
-                      <a:headEnd type="none" w="med" len="med"/>
-                      <a:tailEnd type="none" w="med" len="med"/>
-                    </a:lnL>
-                    <a:lnR w="12700" cap="flat" cmpd="sng" algn="ctr">
-                      <a:solidFill>
-                        <a:schemeClr val="tx1"/>
-                      </a:solidFill>
-                      <a:prstDash val="solid"/>
-                      <a:round/>
-                      <a:headEnd type="none" w="med" len="med"/>
-                      <a:tailEnd type="none" w="med" len="med"/>
-                    </a:lnR>
-                    <a:lnT w="12700" cap="flat" cmpd="sng" algn="ctr">
-                      <a:solidFill>
-                        <a:schemeClr val="tx1"/>
-                      </a:solidFill>
-                      <a:prstDash val="solid"/>
-                      <a:round/>
-                      <a:headEnd type="none" w="med" len="med"/>
-                      <a:tailEnd type="none" w="med" len="med"/>
-                    </a:lnT>
-                    <a:lnB w="12700" cap="flat" cmpd="sng" algn="ctr">
-                      <a:solidFill>
-                        <a:schemeClr val="tx1"/>
-                      </a:solidFill>
-                      <a:prstDash val="solid"/>
-                      <a:round/>
-                      <a:headEnd type="none" w="med" len="med"/>
-                      <a:tailEnd type="none" w="med" len="med"/>
-                    </a:lnB>
-                    <a:noFill/>
-                  </a:tcPr>
-                </a:tc>
-                <a:tc>
-                  <a:txBody>
-                    <a:bodyPr/>
-                    <a:lstStyle/>
-                    <a:p>
-                      <a:pPr algn="l" fontAlgn="b">
-                        <a:buNone/>
-                      </a:pPr>
-                      <a:r>
-                        <a:rPr lang="es-MX" sz="1100" b="0" i="0" u="none" strike="noStrike">
-                          <a:solidFill>
-                            <a:schemeClr val="tx1"/>
-                          </a:solidFill>
-                          <a:effectLst/>
-                          <a:latin typeface="Aptos (cuerpo)"/>
-                        </a:rPr>
-                        <a:t>Tesorería || Adcontent H2H</a:t>
-                      </a:r>
-                    </a:p>
-                  </a:txBody>
-                  <a:tcPr marL="6244" marR="6244" marT="6244" marB="0" anchor="ctr">
-                    <a:lnL w="12700" cap="flat" cmpd="sng" algn="ctr">
-                      <a:solidFill>
-                        <a:schemeClr val="tx1"/>
-                      </a:solidFill>
-                      <a:prstDash val="solid"/>
-                      <a:round/>
-                      <a:headEnd type="none" w="med" len="med"/>
-                      <a:tailEnd type="none" w="med" len="med"/>
-                    </a:lnL>
-                    <a:lnR w="12700" cap="flat" cmpd="sng" algn="ctr">
-                      <a:solidFill>
-                        <a:schemeClr val="tx1"/>
-                      </a:solidFill>
-                      <a:prstDash val="solid"/>
-                      <a:round/>
-                      <a:headEnd type="none" w="med" len="med"/>
-                      <a:tailEnd type="none" w="med" len="med"/>
-                    </a:lnR>
-                    <a:lnT w="12700" cap="flat" cmpd="sng" algn="ctr">
-                      <a:solidFill>
-                        <a:schemeClr val="tx1"/>
-                      </a:solidFill>
-                      <a:prstDash val="solid"/>
-                      <a:round/>
-                      <a:headEnd type="none" w="med" len="med"/>
-                      <a:tailEnd type="none" w="med" len="med"/>
-                    </a:lnT>
-                    <a:lnB w="12700" cap="flat" cmpd="sng" algn="ctr">
-                      <a:solidFill>
-                        <a:schemeClr val="tx1"/>
-                      </a:solidFill>
-                      <a:prstDash val="solid"/>
-                      <a:round/>
-                      <a:headEnd type="none" w="med" len="med"/>
-                      <a:tailEnd type="none" w="med" len="med"/>
-                    </a:lnB>
-                    <a:noFill/>
-                  </a:tcPr>
-                </a:tc>
-                <a:tc>
-                  <a:txBody>
-                    <a:bodyPr/>
-                    <a:lstStyle/>
-                    <a:p>
-                      <a:pPr marL="0" indent="0" algn="l" fontAlgn="b">
-                        <a:buFont typeface="Arial" panose="020B0604020202020204" pitchFamily="34" charset="0"/>
-                        <a:buNone/>
-                      </a:pPr>
-                      <a:r>
-                        <a:rPr lang="es-MX" sz="1100" b="0" i="0" u="none" strike="noStrike" dirty="0">
-                          <a:solidFill>
-                            <a:schemeClr val="tx1"/>
-                          </a:solidFill>
-                          <a:effectLst/>
-                          <a:latin typeface="Aptos (cuerpo)"/>
-                        </a:rPr>
-                        <a:t>Pendiente Autorización de Dirección de Finanzas</a:t>
-                      </a:r>
-                    </a:p>
-                  </a:txBody>
-                  <a:tcPr marL="6244" marR="6244" marT="6244" marB="0" anchor="ctr">
-                    <a:lnL w="12700" cap="flat" cmpd="sng" algn="ctr">
-                      <a:solidFill>
-                        <a:schemeClr val="tx1"/>
-                      </a:solidFill>
-                      <a:prstDash val="solid"/>
-                      <a:round/>
-                      <a:headEnd type="none" w="med" len="med"/>
-                      <a:tailEnd type="none" w="med" len="med"/>
-                    </a:lnL>
-                    <a:lnR w="12700" cap="flat" cmpd="sng" algn="ctr">
-                      <a:solidFill>
-                        <a:schemeClr val="tx1"/>
-                      </a:solidFill>
-                      <a:prstDash val="solid"/>
-                      <a:round/>
-                      <a:headEnd type="none" w="med" len="med"/>
-                      <a:tailEnd type="none" w="med" len="med"/>
-                    </a:lnR>
-                    <a:lnT w="12700" cap="flat" cmpd="sng" algn="ctr">
-                      <a:solidFill>
-                        <a:schemeClr val="tx1"/>
-                      </a:solidFill>
-                      <a:prstDash val="solid"/>
-                      <a:round/>
-                      <a:headEnd type="none" w="med" len="med"/>
-                      <a:tailEnd type="none" w="med" len="med"/>
-                    </a:lnT>
-                    <a:lnB w="12700" cap="flat" cmpd="sng" algn="ctr">
-                      <a:solidFill>
-                        <a:schemeClr val="tx1"/>
-                      </a:solidFill>
-                      <a:prstDash val="solid"/>
-                      <a:round/>
-                      <a:headEnd type="none" w="med" len="med"/>
-                      <a:tailEnd type="none" w="med" len="med"/>
-                    </a:lnB>
-                    <a:noFill/>
-                  </a:tcPr>
-                </a:tc>
-                <a:extLst>
-                  <a:ext uri="{0D108BD9-81ED-4DB2-BD59-A6C34878D82A}">
-                    <a16:rowId xmlns:a16="http://schemas.microsoft.com/office/drawing/2014/main" val="2497780819"/>
-                  </a:ext>
-                </a:extLst>
               </a:tr>
             </a:tbl>
           </a:graphicData>

</xml_diff>

<commit_message>
cierre_base: eliminar placeholder Titulo del slide 2
</commit_message>
<xml_diff>
--- a/cierre_base.pptx
+++ b/cierre_base.pptx
@@ -5394,31 +5394,6 @@
           <a:chExt cx="0" cy="0"/>
         </a:xfrm>
       </p:grpSpPr>
-      <p:sp>
-        <p:nvSpPr>
-          <p:cNvPr id="2" name="Título 1">
-            <a:extLst>
-              <a:ext uri="{FF2B5EF4-FFF2-40B4-BE49-F238E27FC236}">
-                <a16:creationId xmlns:a16="http://schemas.microsoft.com/office/drawing/2014/main" id="{8C5096DD-8213-E4D6-FEA5-3E1E3E00F286}"/>
-              </a:ext>
-            </a:extLst>
-          </p:cNvPr>
-          <p:cNvSpPr>
-            <a:spLocks noGrp="1"/>
-          </p:cNvSpPr>
-          <p:nvPr>
-            <p:ph type="ctrTitle"/>
-          </p:nvPr>
-        </p:nvSpPr>
-        <p:spPr/>
-        <p:txBody>
-          <a:bodyPr/>
-          <a:lstStyle/>
-          <a:p>
-            <a:endParaRPr lang="es-MX"/>
-          </a:p>
-        </p:txBody>
-      </p:sp>
       <p:sp>
         <p:nvSpPr>
           <p:cNvPr id="3" name="Rectangle 2"/>

</xml_diff>

<commit_message>
cierre_base: fecha derecha slide1 + contenido bajo slide2 para mostrar logo
</commit_message>
<xml_diff>
--- a/cierre_base.pptx
+++ b/cierre_base.pptx
@@ -5331,8 +5331,8 @@
         </p:nvSpPr>
         <p:spPr>
           <a:xfrm>
-            <a:off x="1554480" y="4607642"/>
-            <a:ext cx="6858000" cy="282834"/>
+            <a:off x="0" y="4607642"/>
+            <a:ext cx="8686800" cy="282834"/>
           </a:xfrm>
           <a:prstGeom prst="rect">
             <a:avLst/>
@@ -5345,7 +5345,7 @@
           </a:bodyPr>
           <a:lstStyle/>
           <a:p>
-            <a:pPr algn="ctr"/>
+            <a:pPr algn="r"/>
             <a:r>
               <a:rPr lang="es-MX" sz="1388" b="1" dirty="0">
                 <a:solidFill>
@@ -5402,7 +5402,7 @@
         </p:nvSpPr>
         <p:spPr>
           <a:xfrm>
-            <a:off x="73152" y="566928"/>
+            <a:off x="73152" y="932688"/>
             <a:ext cx="1229868" cy="566928"/>
           </a:xfrm>
           <a:prstGeom prst="rect">
@@ -5447,7 +5447,7 @@
         </p:nvSpPr>
         <p:spPr>
           <a:xfrm>
-            <a:off x="73152" y="594360"/>
+            <a:off x="73152" y="960120"/>
             <a:ext cx="1229868" cy="292608"/>
           </a:xfrm>
           <a:prstGeom prst="rect">
@@ -5482,7 +5482,7 @@
         </p:nvSpPr>
         <p:spPr>
           <a:xfrm>
-            <a:off x="73152" y="905256"/>
+            <a:off x="73152" y="1271016"/>
             <a:ext cx="1229868" cy="219456"/>
           </a:xfrm>
           <a:prstGeom prst="rect">
@@ -5517,7 +5517,7 @@
         </p:nvSpPr>
         <p:spPr>
           <a:xfrm>
-            <a:off x="1353312" y="566928"/>
+            <a:off x="1353312" y="932688"/>
             <a:ext cx="1229868" cy="566928"/>
           </a:xfrm>
           <a:prstGeom prst="rect">
@@ -5562,7 +5562,7 @@
         </p:nvSpPr>
         <p:spPr>
           <a:xfrm>
-            <a:off x="1353312" y="594360"/>
+            <a:off x="1353312" y="960120"/>
             <a:ext cx="1229868" cy="292608"/>
           </a:xfrm>
           <a:prstGeom prst="rect">
@@ -5597,7 +5597,7 @@
         </p:nvSpPr>
         <p:spPr>
           <a:xfrm>
-            <a:off x="1353312" y="905256"/>
+            <a:off x="1353312" y="1271016"/>
             <a:ext cx="1229868" cy="219456"/>
           </a:xfrm>
           <a:prstGeom prst="rect">
@@ -5632,7 +5632,7 @@
         </p:nvSpPr>
         <p:spPr>
           <a:xfrm>
-            <a:off x="2633472" y="566928"/>
+            <a:off x="2633472" y="932688"/>
             <a:ext cx="1229868" cy="566928"/>
           </a:xfrm>
           <a:prstGeom prst="rect">
@@ -5677,7 +5677,7 @@
         </p:nvSpPr>
         <p:spPr>
           <a:xfrm>
-            <a:off x="2633472" y="594360"/>
+            <a:off x="2633472" y="960120"/>
             <a:ext cx="1229868" cy="292608"/>
           </a:xfrm>
           <a:prstGeom prst="rect">
@@ -5712,7 +5712,7 @@
         </p:nvSpPr>
         <p:spPr>
           <a:xfrm>
-            <a:off x="2633472" y="905256"/>
+            <a:off x="2633472" y="1271016"/>
             <a:ext cx="1229868" cy="219456"/>
           </a:xfrm>
           <a:prstGeom prst="rect">
@@ -5747,7 +5747,7 @@
         </p:nvSpPr>
         <p:spPr>
           <a:xfrm>
-            <a:off x="3913631" y="566928"/>
+            <a:off x="3913631" y="932688"/>
             <a:ext cx="1229868" cy="566928"/>
           </a:xfrm>
           <a:prstGeom prst="rect">
@@ -5792,7 +5792,7 @@
         </p:nvSpPr>
         <p:spPr>
           <a:xfrm>
-            <a:off x="3913631" y="594360"/>
+            <a:off x="3913631" y="960120"/>
             <a:ext cx="1229868" cy="292608"/>
           </a:xfrm>
           <a:prstGeom prst="rect">
@@ -5827,7 +5827,7 @@
         </p:nvSpPr>
         <p:spPr>
           <a:xfrm>
-            <a:off x="3913631" y="905256"/>
+            <a:off x="3913631" y="1271016"/>
             <a:ext cx="1229868" cy="219456"/>
           </a:xfrm>
           <a:prstGeom prst="rect">
@@ -5863,7 +5863,7 @@
         </p:nvSpPr>
         <p:spPr>
           <a:xfrm>
-            <a:off x="5193792" y="566928"/>
+            <a:off x="5193792" y="932688"/>
             <a:ext cx="1229868" cy="566928"/>
           </a:xfrm>
           <a:prstGeom prst="rect">
@@ -5908,7 +5908,7 @@
         </p:nvSpPr>
         <p:spPr>
           <a:xfrm>
-            <a:off x="5193792" y="594360"/>
+            <a:off x="5193792" y="960120"/>
             <a:ext cx="1229868" cy="292608"/>
           </a:xfrm>
           <a:prstGeom prst="rect">
@@ -5943,7 +5943,7 @@
         </p:nvSpPr>
         <p:spPr>
           <a:xfrm>
-            <a:off x="5193792" y="905256"/>
+            <a:off x="5193792" y="1271016"/>
             <a:ext cx="1229868" cy="219456"/>
           </a:xfrm>
           <a:prstGeom prst="rect">
@@ -5978,7 +5978,7 @@
         </p:nvSpPr>
         <p:spPr>
           <a:xfrm>
-            <a:off x="6473952" y="566928"/>
+            <a:off x="6473952" y="932688"/>
             <a:ext cx="1229868" cy="566928"/>
           </a:xfrm>
           <a:prstGeom prst="rect">
@@ -6023,7 +6023,7 @@
         </p:nvSpPr>
         <p:spPr>
           <a:xfrm>
-            <a:off x="6473952" y="594360"/>
+            <a:off x="6473952" y="960120"/>
             <a:ext cx="1229868" cy="292608"/>
           </a:xfrm>
           <a:prstGeom prst="rect">
@@ -6058,7 +6058,7 @@
         </p:nvSpPr>
         <p:spPr>
           <a:xfrm>
-            <a:off x="6473952" y="905256"/>
+            <a:off x="6473952" y="1271016"/>
             <a:ext cx="1229868" cy="219456"/>
           </a:xfrm>
           <a:prstGeom prst="rect">
@@ -6093,7 +6093,7 @@
         </p:nvSpPr>
         <p:spPr>
           <a:xfrm>
-            <a:off x="7754111" y="566928"/>
+            <a:off x="7754111" y="932688"/>
             <a:ext cx="1229868" cy="566928"/>
           </a:xfrm>
           <a:prstGeom prst="rect">
@@ -6138,7 +6138,7 @@
         </p:nvSpPr>
         <p:spPr>
           <a:xfrm>
-            <a:off x="7754111" y="594360"/>
+            <a:off x="7754111" y="960120"/>
             <a:ext cx="1229868" cy="292608"/>
           </a:xfrm>
           <a:prstGeom prst="rect">
@@ -6173,7 +6173,7 @@
         </p:nvSpPr>
         <p:spPr>
           <a:xfrm>
-            <a:off x="7754111" y="905256"/>
+            <a:off x="7754111" y="1271016"/>
             <a:ext cx="1229868" cy="219456"/>
           </a:xfrm>
           <a:prstGeom prst="rect">
@@ -6208,7 +6208,7 @@
         </p:nvSpPr>
         <p:spPr>
           <a:xfrm>
-            <a:off x="1600200" y="36576"/>
+            <a:off x="1600200" y="402336"/>
             <a:ext cx="5943600" cy="310896"/>
           </a:xfrm>
           <a:prstGeom prst="rect">
@@ -6243,7 +6243,7 @@
         </p:nvSpPr>
         <p:spPr>
           <a:xfrm>
-            <a:off x="0" y="347472"/>
+            <a:off x="0" y="713232"/>
             <a:ext cx="9144000" cy="164592"/>
           </a:xfrm>
           <a:prstGeom prst="rect">
@@ -6279,7 +6279,7 @@
           <p:nvPr/>
         </p:nvGraphicFramePr>
         <p:xfrm>
-          <a:off x="73152" y="1188720"/>
+          <a:off x="73152" y="1554480"/>
           <a:ext cx="8741664" cy="3346704"/>
         </p:xfrm>
         <a:graphic>

</xml_diff>

<commit_message>
cierre_base: slide3 con 5 eventualidades IMC reales
</commit_message>
<xml_diff>
--- a/cierre_base.pptx
+++ b/cierre_base.pptx
@@ -10365,7 +10365,7 @@
                           <a:effectLst/>
                           <a:latin typeface="Aptos (cuerpo)"/>
                         </a:rPr>
-                        <a:t>Migración oficinas Tlalnepantla</a:t>
+                        <a:t>Capital Humano || BUK Campos Personalizados</a:t>
                       </a:r>
                     </a:p>
                   </a:txBody>
@@ -10413,7 +10413,153 @@
                           <a:effectLst/>
                           <a:latin typeface="Aptos (cuerpo)"/>
                         </a:rPr>
-                        <a:t>documetacnion</a:t>
+                        <a:t>fsdgshsdh</a:t>
+                      </a:r>
+                    </a:p>
+                  </a:txBody>
+                  <a:tcPr marL="6244" marR="6244" marT="6244" marB="0" anchor="ctr">
+                    <a:lnL w="12700" cap="flat" cmpd="sng" algn="ctr">
+                      <a:solidFill>
+                        <a:schemeClr val="tx1"/>
+                      </a:solidFill>
+                      <a:prstDash val="solid"/>
+                    </a:lnL>
+                    <a:lnR w="12700" cap="flat" cmpd="sng" algn="ctr">
+                      <a:solidFill>
+                        <a:schemeClr val="tx1"/>
+                      </a:solidFill>
+                      <a:prstDash val="solid"/>
+                    </a:lnR>
+                    <a:lnT w="12700" cap="flat" cmpd="sng" algn="ctr">
+                      <a:solidFill>
+                        <a:schemeClr val="tx1"/>
+                      </a:solidFill>
+                      <a:prstDash val="solid"/>
+                    </a:lnT>
+                    <a:lnB w="12700" cap="flat" cmpd="sng" algn="ctr">
+                      <a:solidFill>
+                        <a:schemeClr val="tx1"/>
+                      </a:solidFill>
+                      <a:prstDash val="solid"/>
+                    </a:lnB>
+                    <a:noFill/>
+                  </a:tcPr>
+                </a:tc>
+              </a:tr>
+              <a:tr h="420000">
+                <a:tc>
+                  <a:txBody>
+                    <a:bodyPr/>
+                    <a:lstStyle/>
+                    <a:p>
+                      <a:pPr marL="0" algn="ctr" defTabSz="457200" rtl="0" eaLnBrk="1" fontAlgn="b" latinLnBrk="0" hangingPunct="1">
+                        <a:buNone/>
+                      </a:pPr>
+                      <a:r>
+                        <a:rPr lang="es-MX" sz="1000" u="none" strike="noStrike" kern="1200">
+                          <a:solidFill>
+                            <a:schemeClr val="tx1"/>
+                          </a:solidFill>
+                          <a:effectLst/>
+                          <a:latin typeface="Aptos (cuerpo)"/>
+                        </a:rPr>
+                        <a:t>5</a:t>
+                      </a:r>
+                    </a:p>
+                  </a:txBody>
+                  <a:tcPr marL="6244" marR="6244" marT="6244" marB="0" anchor="ctr">
+                    <a:lnL w="12700" cap="flat" cmpd="sng" algn="ctr">
+                      <a:solidFill>
+                        <a:schemeClr val="tx1"/>
+                      </a:solidFill>
+                      <a:prstDash val="solid"/>
+                    </a:lnL>
+                    <a:lnR w="12700" cap="flat" cmpd="sng" algn="ctr">
+                      <a:solidFill>
+                        <a:schemeClr val="tx1"/>
+                      </a:solidFill>
+                      <a:prstDash val="solid"/>
+                    </a:lnR>
+                    <a:lnT w="12700" cap="flat" cmpd="sng" algn="ctr">
+                      <a:solidFill>
+                        <a:schemeClr val="tx1"/>
+                      </a:solidFill>
+                      <a:prstDash val="solid"/>
+                    </a:lnT>
+                    <a:lnB w="12700" cap="flat" cmpd="sng" algn="ctr">
+                      <a:solidFill>
+                        <a:schemeClr val="tx1"/>
+                      </a:solidFill>
+                      <a:prstDash val="solid"/>
+                    </a:lnB>
+                    <a:noFill/>
+                  </a:tcPr>
+                </a:tc>
+                <a:tc>
+                  <a:txBody>
+                    <a:bodyPr/>
+                    <a:lstStyle/>
+                    <a:p>
+                      <a:pPr marL="0" algn="l" defTabSz="457200" rtl="0" eaLnBrk="1" fontAlgn="b" latinLnBrk="0" hangingPunct="1">
+                        <a:buNone/>
+                      </a:pPr>
+                      <a:r>
+                        <a:rPr lang="es-MX" sz="1000" u="none" strike="noStrike" kern="1200">
+                          <a:solidFill>
+                            <a:schemeClr val="tx1"/>
+                          </a:solidFill>
+                          <a:effectLst/>
+                          <a:latin typeface="Aptos (cuerpo)"/>
+                        </a:rPr>
+                        <a:t>Talleres || Integración Mecanica Mx - SAE</a:t>
+                      </a:r>
+                    </a:p>
+                  </a:txBody>
+                  <a:tcPr marL="6244" marR="6244" marT="6244" marB="0" anchor="ctr">
+                    <a:lnL w="12700" cap="flat" cmpd="sng" algn="ctr">
+                      <a:solidFill>
+                        <a:schemeClr val="tx1"/>
+                      </a:solidFill>
+                      <a:prstDash val="solid"/>
+                    </a:lnL>
+                    <a:lnR w="12700" cap="flat" cmpd="sng" algn="ctr">
+                      <a:solidFill>
+                        <a:schemeClr val="tx1"/>
+                      </a:solidFill>
+                      <a:prstDash val="solid"/>
+                    </a:lnR>
+                    <a:lnT w="12700" cap="flat" cmpd="sng" algn="ctr">
+                      <a:solidFill>
+                        <a:schemeClr val="tx1"/>
+                      </a:solidFill>
+                      <a:prstDash val="solid"/>
+                    </a:lnT>
+                    <a:lnB w="12700" cap="flat" cmpd="sng" algn="ctr">
+                      <a:solidFill>
+                        <a:schemeClr val="tx1"/>
+                      </a:solidFill>
+                      <a:prstDash val="solid"/>
+                    </a:lnB>
+                    <a:noFill/>
+                  </a:tcPr>
+                </a:tc>
+                <a:tc>
+                  <a:txBody>
+                    <a:bodyPr/>
+                    <a:lstStyle/>
+                    <a:p>
+                      <a:pPr marL="0" algn="l" defTabSz="457200" rtl="0" eaLnBrk="1" fontAlgn="b" latinLnBrk="0" hangingPunct="1">
+                        <a:buNone/>
+                      </a:pPr>
+                      <a:r>
+                        <a:rPr lang="es-MX" sz="1000" u="none" strike="noStrike" kern="1200">
+                          <a:solidFill>
+                            <a:schemeClr val="tx1"/>
+                          </a:solidFill>
+                          <a:effectLst/>
+                          <a:latin typeface="Aptos (cuerpo)"/>
+                        </a:rPr>
+                        <a:t>asasfagdgdsgg</a:t>
                       </a:r>
                     </a:p>
                   </a:txBody>

</xml_diff>

<commit_message>
reporte: actualizar cierre_base.pptx (bajo demanda)
</commit_message>
<xml_diff>
--- a/cierre_base.pptx
+++ b/cierre_base.pptx
@@ -5331,8 +5331,8 @@
         </p:nvSpPr>
         <p:spPr>
           <a:xfrm>
-            <a:off x="0" y="4607642"/>
-            <a:ext cx="8686800" cy="282834"/>
+            <a:off x="1554480" y="4607642"/>
+            <a:ext cx="6858000" cy="282834"/>
           </a:xfrm>
           <a:prstGeom prst="rect">
             <a:avLst/>
@@ -5345,7 +5345,7 @@
           </a:bodyPr>
           <a:lstStyle/>
           <a:p>
-            <a:pPr algn="r"/>
+            <a:pPr algn="ctr"/>
             <a:r>
               <a:rPr lang="es-MX" sz="1388" b="1" dirty="0">
                 <a:solidFill>
@@ -5353,7 +5353,7 @@
                 </a:solidFill>
                 <a:latin typeface="Arial Nova Light"/>
               </a:rPr>
-              <a:t>Cierre semanal del 25 de Junio al 2 de Julio</a:t>
+              <a:t>Cierre semanal del 2 de Julio al 9 de Julio</a:t>
             </a:r>
             <a:endParaRPr lang="es-MX" sz="1400" b="1" dirty="0">
               <a:solidFill>
@@ -5402,7 +5402,7 @@
         </p:nvSpPr>
         <p:spPr>
           <a:xfrm>
-            <a:off x="73152" y="932688"/>
+            <a:off x="73152" y="566928"/>
             <a:ext cx="1229868" cy="566928"/>
           </a:xfrm>
           <a:prstGeom prst="rect">
@@ -5447,7 +5447,7 @@
         </p:nvSpPr>
         <p:spPr>
           <a:xfrm>
-            <a:off x="73152" y="960120"/>
+            <a:off x="73152" y="594360"/>
             <a:ext cx="1229868" cy="292608"/>
           </a:xfrm>
           <a:prstGeom prst="rect">
@@ -5469,7 +5469,7 @@
                 </a:solidFill>
                 <a:latin typeface="Calibri"/>
               </a:rPr>
-              <a:t>16</a:t>
+              <a:t>18</a:t>
             </a:r>
           </a:p>
         </p:txBody>
@@ -5482,7 +5482,7 @@
         </p:nvSpPr>
         <p:spPr>
           <a:xfrm>
-            <a:off x="73152" y="1271016"/>
+            <a:off x="73152" y="905256"/>
             <a:ext cx="1229868" cy="219456"/>
           </a:xfrm>
           <a:prstGeom prst="rect">
@@ -5517,7 +5517,7 @@
         </p:nvSpPr>
         <p:spPr>
           <a:xfrm>
-            <a:off x="1353312" y="932688"/>
+            <a:off x="1353312" y="566928"/>
             <a:ext cx="1229868" cy="566928"/>
           </a:xfrm>
           <a:prstGeom prst="rect">
@@ -5562,7 +5562,7 @@
         </p:nvSpPr>
         <p:spPr>
           <a:xfrm>
-            <a:off x="1353312" y="960120"/>
+            <a:off x="1353312" y="594360"/>
             <a:ext cx="1229868" cy="292608"/>
           </a:xfrm>
           <a:prstGeom prst="rect">
@@ -5584,7 +5584,7 @@
                 </a:solidFill>
                 <a:latin typeface="Calibri"/>
               </a:rPr>
-              <a:t>7</a:t>
+              <a:t>9</a:t>
             </a:r>
           </a:p>
         </p:txBody>
@@ -5597,7 +5597,7 @@
         </p:nvSpPr>
         <p:spPr>
           <a:xfrm>
-            <a:off x="1353312" y="1271016"/>
+            <a:off x="1353312" y="905256"/>
             <a:ext cx="1229868" cy="219456"/>
           </a:xfrm>
           <a:prstGeom prst="rect">
@@ -5632,7 +5632,7 @@
         </p:nvSpPr>
         <p:spPr>
           <a:xfrm>
-            <a:off x="2633472" y="932688"/>
+            <a:off x="2633472" y="566928"/>
             <a:ext cx="1229868" cy="566928"/>
           </a:xfrm>
           <a:prstGeom prst="rect">
@@ -5677,7 +5677,7 @@
         </p:nvSpPr>
         <p:spPr>
           <a:xfrm>
-            <a:off x="2633472" y="960120"/>
+            <a:off x="2633472" y="594360"/>
             <a:ext cx="1229868" cy="292608"/>
           </a:xfrm>
           <a:prstGeom prst="rect">
@@ -5699,7 +5699,7 @@
                 </a:solidFill>
                 <a:latin typeface="Calibri"/>
               </a:rPr>
-              <a:t>4</a:t>
+              <a:t>3</a:t>
             </a:r>
           </a:p>
         </p:txBody>
@@ -5712,7 +5712,7 @@
         </p:nvSpPr>
         <p:spPr>
           <a:xfrm>
-            <a:off x="2633472" y="1271016"/>
+            <a:off x="2633472" y="905256"/>
             <a:ext cx="1229868" cy="219456"/>
           </a:xfrm>
           <a:prstGeom prst="rect">
@@ -5747,7 +5747,7 @@
         </p:nvSpPr>
         <p:spPr>
           <a:xfrm>
-            <a:off x="3913631" y="932688"/>
+            <a:off x="3913631" y="566928"/>
             <a:ext cx="1229868" cy="566928"/>
           </a:xfrm>
           <a:prstGeom prst="rect">
@@ -5792,7 +5792,7 @@
         </p:nvSpPr>
         <p:spPr>
           <a:xfrm>
-            <a:off x="3913631" y="960120"/>
+            <a:off x="3913631" y="594360"/>
             <a:ext cx="1229868" cy="292608"/>
           </a:xfrm>
           <a:prstGeom prst="rect">
@@ -5814,7 +5814,7 @@
                 </a:solidFill>
                 <a:latin typeface="Calibri"/>
               </a:rPr>
-              <a:t>1</a:t>
+              <a:t>2</a:t>
             </a:r>
           </a:p>
         </p:txBody>
@@ -5827,7 +5827,7 @@
         </p:nvSpPr>
         <p:spPr>
           <a:xfrm>
-            <a:off x="3913631" y="1271016"/>
+            <a:off x="3913631" y="905256"/>
             <a:ext cx="1229868" cy="219456"/>
           </a:xfrm>
           <a:prstGeom prst="rect">
@@ -5863,7 +5863,7 @@
         </p:nvSpPr>
         <p:spPr>
           <a:xfrm>
-            <a:off x="5193792" y="932688"/>
+            <a:off x="5193792" y="566928"/>
             <a:ext cx="1229868" cy="566928"/>
           </a:xfrm>
           <a:prstGeom prst="rect">
@@ -5908,7 +5908,7 @@
         </p:nvSpPr>
         <p:spPr>
           <a:xfrm>
-            <a:off x="5193792" y="960120"/>
+            <a:off x="5193792" y="594360"/>
             <a:ext cx="1229868" cy="292608"/>
           </a:xfrm>
           <a:prstGeom prst="rect">
@@ -5943,7 +5943,7 @@
         </p:nvSpPr>
         <p:spPr>
           <a:xfrm>
-            <a:off x="5193792" y="1271016"/>
+            <a:off x="5193792" y="905256"/>
             <a:ext cx="1229868" cy="219456"/>
           </a:xfrm>
           <a:prstGeom prst="rect">
@@ -5978,7 +5978,7 @@
         </p:nvSpPr>
         <p:spPr>
           <a:xfrm>
-            <a:off x="6473952" y="932688"/>
+            <a:off x="6473952" y="566928"/>
             <a:ext cx="1229868" cy="566928"/>
           </a:xfrm>
           <a:prstGeom prst="rect">
@@ -6023,7 +6023,7 @@
         </p:nvSpPr>
         <p:spPr>
           <a:xfrm>
-            <a:off x="6473952" y="960120"/>
+            <a:off x="6473952" y="594360"/>
             <a:ext cx="1229868" cy="292608"/>
           </a:xfrm>
           <a:prstGeom prst="rect">
@@ -6045,7 +6045,7 @@
                 </a:solidFill>
                 <a:latin typeface="Calibri"/>
               </a:rPr>
-              <a:t>6</a:t>
+              <a:t>3</a:t>
             </a:r>
           </a:p>
         </p:txBody>
@@ -6058,7 +6058,7 @@
         </p:nvSpPr>
         <p:spPr>
           <a:xfrm>
-            <a:off x="6473952" y="1271016"/>
+            <a:off x="6473952" y="905256"/>
             <a:ext cx="1229868" cy="219456"/>
           </a:xfrm>
           <a:prstGeom prst="rect">
@@ -6093,7 +6093,7 @@
         </p:nvSpPr>
         <p:spPr>
           <a:xfrm>
-            <a:off x="7754111" y="932688"/>
+            <a:off x="7754111" y="566928"/>
             <a:ext cx="1229868" cy="566928"/>
           </a:xfrm>
           <a:prstGeom prst="rect">
@@ -6138,7 +6138,7 @@
         </p:nvSpPr>
         <p:spPr>
           <a:xfrm>
-            <a:off x="7754111" y="960120"/>
+            <a:off x="7754111" y="594360"/>
             <a:ext cx="1229868" cy="292608"/>
           </a:xfrm>
           <a:prstGeom prst="rect">
@@ -6173,7 +6173,7 @@
         </p:nvSpPr>
         <p:spPr>
           <a:xfrm>
-            <a:off x="7754111" y="1271016"/>
+            <a:off x="7754111" y="905256"/>
             <a:ext cx="1229868" cy="219456"/>
           </a:xfrm>
           <a:prstGeom prst="rect">
@@ -6208,7 +6208,7 @@
         </p:nvSpPr>
         <p:spPr>
           <a:xfrm>
-            <a:off x="1600200" y="402336"/>
+            <a:off x="1600200" y="36576"/>
             <a:ext cx="5943600" cy="310896"/>
           </a:xfrm>
           <a:prstGeom prst="rect">
@@ -6243,7 +6243,7 @@
         </p:nvSpPr>
         <p:spPr>
           <a:xfrm>
-            <a:off x="0" y="713232"/>
+            <a:off x="0" y="347472"/>
             <a:ext cx="9144000" cy="164592"/>
           </a:xfrm>
           <a:prstGeom prst="rect">
@@ -6265,7 +6265,7 @@
                 </a:solidFill>
                 <a:latin typeface="Calibri"/>
               </a:rPr>
-              <a:t>Cierre semanal del 25 de Junio al 2 de Julio</a:t>
+              <a:t>Cierre semanal del 2 de Julio al 9 de Julio</a:t>
             </a:r>
           </a:p>
         </p:txBody>
@@ -6279,8 +6279,8 @@
           <p:nvPr/>
         </p:nvGraphicFramePr>
         <p:xfrm>
-          <a:off x="73152" y="1554480"/>
-          <a:ext cx="8741664" cy="3346704"/>
+          <a:off x="73152" y="1188720"/>
+          <a:ext cx="8741664" cy="3739896"/>
         </p:xfrm>
         <a:graphic>
           <a:graphicData uri="http://schemas.openxmlformats.org/drawingml/2006/table">
@@ -6590,7 +6590,7 @@
                           </a:solidFill>
                           <a:latin typeface="Calibri"/>
                         </a:rPr>
-                        <a:t>98%</a:t>
+                        <a:t>82%</a:t>
                       </a:r>
                     </a:p>
                   </a:txBody>
@@ -6613,7 +6613,7 @@
                           </a:solidFill>
                           <a:latin typeface="Calibri"/>
                         </a:rPr>
-                        <a:t>97%</a:t>
+                        <a:t>100%</a:t>
                       </a:r>
                     </a:p>
                   </a:txBody>
@@ -6632,11 +6632,11 @@
                       <a:r>
                         <a:rPr sz="700" b="1">
                           <a:solidFill>
-                            <a:srgbClr val="22C55E"/>
-                          </a:solidFill>
-                          <a:latin typeface="Calibri"/>
-                        </a:rPr>
-                        <a:t>98%</a:t>
+                            <a:srgbClr val="EF4444"/>
+                          </a:solidFill>
+                          <a:latin typeface="Calibri"/>
+                        </a:rPr>
+                        <a:t>82%</a:t>
                       </a:r>
                     </a:p>
                   </a:txBody>
@@ -6644,12 +6644,12 @@
                     <a:gradFill>
                       <a:gsLst>
                         <a:gs pos="0">
-                          <a:srgbClr val="22C55E"/>
+                          <a:srgbClr val="EF4444"/>
                         </a:gs>
-                        <a:gs pos="98000">
-                          <a:srgbClr val="22C55E"/>
+                        <a:gs pos="82000">
+                          <a:srgbClr val="EF4444"/>
                         </a:gs>
-                        <a:gs pos="98500">
+                        <a:gs pos="82500">
                           <a:srgbClr val="E2E2E2"/>
                         </a:gs>
                         <a:gs pos="100000">
@@ -6669,11 +6669,11 @@
                       <a:r>
                         <a:rPr sz="700" b="1">
                           <a:solidFill>
-                            <a:srgbClr val="22C55E"/>
-                          </a:solidFill>
-                          <a:latin typeface="Calibri"/>
-                        </a:rPr>
-                        <a:t>A tiempo</a:t>
+                            <a:srgbClr val="EF4444"/>
+                          </a:solidFill>
+                          <a:latin typeface="Calibri"/>
+                        </a:rPr>
+                        <a:t>Atrasado</a:t>
                       </a:r>
                     </a:p>
                   </a:txBody>
@@ -7371,7 +7371,7 @@
                           </a:solidFill>
                           <a:latin typeface="Calibri"/>
                         </a:rPr>
-                        <a:t>90%</a:t>
+                        <a:t>91%</a:t>
                       </a:r>
                     </a:p>
                   </a:txBody>
@@ -7748,6 +7748,1522 @@
                           </a:solidFill>
                           <a:latin typeface="Calibri"/>
                         </a:rPr>
+                        <a:t>100%</a:t>
+                      </a:r>
+                    </a:p>
+                  </a:txBody>
+                  <a:tcPr>
+                    <a:solidFill>
+                      <a:srgbClr val="F5F7FA"/>
+                    </a:solidFill>
+                  </a:tcPr>
+                </a:tc>
+                <a:tc>
+                  <a:txBody>
+                    <a:bodyPr wrap="square"/>
+                    <a:lstStyle/>
+                    <a:p>
+                      <a:pPr algn="ctr"/>
+                      <a:r>
+                        <a:rPr sz="700" b="0">
+                          <a:solidFill>
+                            <a:srgbClr val="555555"/>
+                          </a:solidFill>
+                          <a:latin typeface="Calibri"/>
+                        </a:rPr>
+                        <a:t>100%</a:t>
+                      </a:r>
+                    </a:p>
+                  </a:txBody>
+                  <a:tcPr>
+                    <a:solidFill>
+                      <a:srgbClr val="F5F7FA"/>
+                    </a:solidFill>
+                  </a:tcPr>
+                </a:tc>
+                <a:tc>
+                  <a:txBody>
+                    <a:bodyPr wrap="square"/>
+                    <a:lstStyle/>
+                    <a:p>
+                      <a:pPr algn="r"/>
+                      <a:r>
+                        <a:rPr sz="700" b="1">
+                          <a:solidFill>
+                            <a:srgbClr val="22C55E"/>
+                          </a:solidFill>
+                          <a:latin typeface="Calibri"/>
+                        </a:rPr>
+                        <a:t>100%</a:t>
+                      </a:r>
+                    </a:p>
+                  </a:txBody>
+                  <a:tcPr>
+                    <a:solidFill>
+                      <a:srgbClr val="22C55E"/>
+                    </a:solidFill>
+                  </a:tcPr>
+                </a:tc>
+                <a:tc>
+                  <a:txBody>
+                    <a:bodyPr wrap="square"/>
+                    <a:lstStyle/>
+                    <a:p>
+                      <a:pPr algn="ctr"/>
+                      <a:r>
+                        <a:rPr sz="700" b="1">
+                          <a:solidFill>
+                            <a:srgbClr val="22C55E"/>
+                          </a:solidFill>
+                          <a:latin typeface="Calibri"/>
+                        </a:rPr>
+                        <a:t>Terminado</a:t>
+                      </a:r>
+                    </a:p>
+                  </a:txBody>
+                  <a:tcPr>
+                    <a:solidFill>
+                      <a:srgbClr val="F5F7FA"/>
+                    </a:solidFill>
+                  </a:tcPr>
+                </a:tc>
+              </a:tr>
+              <a:tr h="196596">
+                <a:tc>
+                  <a:txBody>
+                    <a:bodyPr wrap="square"/>
+                    <a:lstStyle/>
+                    <a:p>
+                      <a:pPr algn="ctr"/>
+                      <a:r>
+                        <a:rPr sz="700" b="1">
+                          <a:solidFill>
+                            <a:srgbClr val="1A2340"/>
+                          </a:solidFill>
+                          <a:latin typeface="Calibri"/>
+                        </a:rPr>
+                        <a:t>Proyecto</a:t>
+                      </a:r>
+                    </a:p>
+                  </a:txBody>
+                  <a:tcPr>
+                    <a:solidFill>
+                      <a:srgbClr val="FFFFFF"/>
+                    </a:solidFill>
+                  </a:tcPr>
+                </a:tc>
+                <a:tc>
+                  <a:txBody>
+                    <a:bodyPr wrap="square"/>
+                    <a:lstStyle/>
+                    <a:p>
+                      <a:pPr algn="l"/>
+                      <a:r>
+                        <a:rPr sz="700" b="0">
+                          <a:solidFill>
+                            <a:srgbClr val="1A2340"/>
+                          </a:solidFill>
+                          <a:latin typeface="Calibri"/>
+                        </a:rPr>
+                        <a:t>Operaciones Fleet || Lobby Fix</a:t>
+                      </a:r>
+                    </a:p>
+                  </a:txBody>
+                  <a:tcPr>
+                    <a:solidFill>
+                      <a:srgbClr val="FFFFFF"/>
+                    </a:solidFill>
+                  </a:tcPr>
+                </a:tc>
+                <a:tc>
+                  <a:txBody>
+                    <a:bodyPr wrap="square"/>
+                    <a:lstStyle/>
+                    <a:p>
+                      <a:pPr algn="ctr"/>
+                      <a:r>
+                        <a:rPr sz="700" b="0">
+                          <a:solidFill>
+                            <a:srgbClr val="555555"/>
+                          </a:solidFill>
+                          <a:latin typeface="Calibri"/>
+                        </a:rPr>
+                        <a:t>11/11/2025</a:t>
+                      </a:r>
+                    </a:p>
+                  </a:txBody>
+                  <a:tcPr>
+                    <a:solidFill>
+                      <a:srgbClr val="FFFFFF"/>
+                    </a:solidFill>
+                  </a:tcPr>
+                </a:tc>
+                <a:tc>
+                  <a:txBody>
+                    <a:bodyPr wrap="square"/>
+                    <a:lstStyle/>
+                    <a:p>
+                      <a:pPr algn="ctr"/>
+                      <a:r>
+                        <a:rPr sz="700" b="0">
+                          <a:solidFill>
+                            <a:srgbClr val="555555"/>
+                          </a:solidFill>
+                          <a:latin typeface="Calibri"/>
+                        </a:rPr>
+                        <a:t>29/06/2026</a:t>
+                      </a:r>
+                    </a:p>
+                  </a:txBody>
+                  <a:tcPr>
+                    <a:solidFill>
+                      <a:srgbClr val="FFFFFF"/>
+                    </a:solidFill>
+                  </a:tcPr>
+                </a:tc>
+                <a:tc>
+                  <a:txBody>
+                    <a:bodyPr wrap="square"/>
+                    <a:lstStyle/>
+                    <a:p>
+                      <a:pPr algn="ctr"/>
+                      <a:r>
+                        <a:rPr sz="700" b="1">
+                          <a:solidFill>
+                            <a:srgbClr val="1A2340"/>
+                          </a:solidFill>
+                          <a:latin typeface="Calibri"/>
+                        </a:rPr>
+                        <a:t>100%</a:t>
+                      </a:r>
+                    </a:p>
+                  </a:txBody>
+                  <a:tcPr>
+                    <a:solidFill>
+                      <a:srgbClr val="FFFFFF"/>
+                    </a:solidFill>
+                  </a:tcPr>
+                </a:tc>
+                <a:tc>
+                  <a:txBody>
+                    <a:bodyPr wrap="square"/>
+                    <a:lstStyle/>
+                    <a:p>
+                      <a:pPr algn="ctr"/>
+                      <a:r>
+                        <a:rPr sz="700" b="0">
+                          <a:solidFill>
+                            <a:srgbClr val="555555"/>
+                          </a:solidFill>
+                          <a:latin typeface="Calibri"/>
+                        </a:rPr>
+                        <a:t>100%</a:t>
+                      </a:r>
+                    </a:p>
+                  </a:txBody>
+                  <a:tcPr>
+                    <a:solidFill>
+                      <a:srgbClr val="FFFFFF"/>
+                    </a:solidFill>
+                  </a:tcPr>
+                </a:tc>
+                <a:tc>
+                  <a:txBody>
+                    <a:bodyPr wrap="square"/>
+                    <a:lstStyle/>
+                    <a:p>
+                      <a:pPr algn="r"/>
+                      <a:r>
+                        <a:rPr sz="700" b="1">
+                          <a:solidFill>
+                            <a:srgbClr val="22C55E"/>
+                          </a:solidFill>
+                          <a:latin typeface="Calibri"/>
+                        </a:rPr>
+                        <a:t>100%</a:t>
+                      </a:r>
+                    </a:p>
+                  </a:txBody>
+                  <a:tcPr>
+                    <a:solidFill>
+                      <a:srgbClr val="22C55E"/>
+                    </a:solidFill>
+                  </a:tcPr>
+                </a:tc>
+                <a:tc>
+                  <a:txBody>
+                    <a:bodyPr wrap="square"/>
+                    <a:lstStyle/>
+                    <a:p>
+                      <a:pPr algn="ctr"/>
+                      <a:r>
+                        <a:rPr sz="700" b="1">
+                          <a:solidFill>
+                            <a:srgbClr val="22C55E"/>
+                          </a:solidFill>
+                          <a:latin typeface="Calibri"/>
+                        </a:rPr>
+                        <a:t>Terminado</a:t>
+                      </a:r>
+                    </a:p>
+                  </a:txBody>
+                  <a:tcPr>
+                    <a:solidFill>
+                      <a:srgbClr val="FFFFFF"/>
+                    </a:solidFill>
+                  </a:tcPr>
+                </a:tc>
+              </a:tr>
+              <a:tr h="196596">
+                <a:tc>
+                  <a:txBody>
+                    <a:bodyPr wrap="square"/>
+                    <a:lstStyle/>
+                    <a:p>
+                      <a:pPr algn="ctr"/>
+                      <a:r>
+                        <a:rPr sz="700" b="1">
+                          <a:solidFill>
+                            <a:srgbClr val="1A2340"/>
+                          </a:solidFill>
+                          <a:latin typeface="Calibri"/>
+                        </a:rPr>
+                        <a:t>Proyecto</a:t>
+                      </a:r>
+                    </a:p>
+                  </a:txBody>
+                  <a:tcPr>
+                    <a:solidFill>
+                      <a:srgbClr val="F5F7FA"/>
+                    </a:solidFill>
+                  </a:tcPr>
+                </a:tc>
+                <a:tc>
+                  <a:txBody>
+                    <a:bodyPr wrap="square"/>
+                    <a:lstStyle/>
+                    <a:p>
+                      <a:pPr algn="l"/>
+                      <a:r>
+                        <a:rPr sz="700" b="0">
+                          <a:solidFill>
+                            <a:srgbClr val="1A2340"/>
+                          </a:solidFill>
+                          <a:latin typeface="Calibri"/>
+                        </a:rPr>
+                        <a:t>Operaciones Fleet || Nexcar || Desarrollos</a:t>
+                      </a:r>
+                    </a:p>
+                  </a:txBody>
+                  <a:tcPr>
+                    <a:solidFill>
+                      <a:srgbClr val="F5F7FA"/>
+                    </a:solidFill>
+                  </a:tcPr>
+                </a:tc>
+                <a:tc>
+                  <a:txBody>
+                    <a:bodyPr wrap="square"/>
+                    <a:lstStyle/>
+                    <a:p>
+                      <a:pPr algn="ctr"/>
+                      <a:r>
+                        <a:rPr sz="700" b="0">
+                          <a:solidFill>
+                            <a:srgbClr val="555555"/>
+                          </a:solidFill>
+                          <a:latin typeface="Calibri"/>
+                        </a:rPr>
+                        <a:t>05/03/2026</a:t>
+                      </a:r>
+                    </a:p>
+                  </a:txBody>
+                  <a:tcPr>
+                    <a:solidFill>
+                      <a:srgbClr val="F5F7FA"/>
+                    </a:solidFill>
+                  </a:tcPr>
+                </a:tc>
+                <a:tc>
+                  <a:txBody>
+                    <a:bodyPr wrap="square"/>
+                    <a:lstStyle/>
+                    <a:p>
+                      <a:pPr algn="ctr"/>
+                      <a:r>
+                        <a:rPr sz="700" b="0">
+                          <a:solidFill>
+                            <a:srgbClr val="555555"/>
+                          </a:solidFill>
+                          <a:latin typeface="Calibri"/>
+                        </a:rPr>
+                        <a:t>10/07/2026</a:t>
+                      </a:r>
+                    </a:p>
+                  </a:txBody>
+                  <a:tcPr>
+                    <a:solidFill>
+                      <a:srgbClr val="F5F7FA"/>
+                    </a:solidFill>
+                  </a:tcPr>
+                </a:tc>
+                <a:tc>
+                  <a:txBody>
+                    <a:bodyPr wrap="square"/>
+                    <a:lstStyle/>
+                    <a:p>
+                      <a:pPr algn="ctr"/>
+                      <a:r>
+                        <a:rPr sz="700" b="1">
+                          <a:solidFill>
+                            <a:srgbClr val="1A2340"/>
+                          </a:solidFill>
+                          <a:latin typeface="Calibri"/>
+                        </a:rPr>
+                        <a:t>100%</a:t>
+                      </a:r>
+                    </a:p>
+                  </a:txBody>
+                  <a:tcPr>
+                    <a:solidFill>
+                      <a:srgbClr val="F5F7FA"/>
+                    </a:solidFill>
+                  </a:tcPr>
+                </a:tc>
+                <a:tc>
+                  <a:txBody>
+                    <a:bodyPr wrap="square"/>
+                    <a:lstStyle/>
+                    <a:p>
+                      <a:pPr algn="ctr"/>
+                      <a:r>
+                        <a:rPr sz="700" b="0">
+                          <a:solidFill>
+                            <a:srgbClr val="555555"/>
+                          </a:solidFill>
+                          <a:latin typeface="Calibri"/>
+                        </a:rPr>
+                        <a:t>96%</a:t>
+                      </a:r>
+                    </a:p>
+                  </a:txBody>
+                  <a:tcPr>
+                    <a:solidFill>
+                      <a:srgbClr val="F5F7FA"/>
+                    </a:solidFill>
+                  </a:tcPr>
+                </a:tc>
+                <a:tc>
+                  <a:txBody>
+                    <a:bodyPr wrap="square"/>
+                    <a:lstStyle/>
+                    <a:p>
+                      <a:pPr algn="r"/>
+                      <a:r>
+                        <a:rPr sz="700" b="1">
+                          <a:solidFill>
+                            <a:srgbClr val="22C55E"/>
+                          </a:solidFill>
+                          <a:latin typeface="Calibri"/>
+                        </a:rPr>
+                        <a:t>100%</a:t>
+                      </a:r>
+                    </a:p>
+                  </a:txBody>
+                  <a:tcPr>
+                    <a:solidFill>
+                      <a:srgbClr val="22C55E"/>
+                    </a:solidFill>
+                  </a:tcPr>
+                </a:tc>
+                <a:tc>
+                  <a:txBody>
+                    <a:bodyPr wrap="square"/>
+                    <a:lstStyle/>
+                    <a:p>
+                      <a:pPr algn="ctr"/>
+                      <a:r>
+                        <a:rPr sz="700" b="1">
+                          <a:solidFill>
+                            <a:srgbClr val="22C55E"/>
+                          </a:solidFill>
+                          <a:latin typeface="Calibri"/>
+                        </a:rPr>
+                        <a:t>Terminado</a:t>
+                      </a:r>
+                    </a:p>
+                  </a:txBody>
+                  <a:tcPr>
+                    <a:solidFill>
+                      <a:srgbClr val="F5F7FA"/>
+                    </a:solidFill>
+                  </a:tcPr>
+                </a:tc>
+              </a:tr>
+              <a:tr h="196596">
+                <a:tc>
+                  <a:txBody>
+                    <a:bodyPr wrap="square"/>
+                    <a:lstStyle/>
+                    <a:p>
+                      <a:pPr algn="ctr"/>
+                      <a:r>
+                        <a:rPr sz="700" b="1">
+                          <a:solidFill>
+                            <a:srgbClr val="1A2340"/>
+                          </a:solidFill>
+                          <a:latin typeface="Calibri"/>
+                        </a:rPr>
+                        <a:t>Proyecto</a:t>
+                      </a:r>
+                    </a:p>
+                  </a:txBody>
+                  <a:tcPr>
+                    <a:solidFill>
+                      <a:srgbClr val="FFFFFF"/>
+                    </a:solidFill>
+                  </a:tcPr>
+                </a:tc>
+                <a:tc>
+                  <a:txBody>
+                    <a:bodyPr wrap="square"/>
+                    <a:lstStyle/>
+                    <a:p>
+                      <a:pPr algn="l"/>
+                      <a:r>
+                        <a:rPr sz="700" b="0">
+                          <a:solidFill>
+                            <a:srgbClr val="1A2340"/>
+                          </a:solidFill>
+                          <a:latin typeface="Calibri"/>
+                        </a:rPr>
+                        <a:t>Operaciones Fleet || Data Lab</a:t>
+                      </a:r>
+                    </a:p>
+                  </a:txBody>
+                  <a:tcPr>
+                    <a:solidFill>
+                      <a:srgbClr val="FFFFFF"/>
+                    </a:solidFill>
+                  </a:tcPr>
+                </a:tc>
+                <a:tc>
+                  <a:txBody>
+                    <a:bodyPr wrap="square"/>
+                    <a:lstStyle/>
+                    <a:p>
+                      <a:pPr algn="ctr"/>
+                      <a:r>
+                        <a:rPr sz="700" b="0">
+                          <a:solidFill>
+                            <a:srgbClr val="555555"/>
+                          </a:solidFill>
+                          <a:latin typeface="Calibri"/>
+                        </a:rPr>
+                        <a:t>20/01/2026</a:t>
+                      </a:r>
+                    </a:p>
+                  </a:txBody>
+                  <a:tcPr>
+                    <a:solidFill>
+                      <a:srgbClr val="FFFFFF"/>
+                    </a:solidFill>
+                  </a:tcPr>
+                </a:tc>
+                <a:tc>
+                  <a:txBody>
+                    <a:bodyPr wrap="square"/>
+                    <a:lstStyle/>
+                    <a:p>
+                      <a:pPr algn="ctr"/>
+                      <a:r>
+                        <a:rPr sz="700" b="0">
+                          <a:solidFill>
+                            <a:srgbClr val="555555"/>
+                          </a:solidFill>
+                          <a:latin typeface="Calibri"/>
+                        </a:rPr>
+                        <a:t>22/06/2026</a:t>
+                      </a:r>
+                    </a:p>
+                  </a:txBody>
+                  <a:tcPr>
+                    <a:solidFill>
+                      <a:srgbClr val="FFFFFF"/>
+                    </a:solidFill>
+                  </a:tcPr>
+                </a:tc>
+                <a:tc>
+                  <a:txBody>
+                    <a:bodyPr wrap="square"/>
+                    <a:lstStyle/>
+                    <a:p>
+                      <a:pPr algn="ctr"/>
+                      <a:r>
+                        <a:rPr sz="700" b="1">
+                          <a:solidFill>
+                            <a:srgbClr val="1A2340"/>
+                          </a:solidFill>
+                          <a:latin typeface="Calibri"/>
+                        </a:rPr>
+                        <a:t>100%</a:t>
+                      </a:r>
+                    </a:p>
+                  </a:txBody>
+                  <a:tcPr>
+                    <a:solidFill>
+                      <a:srgbClr val="FFFFFF"/>
+                    </a:solidFill>
+                  </a:tcPr>
+                </a:tc>
+                <a:tc>
+                  <a:txBody>
+                    <a:bodyPr wrap="square"/>
+                    <a:lstStyle/>
+                    <a:p>
+                      <a:pPr algn="ctr"/>
+                      <a:r>
+                        <a:rPr sz="700" b="0">
+                          <a:solidFill>
+                            <a:srgbClr val="555555"/>
+                          </a:solidFill>
+                          <a:latin typeface="Calibri"/>
+                        </a:rPr>
+                        <a:t>100%</a:t>
+                      </a:r>
+                    </a:p>
+                  </a:txBody>
+                  <a:tcPr>
+                    <a:solidFill>
+                      <a:srgbClr val="FFFFFF"/>
+                    </a:solidFill>
+                  </a:tcPr>
+                </a:tc>
+                <a:tc>
+                  <a:txBody>
+                    <a:bodyPr wrap="square"/>
+                    <a:lstStyle/>
+                    <a:p>
+                      <a:pPr algn="r"/>
+                      <a:r>
+                        <a:rPr sz="700" b="1">
+                          <a:solidFill>
+                            <a:srgbClr val="22C55E"/>
+                          </a:solidFill>
+                          <a:latin typeface="Calibri"/>
+                        </a:rPr>
+                        <a:t>100%</a:t>
+                      </a:r>
+                    </a:p>
+                  </a:txBody>
+                  <a:tcPr>
+                    <a:solidFill>
+                      <a:srgbClr val="22C55E"/>
+                    </a:solidFill>
+                  </a:tcPr>
+                </a:tc>
+                <a:tc>
+                  <a:txBody>
+                    <a:bodyPr wrap="square"/>
+                    <a:lstStyle/>
+                    <a:p>
+                      <a:pPr algn="ctr"/>
+                      <a:r>
+                        <a:rPr sz="700" b="1">
+                          <a:solidFill>
+                            <a:srgbClr val="22C55E"/>
+                          </a:solidFill>
+                          <a:latin typeface="Calibri"/>
+                        </a:rPr>
+                        <a:t>Terminado</a:t>
+                      </a:r>
+                    </a:p>
+                  </a:txBody>
+                  <a:tcPr>
+                    <a:solidFill>
+                      <a:srgbClr val="FFFFFF"/>
+                    </a:solidFill>
+                  </a:tcPr>
+                </a:tc>
+              </a:tr>
+              <a:tr h="196596">
+                <a:tc>
+                  <a:txBody>
+                    <a:bodyPr wrap="square"/>
+                    <a:lstStyle/>
+                    <a:p>
+                      <a:pPr algn="ctr"/>
+                      <a:r>
+                        <a:rPr sz="700" b="1">
+                          <a:solidFill>
+                            <a:srgbClr val="1A2340"/>
+                          </a:solidFill>
+                          <a:latin typeface="Calibri"/>
+                        </a:rPr>
+                        <a:t>Proyecto</a:t>
+                      </a:r>
+                    </a:p>
+                  </a:txBody>
+                  <a:tcPr>
+                    <a:solidFill>
+                      <a:srgbClr val="F5F7FA"/>
+                    </a:solidFill>
+                  </a:tcPr>
+                </a:tc>
+                <a:tc>
+                  <a:txBody>
+                    <a:bodyPr wrap="square"/>
+                    <a:lstStyle/>
+                    <a:p>
+                      <a:pPr algn="l"/>
+                      <a:r>
+                        <a:rPr sz="700" b="0">
+                          <a:solidFill>
+                            <a:srgbClr val="1A2340"/>
+                          </a:solidFill>
+                          <a:latin typeface="Calibri"/>
+                        </a:rPr>
+                        <a:t>Cartera || Cambio de Pac de Timbrado</a:t>
+                      </a:r>
+                    </a:p>
+                  </a:txBody>
+                  <a:tcPr>
+                    <a:solidFill>
+                      <a:srgbClr val="F5F7FA"/>
+                    </a:solidFill>
+                  </a:tcPr>
+                </a:tc>
+                <a:tc>
+                  <a:txBody>
+                    <a:bodyPr wrap="square"/>
+                    <a:lstStyle/>
+                    <a:p>
+                      <a:pPr algn="ctr"/>
+                      <a:r>
+                        <a:rPr sz="700" b="0">
+                          <a:solidFill>
+                            <a:srgbClr val="555555"/>
+                          </a:solidFill>
+                          <a:latin typeface="Calibri"/>
+                        </a:rPr>
+                        <a:t>07/07/2025</a:t>
+                      </a:r>
+                    </a:p>
+                  </a:txBody>
+                  <a:tcPr>
+                    <a:solidFill>
+                      <a:srgbClr val="F5F7FA"/>
+                    </a:solidFill>
+                  </a:tcPr>
+                </a:tc>
+                <a:tc>
+                  <a:txBody>
+                    <a:bodyPr wrap="square"/>
+                    <a:lstStyle/>
+                    <a:p>
+                      <a:pPr algn="ctr"/>
+                      <a:r>
+                        <a:rPr sz="700" b="0">
+                          <a:solidFill>
+                            <a:srgbClr val="555555"/>
+                          </a:solidFill>
+                          <a:latin typeface="Calibri"/>
+                        </a:rPr>
+                        <a:t>25/02/2026</a:t>
+                      </a:r>
+                    </a:p>
+                  </a:txBody>
+                  <a:tcPr>
+                    <a:solidFill>
+                      <a:srgbClr val="F5F7FA"/>
+                    </a:solidFill>
+                  </a:tcPr>
+                </a:tc>
+                <a:tc>
+                  <a:txBody>
+                    <a:bodyPr wrap="square"/>
+                    <a:lstStyle/>
+                    <a:p>
+                      <a:pPr algn="ctr"/>
+                      <a:r>
+                        <a:rPr sz="700" b="1">
+                          <a:solidFill>
+                            <a:srgbClr val="1A2340"/>
+                          </a:solidFill>
+                          <a:latin typeface="Calibri"/>
+                        </a:rPr>
+                        <a:t>100%</a:t>
+                      </a:r>
+                    </a:p>
+                  </a:txBody>
+                  <a:tcPr>
+                    <a:solidFill>
+                      <a:srgbClr val="F5F7FA"/>
+                    </a:solidFill>
+                  </a:tcPr>
+                </a:tc>
+                <a:tc>
+                  <a:txBody>
+                    <a:bodyPr wrap="square"/>
+                    <a:lstStyle/>
+                    <a:p>
+                      <a:pPr algn="ctr"/>
+                      <a:r>
+                        <a:rPr sz="700" b="0">
+                          <a:solidFill>
+                            <a:srgbClr val="555555"/>
+                          </a:solidFill>
+                          <a:latin typeface="Calibri"/>
+                        </a:rPr>
+                        <a:t>100%</a:t>
+                      </a:r>
+                    </a:p>
+                  </a:txBody>
+                  <a:tcPr>
+                    <a:solidFill>
+                      <a:srgbClr val="F5F7FA"/>
+                    </a:solidFill>
+                  </a:tcPr>
+                </a:tc>
+                <a:tc>
+                  <a:txBody>
+                    <a:bodyPr wrap="square"/>
+                    <a:lstStyle/>
+                    <a:p>
+                      <a:pPr algn="r"/>
+                      <a:r>
+                        <a:rPr sz="700" b="1">
+                          <a:solidFill>
+                            <a:srgbClr val="22C55E"/>
+                          </a:solidFill>
+                          <a:latin typeface="Calibri"/>
+                        </a:rPr>
+                        <a:t>100%</a:t>
+                      </a:r>
+                    </a:p>
+                  </a:txBody>
+                  <a:tcPr>
+                    <a:solidFill>
+                      <a:srgbClr val="22C55E"/>
+                    </a:solidFill>
+                  </a:tcPr>
+                </a:tc>
+                <a:tc>
+                  <a:txBody>
+                    <a:bodyPr wrap="square"/>
+                    <a:lstStyle/>
+                    <a:p>
+                      <a:pPr algn="ctr"/>
+                      <a:r>
+                        <a:rPr sz="700" b="1">
+                          <a:solidFill>
+                            <a:srgbClr val="22C55E"/>
+                          </a:solidFill>
+                          <a:latin typeface="Calibri"/>
+                        </a:rPr>
+                        <a:t>Terminado</a:t>
+                      </a:r>
+                    </a:p>
+                  </a:txBody>
+                  <a:tcPr>
+                    <a:solidFill>
+                      <a:srgbClr val="F5F7FA"/>
+                    </a:solidFill>
+                  </a:tcPr>
+                </a:tc>
+              </a:tr>
+              <a:tr h="196596">
+                <a:tc>
+                  <a:txBody>
+                    <a:bodyPr wrap="square"/>
+                    <a:lstStyle/>
+                    <a:p>
+                      <a:pPr algn="ctr"/>
+                      <a:r>
+                        <a:rPr sz="700" b="1">
+                          <a:solidFill>
+                            <a:srgbClr val="1A2340"/>
+                          </a:solidFill>
+                          <a:latin typeface="Calibri"/>
+                        </a:rPr>
+                        <a:t>Proyecto</a:t>
+                      </a:r>
+                    </a:p>
+                  </a:txBody>
+                  <a:tcPr>
+                    <a:solidFill>
+                      <a:srgbClr val="FFFFFF"/>
+                    </a:solidFill>
+                  </a:tcPr>
+                </a:tc>
+                <a:tc>
+                  <a:txBody>
+                    <a:bodyPr wrap="square"/>
+                    <a:lstStyle/>
+                    <a:p>
+                      <a:pPr algn="l"/>
+                      <a:r>
+                        <a:rPr sz="700" b="0">
+                          <a:solidFill>
+                            <a:srgbClr val="1A2340"/>
+                          </a:solidFill>
+                          <a:latin typeface="Calibri"/>
+                        </a:rPr>
+                        <a:t>Operaciones Fleet || Nueva Instancia</a:t>
+                      </a:r>
+                    </a:p>
+                  </a:txBody>
+                  <a:tcPr>
+                    <a:solidFill>
+                      <a:srgbClr val="FFFFFF"/>
+                    </a:solidFill>
+                  </a:tcPr>
+                </a:tc>
+                <a:tc>
+                  <a:txBody>
+                    <a:bodyPr wrap="square"/>
+                    <a:lstStyle/>
+                    <a:p>
+                      <a:pPr algn="ctr"/>
+                      <a:r>
+                        <a:rPr sz="700" b="0">
+                          <a:solidFill>
+                            <a:srgbClr val="555555"/>
+                          </a:solidFill>
+                          <a:latin typeface="Calibri"/>
+                        </a:rPr>
+                        <a:t>08/08/2025</a:t>
+                      </a:r>
+                    </a:p>
+                  </a:txBody>
+                  <a:tcPr>
+                    <a:solidFill>
+                      <a:srgbClr val="FFFFFF"/>
+                    </a:solidFill>
+                  </a:tcPr>
+                </a:tc>
+                <a:tc>
+                  <a:txBody>
+                    <a:bodyPr wrap="square"/>
+                    <a:lstStyle/>
+                    <a:p>
+                      <a:pPr algn="ctr"/>
+                      <a:r>
+                        <a:rPr sz="700" b="0">
+                          <a:solidFill>
+                            <a:srgbClr val="555555"/>
+                          </a:solidFill>
+                          <a:latin typeface="Calibri"/>
+                        </a:rPr>
+                        <a:t>01/06/2026</a:t>
+                      </a:r>
+                    </a:p>
+                  </a:txBody>
+                  <a:tcPr>
+                    <a:solidFill>
+                      <a:srgbClr val="FFFFFF"/>
+                    </a:solidFill>
+                  </a:tcPr>
+                </a:tc>
+                <a:tc>
+                  <a:txBody>
+                    <a:bodyPr wrap="square"/>
+                    <a:lstStyle/>
+                    <a:p>
+                      <a:pPr algn="ctr"/>
+                      <a:r>
+                        <a:rPr sz="700" b="1">
+                          <a:solidFill>
+                            <a:srgbClr val="1A2340"/>
+                          </a:solidFill>
+                          <a:latin typeface="Calibri"/>
+                        </a:rPr>
+                        <a:t>100%</a:t>
+                      </a:r>
+                    </a:p>
+                  </a:txBody>
+                  <a:tcPr>
+                    <a:solidFill>
+                      <a:srgbClr val="FFFFFF"/>
+                    </a:solidFill>
+                  </a:tcPr>
+                </a:tc>
+                <a:tc>
+                  <a:txBody>
+                    <a:bodyPr wrap="square"/>
+                    <a:lstStyle/>
+                    <a:p>
+                      <a:pPr algn="ctr"/>
+                      <a:r>
+                        <a:rPr sz="700" b="0">
+                          <a:solidFill>
+                            <a:srgbClr val="555555"/>
+                          </a:solidFill>
+                          <a:latin typeface="Calibri"/>
+                        </a:rPr>
+                        <a:t>100%</a:t>
+                      </a:r>
+                    </a:p>
+                  </a:txBody>
+                  <a:tcPr>
+                    <a:solidFill>
+                      <a:srgbClr val="FFFFFF"/>
+                    </a:solidFill>
+                  </a:tcPr>
+                </a:tc>
+                <a:tc>
+                  <a:txBody>
+                    <a:bodyPr wrap="square"/>
+                    <a:lstStyle/>
+                    <a:p>
+                      <a:pPr algn="r"/>
+                      <a:r>
+                        <a:rPr sz="700" b="1">
+                          <a:solidFill>
+                            <a:srgbClr val="22C55E"/>
+                          </a:solidFill>
+                          <a:latin typeface="Calibri"/>
+                        </a:rPr>
+                        <a:t>100%</a:t>
+                      </a:r>
+                    </a:p>
+                  </a:txBody>
+                  <a:tcPr>
+                    <a:solidFill>
+                      <a:srgbClr val="22C55E"/>
+                    </a:solidFill>
+                  </a:tcPr>
+                </a:tc>
+                <a:tc>
+                  <a:txBody>
+                    <a:bodyPr wrap="square"/>
+                    <a:lstStyle/>
+                    <a:p>
+                      <a:pPr algn="ctr"/>
+                      <a:r>
+                        <a:rPr sz="700" b="1">
+                          <a:solidFill>
+                            <a:srgbClr val="22C55E"/>
+                          </a:solidFill>
+                          <a:latin typeface="Calibri"/>
+                        </a:rPr>
+                        <a:t>Terminado</a:t>
+                      </a:r>
+                    </a:p>
+                  </a:txBody>
+                  <a:tcPr>
+                    <a:solidFill>
+                      <a:srgbClr val="FFFFFF"/>
+                    </a:solidFill>
+                  </a:tcPr>
+                </a:tc>
+              </a:tr>
+              <a:tr h="196596">
+                <a:tc>
+                  <a:txBody>
+                    <a:bodyPr wrap="square"/>
+                    <a:lstStyle/>
+                    <a:p>
+                      <a:pPr algn="ctr"/>
+                      <a:r>
+                        <a:rPr sz="700" b="1">
+                          <a:solidFill>
+                            <a:srgbClr val="1A2340"/>
+                          </a:solidFill>
+                          <a:latin typeface="Calibri"/>
+                        </a:rPr>
+                        <a:t>Proyecto</a:t>
+                      </a:r>
+                    </a:p>
+                  </a:txBody>
+                  <a:tcPr>
+                    <a:solidFill>
+                      <a:srgbClr val="F5F7FA"/>
+                    </a:solidFill>
+                  </a:tcPr>
+                </a:tc>
+                <a:tc>
+                  <a:txBody>
+                    <a:bodyPr wrap="square"/>
+                    <a:lstStyle/>
+                    <a:p>
+                      <a:pPr algn="l"/>
+                      <a:r>
+                        <a:rPr sz="700" b="0">
+                          <a:solidFill>
+                            <a:srgbClr val="1A2340"/>
+                          </a:solidFill>
+                          <a:latin typeface="Calibri"/>
+                        </a:rPr>
+                        <a:t>Tesoreria || Adcontent H2H</a:t>
+                      </a:r>
+                    </a:p>
+                  </a:txBody>
+                  <a:tcPr>
+                    <a:solidFill>
+                      <a:srgbClr val="F5F7FA"/>
+                    </a:solidFill>
+                  </a:tcPr>
+                </a:tc>
+                <a:tc>
+                  <a:txBody>
+                    <a:bodyPr wrap="square"/>
+                    <a:lstStyle/>
+                    <a:p>
+                      <a:pPr algn="ctr"/>
+                      <a:r>
+                        <a:rPr sz="700" b="0">
+                          <a:solidFill>
+                            <a:srgbClr val="555555"/>
+                          </a:solidFill>
+                          <a:latin typeface="Calibri"/>
+                        </a:rPr>
+                        <a:t>07/04/2026</a:t>
+                      </a:r>
+                    </a:p>
+                  </a:txBody>
+                  <a:tcPr>
+                    <a:solidFill>
+                      <a:srgbClr val="F5F7FA"/>
+                    </a:solidFill>
+                  </a:tcPr>
+                </a:tc>
+                <a:tc>
+                  <a:txBody>
+                    <a:bodyPr wrap="square"/>
+                    <a:lstStyle/>
+                    <a:p>
+                      <a:pPr algn="ctr"/>
+                      <a:r>
+                        <a:rPr sz="700" b="0">
+                          <a:solidFill>
+                            <a:srgbClr val="555555"/>
+                          </a:solidFill>
+                          <a:latin typeface="Calibri"/>
+                        </a:rPr>
+                        <a:t>26/08/2026</a:t>
+                      </a:r>
+                    </a:p>
+                  </a:txBody>
+                  <a:tcPr>
+                    <a:solidFill>
+                      <a:srgbClr val="F5F7FA"/>
+                    </a:solidFill>
+                  </a:tcPr>
+                </a:tc>
+                <a:tc>
+                  <a:txBody>
+                    <a:bodyPr wrap="square"/>
+                    <a:lstStyle/>
+                    <a:p>
+                      <a:pPr algn="ctr"/>
+                      <a:r>
+                        <a:rPr sz="700" b="1">
+                          <a:solidFill>
+                            <a:srgbClr val="1A2340"/>
+                          </a:solidFill>
+                          <a:latin typeface="Calibri"/>
+                        </a:rPr>
+                        <a:t>22%</a:t>
+                      </a:r>
+                    </a:p>
+                  </a:txBody>
+                  <a:tcPr>
+                    <a:solidFill>
+                      <a:srgbClr val="F5F7FA"/>
+                    </a:solidFill>
+                  </a:tcPr>
+                </a:tc>
+                <a:tc>
+                  <a:txBody>
+                    <a:bodyPr wrap="square"/>
+                    <a:lstStyle/>
+                    <a:p>
+                      <a:pPr algn="ctr"/>
+                      <a:r>
+                        <a:rPr sz="700" b="0">
+                          <a:solidFill>
+                            <a:srgbClr val="555555"/>
+                          </a:solidFill>
+                          <a:latin typeface="Calibri"/>
+                        </a:rPr>
+                        <a:t>63%</a:t>
+                      </a:r>
+                    </a:p>
+                  </a:txBody>
+                  <a:tcPr>
+                    <a:solidFill>
+                      <a:srgbClr val="F5F7FA"/>
+                    </a:solidFill>
+                  </a:tcPr>
+                </a:tc>
+                <a:tc>
+                  <a:txBody>
+                    <a:bodyPr wrap="square"/>
+                    <a:lstStyle/>
+                    <a:p>
+                      <a:pPr algn="r"/>
+                      <a:r>
+                        <a:rPr sz="700" b="1">
+                          <a:solidFill>
+                            <a:srgbClr val="EF4444"/>
+                          </a:solidFill>
+                          <a:latin typeface="Calibri"/>
+                        </a:rPr>
+                        <a:t>22%</a:t>
+                      </a:r>
+                    </a:p>
+                  </a:txBody>
+                  <a:tcPr>
+                    <a:gradFill>
+                      <a:gsLst>
+                        <a:gs pos="0">
+                          <a:srgbClr val="EF4444"/>
+                        </a:gs>
+                        <a:gs pos="22000">
+                          <a:srgbClr val="EF4444"/>
+                        </a:gs>
+                        <a:gs pos="22500">
+                          <a:srgbClr val="E2E2E2"/>
+                        </a:gs>
+                        <a:gs pos="100000">
+                          <a:srgbClr val="E2E2E2"/>
+                        </a:gs>
+                      </a:gsLst>
+                      <a:lin ang="0" scaled="0"/>
+                    </a:gradFill>
+                  </a:tcPr>
+                </a:tc>
+                <a:tc>
+                  <a:txBody>
+                    <a:bodyPr wrap="square"/>
+                    <a:lstStyle/>
+                    <a:p>
+                      <a:pPr algn="ctr"/>
+                      <a:r>
+                        <a:rPr sz="700" b="1">
+                          <a:solidFill>
+                            <a:srgbClr val="EF4444"/>
+                          </a:solidFill>
+                          <a:latin typeface="Calibri"/>
+                        </a:rPr>
+                        <a:t>Atrasado</a:t>
+                      </a:r>
+                    </a:p>
+                  </a:txBody>
+                  <a:tcPr>
+                    <a:solidFill>
+                      <a:srgbClr val="F5F7FA"/>
+                    </a:solidFill>
+                  </a:tcPr>
+                </a:tc>
+              </a:tr>
+              <a:tr h="196596">
+                <a:tc>
+                  <a:txBody>
+                    <a:bodyPr wrap="square"/>
+                    <a:lstStyle/>
+                    <a:p>
+                      <a:pPr algn="ctr"/>
+                      <a:r>
+                        <a:rPr sz="700" b="1">
+                          <a:solidFill>
+                            <a:srgbClr val="1A2340"/>
+                          </a:solidFill>
+                          <a:latin typeface="Calibri"/>
+                        </a:rPr>
+                        <a:t>Proyecto</a:t>
+                      </a:r>
+                    </a:p>
+                  </a:txBody>
+                  <a:tcPr>
+                    <a:solidFill>
+                      <a:srgbClr val="FFFFFF"/>
+                    </a:solidFill>
+                  </a:tcPr>
+                </a:tc>
+                <a:tc>
+                  <a:txBody>
+                    <a:bodyPr wrap="square"/>
+                    <a:lstStyle/>
+                    <a:p>
+                      <a:pPr algn="l"/>
+                      <a:r>
+                        <a:rPr sz="700" b="0">
+                          <a:solidFill>
+                            <a:srgbClr val="1A2340"/>
+                          </a:solidFill>
+                          <a:latin typeface="Calibri"/>
+                        </a:rPr>
+                        <a:t>Talleres || Integración Mecanica Mx - SAE</a:t>
+                      </a:r>
+                    </a:p>
+                  </a:txBody>
+                  <a:tcPr>
+                    <a:solidFill>
+                      <a:srgbClr val="FFFFFF"/>
+                    </a:solidFill>
+                  </a:tcPr>
+                </a:tc>
+                <a:tc>
+                  <a:txBody>
+                    <a:bodyPr wrap="square"/>
+                    <a:lstStyle/>
+                    <a:p>
+                      <a:pPr algn="ctr"/>
+                      <a:r>
+                        <a:rPr sz="700" b="0">
+                          <a:solidFill>
+                            <a:srgbClr val="555555"/>
+                          </a:solidFill>
+                          <a:latin typeface="Calibri"/>
+                        </a:rPr>
+                        <a:t>20/04/2026</a:t>
+                      </a:r>
+                    </a:p>
+                  </a:txBody>
+                  <a:tcPr>
+                    <a:solidFill>
+                      <a:srgbClr val="FFFFFF"/>
+                    </a:solidFill>
+                  </a:tcPr>
+                </a:tc>
+                <a:tc>
+                  <a:txBody>
+                    <a:bodyPr wrap="square"/>
+                    <a:lstStyle/>
+                    <a:p>
+                      <a:pPr algn="ctr"/>
+                      <a:r>
+                        <a:rPr sz="700" b="0">
+                          <a:solidFill>
+                            <a:srgbClr val="555555"/>
+                          </a:solidFill>
+                          <a:latin typeface="Calibri"/>
+                        </a:rPr>
+                        <a:t>20/07/2026</a:t>
+                      </a:r>
+                    </a:p>
+                  </a:txBody>
+                  <a:tcPr>
+                    <a:solidFill>
+                      <a:srgbClr val="FFFFFF"/>
+                    </a:solidFill>
+                  </a:tcPr>
+                </a:tc>
+                <a:tc>
+                  <a:txBody>
+                    <a:bodyPr wrap="square"/>
+                    <a:lstStyle/>
+                    <a:p>
+                      <a:pPr algn="ctr"/>
+                      <a:r>
+                        <a:rPr sz="700" b="1">
+                          <a:solidFill>
+                            <a:srgbClr val="1A2340"/>
+                          </a:solidFill>
+                          <a:latin typeface="Calibri"/>
+                        </a:rPr>
+                        <a:t>80%</a:t>
+                      </a:r>
+                    </a:p>
+                  </a:txBody>
+                  <a:tcPr>
+                    <a:solidFill>
+                      <a:srgbClr val="FFFFFF"/>
+                    </a:solidFill>
+                  </a:tcPr>
+                </a:tc>
+                <a:tc>
+                  <a:txBody>
+                    <a:bodyPr wrap="square"/>
+                    <a:lstStyle/>
+                    <a:p>
+                      <a:pPr algn="ctr"/>
+                      <a:r>
+                        <a:rPr sz="700" b="0">
+                          <a:solidFill>
+                            <a:srgbClr val="555555"/>
+                          </a:solidFill>
+                          <a:latin typeface="Calibri"/>
+                        </a:rPr>
+                        <a:t>84%</a:t>
+                      </a:r>
+                    </a:p>
+                  </a:txBody>
+                  <a:tcPr>
+                    <a:solidFill>
+                      <a:srgbClr val="FFFFFF"/>
+                    </a:solidFill>
+                  </a:tcPr>
+                </a:tc>
+                <a:tc>
+                  <a:txBody>
+                    <a:bodyPr wrap="square"/>
+                    <a:lstStyle/>
+                    <a:p>
+                      <a:pPr algn="r"/>
+                      <a:r>
+                        <a:rPr sz="700" b="1">
+                          <a:solidFill>
+                            <a:srgbClr val="F59E0B"/>
+                          </a:solidFill>
+                          <a:latin typeface="Calibri"/>
+                        </a:rPr>
+                        <a:t>80%</a:t>
+                      </a:r>
+                    </a:p>
+                  </a:txBody>
+                  <a:tcPr>
+                    <a:gradFill>
+                      <a:gsLst>
+                        <a:gs pos="0">
+                          <a:srgbClr val="F59E0B"/>
+                        </a:gs>
+                        <a:gs pos="80000">
+                          <a:srgbClr val="F59E0B"/>
+                        </a:gs>
+                        <a:gs pos="80500">
+                          <a:srgbClr val="E2E2E2"/>
+                        </a:gs>
+                        <a:gs pos="100000">
+                          <a:srgbClr val="E2E2E2"/>
+                        </a:gs>
+                      </a:gsLst>
+                      <a:lin ang="0" scaled="0"/>
+                    </a:gradFill>
+                  </a:tcPr>
+                </a:tc>
+                <a:tc>
+                  <a:txBody>
+                    <a:bodyPr wrap="square"/>
+                    <a:lstStyle/>
+                    <a:p>
+                      <a:pPr algn="ctr"/>
+                      <a:r>
+                        <a:rPr sz="700" b="1">
+                          <a:solidFill>
+                            <a:srgbClr val="F59E0B"/>
+                          </a:solidFill>
+                          <a:latin typeface="Calibri"/>
+                        </a:rPr>
+                        <a:t>Riesgo de atraso</a:t>
+                      </a:r>
+                    </a:p>
+                  </a:txBody>
+                  <a:tcPr>
+                    <a:solidFill>
+                      <a:srgbClr val="FFFFFF"/>
+                    </a:solidFill>
+                  </a:tcPr>
+                </a:tc>
+              </a:tr>
+              <a:tr h="196596">
+                <a:tc>
+                  <a:txBody>
+                    <a:bodyPr wrap="square"/>
+                    <a:lstStyle/>
+                    <a:p>
+                      <a:pPr algn="ctr"/>
+                      <a:r>
+                        <a:rPr sz="700" b="1">
+                          <a:solidFill>
+                            <a:srgbClr val="1A2340"/>
+                          </a:solidFill>
+                          <a:latin typeface="Calibri"/>
+                        </a:rPr>
+                        <a:t>Proyecto</a:t>
+                      </a:r>
+                    </a:p>
+                  </a:txBody>
+                  <a:tcPr>
+                    <a:solidFill>
+                      <a:srgbClr val="F5F7FA"/>
+                    </a:solidFill>
+                  </a:tcPr>
+                </a:tc>
+                <a:tc>
+                  <a:txBody>
+                    <a:bodyPr wrap="square"/>
+                    <a:lstStyle/>
+                    <a:p>
+                      <a:pPr algn="l"/>
+                      <a:r>
+                        <a:rPr sz="700" b="0">
+                          <a:solidFill>
+                            <a:srgbClr val="1A2340"/>
+                          </a:solidFill>
+                          <a:latin typeface="Calibri"/>
+                        </a:rPr>
+                        <a:t>Contabilidad || Integración Mecanica-SAE (Fase 2)</a:t>
+                      </a:r>
+                    </a:p>
+                  </a:txBody>
+                  <a:tcPr>
+                    <a:solidFill>
+                      <a:srgbClr val="F5F7FA"/>
+                    </a:solidFill>
+                  </a:tcPr>
+                </a:tc>
+                <a:tc>
+                  <a:txBody>
+                    <a:bodyPr wrap="square"/>
+                    <a:lstStyle/>
+                    <a:p>
+                      <a:pPr algn="ctr"/>
+                      <a:r>
+                        <a:rPr sz="700" b="0">
+                          <a:solidFill>
+                            <a:srgbClr val="555555"/>
+                          </a:solidFill>
+                          <a:latin typeface="Calibri"/>
+                        </a:rPr>
+                        <a:t>21/04/2026</a:t>
+                      </a:r>
+                    </a:p>
+                  </a:txBody>
+                  <a:tcPr>
+                    <a:solidFill>
+                      <a:srgbClr val="F5F7FA"/>
+                    </a:solidFill>
+                  </a:tcPr>
+                </a:tc>
+                <a:tc>
+                  <a:txBody>
+                    <a:bodyPr wrap="square"/>
+                    <a:lstStyle/>
+                    <a:p>
+                      <a:pPr algn="ctr"/>
+                      <a:r>
+                        <a:rPr sz="700" b="0">
+                          <a:solidFill>
+                            <a:srgbClr val="555555"/>
+                          </a:solidFill>
+                          <a:latin typeface="Calibri"/>
+                        </a:rPr>
+                        <a:t>12/06/2026</a:t>
+                      </a:r>
+                    </a:p>
+                  </a:txBody>
+                  <a:tcPr>
+                    <a:solidFill>
+                      <a:srgbClr val="F5F7FA"/>
+                    </a:solidFill>
+                  </a:tcPr>
+                </a:tc>
+                <a:tc>
+                  <a:txBody>
+                    <a:bodyPr wrap="square"/>
+                    <a:lstStyle/>
+                    <a:p>
+                      <a:pPr algn="ctr"/>
+                      <a:r>
+                        <a:rPr sz="700" b="1">
+                          <a:solidFill>
+                            <a:srgbClr val="1A2340"/>
+                          </a:solidFill>
+                          <a:latin typeface="Calibri"/>
+                        </a:rPr>
                         <a:t>99%</a:t>
                       </a:r>
                     </a:p>
@@ -7879,7 +9395,7 @@
                           </a:solidFill>
                           <a:latin typeface="Calibri"/>
                         </a:rPr>
-                        <a:t>Operaciones Fleet || Lobby Fix</a:t>
+                        <a:t>DTI || Integración de sistemas</a:t>
                       </a:r>
                     </a:p>
                   </a:txBody>
@@ -7902,7 +9418,7 @@
                           </a:solidFill>
                           <a:latin typeface="Calibri"/>
                         </a:rPr>
-                        <a:t>11/11/2025</a:t>
+                        <a:t>01/06/2026</a:t>
                       </a:r>
                     </a:p>
                   </a:txBody>
@@ -7925,7 +9441,7 @@
                           </a:solidFill>
                           <a:latin typeface="Calibri"/>
                         </a:rPr>
-                        <a:t>29/06/2026</a:t>
+                        <a:t>23/09/2026</a:t>
                       </a:r>
                     </a:p>
                   </a:txBody>
@@ -7948,7 +9464,7 @@
                           </a:solidFill>
                           <a:latin typeface="Calibri"/>
                         </a:rPr>
-                        <a:t>100%</a:t>
+                        <a:t>31%</a:t>
                       </a:r>
                     </a:p>
                   </a:txBody>
@@ -7971,7 +9487,7 @@
                           </a:solidFill>
                           <a:latin typeface="Calibri"/>
                         </a:rPr>
-                        <a:t>100%</a:t>
+                        <a:t>30%</a:t>
                       </a:r>
                     </a:p>
                   </a:txBody>
@@ -7994,193 +9510,7 @@
                           </a:solidFill>
                           <a:latin typeface="Calibri"/>
                         </a:rPr>
-                        <a:t>100%</a:t>
-                      </a:r>
-                    </a:p>
-                  </a:txBody>
-                  <a:tcPr>
-                    <a:solidFill>
-                      <a:srgbClr val="22C55E"/>
-                    </a:solidFill>
-                  </a:tcPr>
-                </a:tc>
-                <a:tc>
-                  <a:txBody>
-                    <a:bodyPr wrap="square"/>
-                    <a:lstStyle/>
-                    <a:p>
-                      <a:pPr algn="ctr"/>
-                      <a:r>
-                        <a:rPr sz="700" b="1">
-                          <a:solidFill>
-                            <a:srgbClr val="22C55E"/>
-                          </a:solidFill>
-                          <a:latin typeface="Calibri"/>
-                        </a:rPr>
-                        <a:t>Terminado</a:t>
-                      </a:r>
-                    </a:p>
-                  </a:txBody>
-                  <a:tcPr>
-                    <a:solidFill>
-                      <a:srgbClr val="FFFFFF"/>
-                    </a:solidFill>
-                  </a:tcPr>
-                </a:tc>
-              </a:tr>
-              <a:tr h="196596">
-                <a:tc>
-                  <a:txBody>
-                    <a:bodyPr wrap="square"/>
-                    <a:lstStyle/>
-                    <a:p>
-                      <a:pPr algn="ctr"/>
-                      <a:r>
-                        <a:rPr sz="700" b="1">
-                          <a:solidFill>
-                            <a:srgbClr val="1A2340"/>
-                          </a:solidFill>
-                          <a:latin typeface="Calibri"/>
-                        </a:rPr>
-                        <a:t>Proyecto</a:t>
-                      </a:r>
-                    </a:p>
-                  </a:txBody>
-                  <a:tcPr>
-                    <a:solidFill>
-                      <a:srgbClr val="F5F7FA"/>
-                    </a:solidFill>
-                  </a:tcPr>
-                </a:tc>
-                <a:tc>
-                  <a:txBody>
-                    <a:bodyPr wrap="square"/>
-                    <a:lstStyle/>
-                    <a:p>
-                      <a:pPr algn="l"/>
-                      <a:r>
-                        <a:rPr sz="700" b="0">
-                          <a:solidFill>
-                            <a:srgbClr val="1A2340"/>
-                          </a:solidFill>
-                          <a:latin typeface="Calibri"/>
-                        </a:rPr>
-                        <a:t>Nexcar || Desarrollo Status</a:t>
-                      </a:r>
-                    </a:p>
-                  </a:txBody>
-                  <a:tcPr>
-                    <a:solidFill>
-                      <a:srgbClr val="F5F7FA"/>
-                    </a:solidFill>
-                  </a:tcPr>
-                </a:tc>
-                <a:tc>
-                  <a:txBody>
-                    <a:bodyPr wrap="square"/>
-                    <a:lstStyle/>
-                    <a:p>
-                      <a:pPr algn="ctr"/>
-                      <a:r>
-                        <a:rPr sz="700" b="0">
-                          <a:solidFill>
-                            <a:srgbClr val="555555"/>
-                          </a:solidFill>
-                          <a:latin typeface="Calibri"/>
-                        </a:rPr>
-                        <a:t>05/03/2026</a:t>
-                      </a:r>
-                    </a:p>
-                  </a:txBody>
-                  <a:tcPr>
-                    <a:solidFill>
-                      <a:srgbClr val="F5F7FA"/>
-                    </a:solidFill>
-                  </a:tcPr>
-                </a:tc>
-                <a:tc>
-                  <a:txBody>
-                    <a:bodyPr wrap="square"/>
-                    <a:lstStyle/>
-                    <a:p>
-                      <a:pPr algn="ctr"/>
-                      <a:r>
-                        <a:rPr sz="700" b="0">
-                          <a:solidFill>
-                            <a:srgbClr val="555555"/>
-                          </a:solidFill>
-                          <a:latin typeface="Calibri"/>
-                        </a:rPr>
-                        <a:t>10/07/2026</a:t>
-                      </a:r>
-                    </a:p>
-                  </a:txBody>
-                  <a:tcPr>
-                    <a:solidFill>
-                      <a:srgbClr val="F5F7FA"/>
-                    </a:solidFill>
-                  </a:tcPr>
-                </a:tc>
-                <a:tc>
-                  <a:txBody>
-                    <a:bodyPr wrap="square"/>
-                    <a:lstStyle/>
-                    <a:p>
-                      <a:pPr algn="ctr"/>
-                      <a:r>
-                        <a:rPr sz="700" b="1">
-                          <a:solidFill>
-                            <a:srgbClr val="1A2340"/>
-                          </a:solidFill>
-                          <a:latin typeface="Calibri"/>
-                        </a:rPr>
-                        <a:t>99%</a:t>
-                      </a:r>
-                    </a:p>
-                  </a:txBody>
-                  <a:tcPr>
-                    <a:solidFill>
-                      <a:srgbClr val="F5F7FA"/>
-                    </a:solidFill>
-                  </a:tcPr>
-                </a:tc>
-                <a:tc>
-                  <a:txBody>
-                    <a:bodyPr wrap="square"/>
-                    <a:lstStyle/>
-                    <a:p>
-                      <a:pPr algn="ctr"/>
-                      <a:r>
-                        <a:rPr sz="700" b="0">
-                          <a:solidFill>
-                            <a:srgbClr val="555555"/>
-                          </a:solidFill>
-                          <a:latin typeface="Calibri"/>
-                        </a:rPr>
-                        <a:t>91%</a:t>
-                      </a:r>
-                    </a:p>
-                  </a:txBody>
-                  <a:tcPr>
-                    <a:solidFill>
-                      <a:srgbClr val="F5F7FA"/>
-                    </a:solidFill>
-                  </a:tcPr>
-                </a:tc>
-                <a:tc>
-                  <a:txBody>
-                    <a:bodyPr wrap="square"/>
-                    <a:lstStyle/>
-                    <a:p>
-                      <a:pPr algn="r"/>
-                      <a:r>
-                        <a:rPr sz="700" b="1">
-                          <a:solidFill>
-                            <a:srgbClr val="22C55E"/>
-                          </a:solidFill>
-                          <a:latin typeface="Calibri"/>
-                        </a:rPr>
-                        <a:t>99%</a:t>
+                        <a:t>31%</a:t>
                       </a:r>
                     </a:p>
                   </a:txBody>
@@ -8190,10 +9520,10 @@
                         <a:gs pos="0">
                           <a:srgbClr val="22C55E"/>
                         </a:gs>
-                        <a:gs pos="99000">
+                        <a:gs pos="31000">
                           <a:srgbClr val="22C55E"/>
                         </a:gs>
-                        <a:gs pos="99500">
+                        <a:gs pos="31500">
                           <a:srgbClr val="E2E2E2"/>
                         </a:gs>
                         <a:gs pos="100000">
@@ -8223,7 +9553,7 @@
                   </a:txBody>
                   <a:tcPr>
                     <a:solidFill>
-                      <a:srgbClr val="F5F7FA"/>
+                      <a:srgbClr val="FFFFFF"/>
                     </a:solidFill>
                   </a:tcPr>
                 </a:tc>
@@ -8248,7 +9578,7 @@
                   </a:txBody>
                   <a:tcPr>
                     <a:solidFill>
-                      <a:srgbClr val="FFFFFF"/>
+                      <a:srgbClr val="F5F7FA"/>
                     </a:solidFill>
                   </a:tcPr>
                 </a:tc>
@@ -8265,13 +9595,13 @@
                           </a:solidFill>
                           <a:latin typeface="Calibri"/>
                         </a:rPr>
-                        <a:t>Operaciones Fleet || Data Lab</a:t>
-                      </a:r>
-                    </a:p>
-                  </a:txBody>
-                  <a:tcPr>
-                    <a:solidFill>
-                      <a:srgbClr val="FFFFFF"/>
+                        <a:t>Capital Humano || BUK Personalizados Fase 2</a:t>
+                      </a:r>
+                    </a:p>
+                  </a:txBody>
+                  <a:tcPr>
+                    <a:solidFill>
+                      <a:srgbClr val="F5F7FA"/>
                     </a:solidFill>
                   </a:tcPr>
                 </a:tc>
@@ -8288,13 +9618,13 @@
                           </a:solidFill>
                           <a:latin typeface="Calibri"/>
                         </a:rPr>
-                        <a:t>20/01/2026</a:t>
-                      </a:r>
-                    </a:p>
-                  </a:txBody>
-                  <a:tcPr>
-                    <a:solidFill>
-                      <a:srgbClr val="FFFFFF"/>
+                        <a:t>08/06/2026</a:t>
+                      </a:r>
+                    </a:p>
+                  </a:txBody>
+                  <a:tcPr>
+                    <a:solidFill>
+                      <a:srgbClr val="F5F7FA"/>
                     </a:solidFill>
                   </a:tcPr>
                 </a:tc>
@@ -8311,13 +9641,13 @@
                           </a:solidFill>
                           <a:latin typeface="Calibri"/>
                         </a:rPr>
-                        <a:t>22/06/2026</a:t>
-                      </a:r>
-                    </a:p>
-                  </a:txBody>
-                  <a:tcPr>
-                    <a:solidFill>
-                      <a:srgbClr val="FFFFFF"/>
+                        <a:t>11/08/2026</a:t>
+                      </a:r>
+                    </a:p>
+                  </a:txBody>
+                  <a:tcPr>
+                    <a:solidFill>
+                      <a:srgbClr val="F5F7FA"/>
                     </a:solidFill>
                   </a:tcPr>
                 </a:tc>
@@ -8334,13 +9664,13 @@
                           </a:solidFill>
                           <a:latin typeface="Calibri"/>
                         </a:rPr>
-                        <a:t>100%</a:t>
-                      </a:r>
-                    </a:p>
-                  </a:txBody>
-                  <a:tcPr>
-                    <a:solidFill>
-                      <a:srgbClr val="FFFFFF"/>
+                        <a:t>74%</a:t>
+                      </a:r>
+                    </a:p>
+                  </a:txBody>
+                  <a:tcPr>
+                    <a:solidFill>
+                      <a:srgbClr val="F5F7FA"/>
                     </a:solidFill>
                   </a:tcPr>
                 </a:tc>
@@ -8357,13 +9687,13 @@
                           </a:solidFill>
                           <a:latin typeface="Calibri"/>
                         </a:rPr>
-                        <a:t>100%</a:t>
-                      </a:r>
-                    </a:p>
-                  </a:txBody>
-                  <a:tcPr>
-                    <a:solidFill>
-                      <a:srgbClr val="FFFFFF"/>
+                        <a:t>43%</a:t>
+                      </a:r>
+                    </a:p>
+                  </a:txBody>
+                  <a:tcPr>
+                    <a:solidFill>
+                      <a:srgbClr val="F5F7FA"/>
                     </a:solidFill>
                   </a:tcPr>
                 </a:tc>
@@ -8380,565 +9710,7 @@
                           </a:solidFill>
                           <a:latin typeface="Calibri"/>
                         </a:rPr>
-                        <a:t>100%</a:t>
-                      </a:r>
-                    </a:p>
-                  </a:txBody>
-                  <a:tcPr>
-                    <a:solidFill>
-                      <a:srgbClr val="22C55E"/>
-                    </a:solidFill>
-                  </a:tcPr>
-                </a:tc>
-                <a:tc>
-                  <a:txBody>
-                    <a:bodyPr wrap="square"/>
-                    <a:lstStyle/>
-                    <a:p>
-                      <a:pPr algn="ctr"/>
-                      <a:r>
-                        <a:rPr sz="700" b="1">
-                          <a:solidFill>
-                            <a:srgbClr val="22C55E"/>
-                          </a:solidFill>
-                          <a:latin typeface="Calibri"/>
-                        </a:rPr>
-                        <a:t>Terminado</a:t>
-                      </a:r>
-                    </a:p>
-                  </a:txBody>
-                  <a:tcPr>
-                    <a:solidFill>
-                      <a:srgbClr val="FFFFFF"/>
-                    </a:solidFill>
-                  </a:tcPr>
-                </a:tc>
-              </a:tr>
-              <a:tr h="196596">
-                <a:tc>
-                  <a:txBody>
-                    <a:bodyPr wrap="square"/>
-                    <a:lstStyle/>
-                    <a:p>
-                      <a:pPr algn="ctr"/>
-                      <a:r>
-                        <a:rPr sz="700" b="1">
-                          <a:solidFill>
-                            <a:srgbClr val="1A2340"/>
-                          </a:solidFill>
-                          <a:latin typeface="Calibri"/>
-                        </a:rPr>
-                        <a:t>Proyecto</a:t>
-                      </a:r>
-                    </a:p>
-                  </a:txBody>
-                  <a:tcPr>
-                    <a:solidFill>
-                      <a:srgbClr val="F5F7FA"/>
-                    </a:solidFill>
-                  </a:tcPr>
-                </a:tc>
-                <a:tc>
-                  <a:txBody>
-                    <a:bodyPr wrap="square"/>
-                    <a:lstStyle/>
-                    <a:p>
-                      <a:pPr algn="l"/>
-                      <a:r>
-                        <a:rPr sz="700" b="0">
-                          <a:solidFill>
-                            <a:srgbClr val="1A2340"/>
-                          </a:solidFill>
-                          <a:latin typeface="Calibri"/>
-                        </a:rPr>
-                        <a:t>Cartera || Cambio de Pac de Timbrado</a:t>
-                      </a:r>
-                    </a:p>
-                  </a:txBody>
-                  <a:tcPr>
-                    <a:solidFill>
-                      <a:srgbClr val="F5F7FA"/>
-                    </a:solidFill>
-                  </a:tcPr>
-                </a:tc>
-                <a:tc>
-                  <a:txBody>
-                    <a:bodyPr wrap="square"/>
-                    <a:lstStyle/>
-                    <a:p>
-                      <a:pPr algn="ctr"/>
-                      <a:r>
-                        <a:rPr sz="700" b="0">
-                          <a:solidFill>
-                            <a:srgbClr val="555555"/>
-                          </a:solidFill>
-                          <a:latin typeface="Calibri"/>
-                        </a:rPr>
-                        <a:t>07/07/2025</a:t>
-                      </a:r>
-                    </a:p>
-                  </a:txBody>
-                  <a:tcPr>
-                    <a:solidFill>
-                      <a:srgbClr val="F5F7FA"/>
-                    </a:solidFill>
-                  </a:tcPr>
-                </a:tc>
-                <a:tc>
-                  <a:txBody>
-                    <a:bodyPr wrap="square"/>
-                    <a:lstStyle/>
-                    <a:p>
-                      <a:pPr algn="ctr"/>
-                      <a:r>
-                        <a:rPr sz="700" b="0">
-                          <a:solidFill>
-                            <a:srgbClr val="555555"/>
-                          </a:solidFill>
-                          <a:latin typeface="Calibri"/>
-                        </a:rPr>
-                        <a:t>25/02/2026</a:t>
-                      </a:r>
-                    </a:p>
-                  </a:txBody>
-                  <a:tcPr>
-                    <a:solidFill>
-                      <a:srgbClr val="F5F7FA"/>
-                    </a:solidFill>
-                  </a:tcPr>
-                </a:tc>
-                <a:tc>
-                  <a:txBody>
-                    <a:bodyPr wrap="square"/>
-                    <a:lstStyle/>
-                    <a:p>
-                      <a:pPr algn="ctr"/>
-                      <a:r>
-                        <a:rPr sz="700" b="1">
-                          <a:solidFill>
-                            <a:srgbClr val="1A2340"/>
-                          </a:solidFill>
-                          <a:latin typeface="Calibri"/>
-                        </a:rPr>
-                        <a:t>100%</a:t>
-                      </a:r>
-                    </a:p>
-                  </a:txBody>
-                  <a:tcPr>
-                    <a:solidFill>
-                      <a:srgbClr val="F5F7FA"/>
-                    </a:solidFill>
-                  </a:tcPr>
-                </a:tc>
-                <a:tc>
-                  <a:txBody>
-                    <a:bodyPr wrap="square"/>
-                    <a:lstStyle/>
-                    <a:p>
-                      <a:pPr algn="ctr"/>
-                      <a:r>
-                        <a:rPr sz="700" b="0">
-                          <a:solidFill>
-                            <a:srgbClr val="555555"/>
-                          </a:solidFill>
-                          <a:latin typeface="Calibri"/>
-                        </a:rPr>
-                        <a:t>100%</a:t>
-                      </a:r>
-                    </a:p>
-                  </a:txBody>
-                  <a:tcPr>
-                    <a:solidFill>
-                      <a:srgbClr val="F5F7FA"/>
-                    </a:solidFill>
-                  </a:tcPr>
-                </a:tc>
-                <a:tc>
-                  <a:txBody>
-                    <a:bodyPr wrap="square"/>
-                    <a:lstStyle/>
-                    <a:p>
-                      <a:pPr algn="r"/>
-                      <a:r>
-                        <a:rPr sz="700" b="1">
-                          <a:solidFill>
-                            <a:srgbClr val="22C55E"/>
-                          </a:solidFill>
-                          <a:latin typeface="Calibri"/>
-                        </a:rPr>
-                        <a:t>100%</a:t>
-                      </a:r>
-                    </a:p>
-                  </a:txBody>
-                  <a:tcPr>
-                    <a:solidFill>
-                      <a:srgbClr val="22C55E"/>
-                    </a:solidFill>
-                  </a:tcPr>
-                </a:tc>
-                <a:tc>
-                  <a:txBody>
-                    <a:bodyPr wrap="square"/>
-                    <a:lstStyle/>
-                    <a:p>
-                      <a:pPr algn="ctr"/>
-                      <a:r>
-                        <a:rPr sz="700" b="1">
-                          <a:solidFill>
-                            <a:srgbClr val="22C55E"/>
-                          </a:solidFill>
-                          <a:latin typeface="Calibri"/>
-                        </a:rPr>
-                        <a:t>Terminado</a:t>
-                      </a:r>
-                    </a:p>
-                  </a:txBody>
-                  <a:tcPr>
-                    <a:solidFill>
-                      <a:srgbClr val="F5F7FA"/>
-                    </a:solidFill>
-                  </a:tcPr>
-                </a:tc>
-              </a:tr>
-              <a:tr h="196596">
-                <a:tc>
-                  <a:txBody>
-                    <a:bodyPr wrap="square"/>
-                    <a:lstStyle/>
-                    <a:p>
-                      <a:pPr algn="ctr"/>
-                      <a:r>
-                        <a:rPr sz="700" b="1">
-                          <a:solidFill>
-                            <a:srgbClr val="1A2340"/>
-                          </a:solidFill>
-                          <a:latin typeface="Calibri"/>
-                        </a:rPr>
-                        <a:t>Proyecto</a:t>
-                      </a:r>
-                    </a:p>
-                  </a:txBody>
-                  <a:tcPr>
-                    <a:solidFill>
-                      <a:srgbClr val="FFFFFF"/>
-                    </a:solidFill>
-                  </a:tcPr>
-                </a:tc>
-                <a:tc>
-                  <a:txBody>
-                    <a:bodyPr wrap="square"/>
-                    <a:lstStyle/>
-                    <a:p>
-                      <a:pPr algn="l"/>
-                      <a:r>
-                        <a:rPr sz="700" b="0">
-                          <a:solidFill>
-                            <a:srgbClr val="1A2340"/>
-                          </a:solidFill>
-                          <a:latin typeface="Calibri"/>
-                        </a:rPr>
-                        <a:t>Operaciones Fleet || Nueva Instancia</a:t>
-                      </a:r>
-                    </a:p>
-                  </a:txBody>
-                  <a:tcPr>
-                    <a:solidFill>
-                      <a:srgbClr val="FFFFFF"/>
-                    </a:solidFill>
-                  </a:tcPr>
-                </a:tc>
-                <a:tc>
-                  <a:txBody>
-                    <a:bodyPr wrap="square"/>
-                    <a:lstStyle/>
-                    <a:p>
-                      <a:pPr algn="ctr"/>
-                      <a:r>
-                        <a:rPr sz="700" b="0">
-                          <a:solidFill>
-                            <a:srgbClr val="555555"/>
-                          </a:solidFill>
-                          <a:latin typeface="Calibri"/>
-                        </a:rPr>
-                        <a:t>08/08/2025</a:t>
-                      </a:r>
-                    </a:p>
-                  </a:txBody>
-                  <a:tcPr>
-                    <a:solidFill>
-                      <a:srgbClr val="FFFFFF"/>
-                    </a:solidFill>
-                  </a:tcPr>
-                </a:tc>
-                <a:tc>
-                  <a:txBody>
-                    <a:bodyPr wrap="square"/>
-                    <a:lstStyle/>
-                    <a:p>
-                      <a:pPr algn="ctr"/>
-                      <a:r>
-                        <a:rPr sz="700" b="0">
-                          <a:solidFill>
-                            <a:srgbClr val="555555"/>
-                          </a:solidFill>
-                          <a:latin typeface="Calibri"/>
-                        </a:rPr>
-                        <a:t>01/06/2026</a:t>
-                      </a:r>
-                    </a:p>
-                  </a:txBody>
-                  <a:tcPr>
-                    <a:solidFill>
-                      <a:srgbClr val="FFFFFF"/>
-                    </a:solidFill>
-                  </a:tcPr>
-                </a:tc>
-                <a:tc>
-                  <a:txBody>
-                    <a:bodyPr wrap="square"/>
-                    <a:lstStyle/>
-                    <a:p>
-                      <a:pPr algn="ctr"/>
-                      <a:r>
-                        <a:rPr sz="700" b="1">
-                          <a:solidFill>
-                            <a:srgbClr val="1A2340"/>
-                          </a:solidFill>
-                          <a:latin typeface="Calibri"/>
-                        </a:rPr>
-                        <a:t>100%</a:t>
-                      </a:r>
-                    </a:p>
-                  </a:txBody>
-                  <a:tcPr>
-                    <a:solidFill>
-                      <a:srgbClr val="FFFFFF"/>
-                    </a:solidFill>
-                  </a:tcPr>
-                </a:tc>
-                <a:tc>
-                  <a:txBody>
-                    <a:bodyPr wrap="square"/>
-                    <a:lstStyle/>
-                    <a:p>
-                      <a:pPr algn="ctr"/>
-                      <a:r>
-                        <a:rPr sz="700" b="0">
-                          <a:solidFill>
-                            <a:srgbClr val="555555"/>
-                          </a:solidFill>
-                          <a:latin typeface="Calibri"/>
-                        </a:rPr>
-                        <a:t>100%</a:t>
-                      </a:r>
-                    </a:p>
-                  </a:txBody>
-                  <a:tcPr>
-                    <a:solidFill>
-                      <a:srgbClr val="FFFFFF"/>
-                    </a:solidFill>
-                  </a:tcPr>
-                </a:tc>
-                <a:tc>
-                  <a:txBody>
-                    <a:bodyPr wrap="square"/>
-                    <a:lstStyle/>
-                    <a:p>
-                      <a:pPr algn="r"/>
-                      <a:r>
-                        <a:rPr sz="700" b="1">
-                          <a:solidFill>
-                            <a:srgbClr val="22C55E"/>
-                          </a:solidFill>
-                          <a:latin typeface="Calibri"/>
-                        </a:rPr>
-                        <a:t>100%</a:t>
-                      </a:r>
-                    </a:p>
-                  </a:txBody>
-                  <a:tcPr>
-                    <a:solidFill>
-                      <a:srgbClr val="22C55E"/>
-                    </a:solidFill>
-                  </a:tcPr>
-                </a:tc>
-                <a:tc>
-                  <a:txBody>
-                    <a:bodyPr wrap="square"/>
-                    <a:lstStyle/>
-                    <a:p>
-                      <a:pPr algn="ctr"/>
-                      <a:r>
-                        <a:rPr sz="700" b="1">
-                          <a:solidFill>
-                            <a:srgbClr val="22C55E"/>
-                          </a:solidFill>
-                          <a:latin typeface="Calibri"/>
-                        </a:rPr>
-                        <a:t>Terminado</a:t>
-                      </a:r>
-                    </a:p>
-                  </a:txBody>
-                  <a:tcPr>
-                    <a:solidFill>
-                      <a:srgbClr val="FFFFFF"/>
-                    </a:solidFill>
-                  </a:tcPr>
-                </a:tc>
-              </a:tr>
-              <a:tr h="196596">
-                <a:tc>
-                  <a:txBody>
-                    <a:bodyPr wrap="square"/>
-                    <a:lstStyle/>
-                    <a:p>
-                      <a:pPr algn="ctr"/>
-                      <a:r>
-                        <a:rPr sz="700" b="1">
-                          <a:solidFill>
-                            <a:srgbClr val="1A2340"/>
-                          </a:solidFill>
-                          <a:latin typeface="Calibri"/>
-                        </a:rPr>
-                        <a:t>Proyecto</a:t>
-                      </a:r>
-                    </a:p>
-                  </a:txBody>
-                  <a:tcPr>
-                    <a:solidFill>
-                      <a:srgbClr val="F5F7FA"/>
-                    </a:solidFill>
-                  </a:tcPr>
-                </a:tc>
-                <a:tc>
-                  <a:txBody>
-                    <a:bodyPr wrap="square"/>
-                    <a:lstStyle/>
-                    <a:p>
-                      <a:pPr algn="l"/>
-                      <a:r>
-                        <a:rPr sz="700" b="0">
-                          <a:solidFill>
-                            <a:srgbClr val="1A2340"/>
-                          </a:solidFill>
-                          <a:latin typeface="Calibri"/>
-                        </a:rPr>
-                        <a:t>Tesoreria || Adcontent H2H</a:t>
-                      </a:r>
-                    </a:p>
-                  </a:txBody>
-                  <a:tcPr>
-                    <a:solidFill>
-                      <a:srgbClr val="F5F7FA"/>
-                    </a:solidFill>
-                  </a:tcPr>
-                </a:tc>
-                <a:tc>
-                  <a:txBody>
-                    <a:bodyPr wrap="square"/>
-                    <a:lstStyle/>
-                    <a:p>
-                      <a:pPr algn="ctr"/>
-                      <a:r>
-                        <a:rPr sz="700" b="0">
-                          <a:solidFill>
-                            <a:srgbClr val="555555"/>
-                          </a:solidFill>
-                          <a:latin typeface="Calibri"/>
-                        </a:rPr>
-                        <a:t>07/04/2026</a:t>
-                      </a:r>
-                    </a:p>
-                  </a:txBody>
-                  <a:tcPr>
-                    <a:solidFill>
-                      <a:srgbClr val="F5F7FA"/>
-                    </a:solidFill>
-                  </a:tcPr>
-                </a:tc>
-                <a:tc>
-                  <a:txBody>
-                    <a:bodyPr wrap="square"/>
-                    <a:lstStyle/>
-                    <a:p>
-                      <a:pPr algn="ctr"/>
-                      <a:r>
-                        <a:rPr sz="700" b="0">
-                          <a:solidFill>
-                            <a:srgbClr val="555555"/>
-                          </a:solidFill>
-                          <a:latin typeface="Calibri"/>
-                        </a:rPr>
-                        <a:t>26/08/2026</a:t>
-                      </a:r>
-                    </a:p>
-                  </a:txBody>
-                  <a:tcPr>
-                    <a:solidFill>
-                      <a:srgbClr val="F5F7FA"/>
-                    </a:solidFill>
-                  </a:tcPr>
-                </a:tc>
-                <a:tc>
-                  <a:txBody>
-                    <a:bodyPr wrap="square"/>
-                    <a:lstStyle/>
-                    <a:p>
-                      <a:pPr algn="ctr"/>
-                      <a:r>
-                        <a:rPr sz="700" b="1">
-                          <a:solidFill>
-                            <a:srgbClr val="1A2340"/>
-                          </a:solidFill>
-                          <a:latin typeface="Calibri"/>
-                        </a:rPr>
-                        <a:t>22%</a:t>
-                      </a:r>
-                    </a:p>
-                  </a:txBody>
-                  <a:tcPr>
-                    <a:solidFill>
-                      <a:srgbClr val="F5F7FA"/>
-                    </a:solidFill>
-                  </a:tcPr>
-                </a:tc>
-                <a:tc>
-                  <a:txBody>
-                    <a:bodyPr wrap="square"/>
-                    <a:lstStyle/>
-                    <a:p>
-                      <a:pPr algn="ctr"/>
-                      <a:r>
-                        <a:rPr sz="700" b="0">
-                          <a:solidFill>
-                            <a:srgbClr val="555555"/>
-                          </a:solidFill>
-                          <a:latin typeface="Calibri"/>
-                        </a:rPr>
-                        <a:t>58%</a:t>
-                      </a:r>
-                    </a:p>
-                  </a:txBody>
-                  <a:tcPr>
-                    <a:solidFill>
-                      <a:srgbClr val="F5F7FA"/>
-                    </a:solidFill>
-                  </a:tcPr>
-                </a:tc>
-                <a:tc>
-                  <a:txBody>
-                    <a:bodyPr wrap="square"/>
-                    <a:lstStyle/>
-                    <a:p>
-                      <a:pPr algn="r"/>
-                      <a:r>
-                        <a:rPr sz="700" b="1">
-                          <a:solidFill>
-                            <a:srgbClr val="EF4444"/>
-                          </a:solidFill>
-                          <a:latin typeface="Calibri"/>
-                        </a:rPr>
-                        <a:t>22%</a:t>
+                        <a:t>74%</a:t>
                       </a:r>
                     </a:p>
                   </a:txBody>
@@ -8946,210 +9718,10 @@
                     <a:gradFill>
                       <a:gsLst>
                         <a:gs pos="0">
-                          <a:srgbClr val="EF4444"/>
-                        </a:gs>
-                        <a:gs pos="22000">
-                          <a:srgbClr val="EF4444"/>
-                        </a:gs>
-                        <a:gs pos="22500">
-                          <a:srgbClr val="E2E2E2"/>
-                        </a:gs>
-                        <a:gs pos="100000">
-                          <a:srgbClr val="E2E2E2"/>
-                        </a:gs>
-                      </a:gsLst>
-                      <a:lin ang="0" scaled="0"/>
-                    </a:gradFill>
-                  </a:tcPr>
-                </a:tc>
-                <a:tc>
-                  <a:txBody>
-                    <a:bodyPr wrap="square"/>
-                    <a:lstStyle/>
-                    <a:p>
-                      <a:pPr algn="ctr"/>
-                      <a:r>
-                        <a:rPr sz="700" b="1">
-                          <a:solidFill>
-                            <a:srgbClr val="EF4444"/>
-                          </a:solidFill>
-                          <a:latin typeface="Calibri"/>
-                        </a:rPr>
-                        <a:t>Atrasado</a:t>
-                      </a:r>
-                    </a:p>
-                  </a:txBody>
-                  <a:tcPr>
-                    <a:solidFill>
-                      <a:srgbClr val="F5F7FA"/>
-                    </a:solidFill>
-                  </a:tcPr>
-                </a:tc>
-              </a:tr>
-              <a:tr h="196596">
-                <a:tc>
-                  <a:txBody>
-                    <a:bodyPr wrap="square"/>
-                    <a:lstStyle/>
-                    <a:p>
-                      <a:pPr algn="ctr"/>
-                      <a:r>
-                        <a:rPr sz="700" b="1">
-                          <a:solidFill>
-                            <a:srgbClr val="1A2340"/>
-                          </a:solidFill>
-                          <a:latin typeface="Calibri"/>
-                        </a:rPr>
-                        <a:t>Proyecto</a:t>
-                      </a:r>
-                    </a:p>
-                  </a:txBody>
-                  <a:tcPr>
-                    <a:solidFill>
-                      <a:srgbClr val="FFFFFF"/>
-                    </a:solidFill>
-                  </a:tcPr>
-                </a:tc>
-                <a:tc>
-                  <a:txBody>
-                    <a:bodyPr wrap="square"/>
-                    <a:lstStyle/>
-                    <a:p>
-                      <a:pPr algn="l"/>
-                      <a:r>
-                        <a:rPr sz="700" b="0">
-                          <a:solidFill>
-                            <a:srgbClr val="1A2340"/>
-                          </a:solidFill>
-                          <a:latin typeface="Calibri"/>
-                        </a:rPr>
-                        <a:t>Talleres || Integración Mecanica Mx - SAE</a:t>
-                      </a:r>
-                    </a:p>
-                  </a:txBody>
-                  <a:tcPr>
-                    <a:solidFill>
-                      <a:srgbClr val="FFFFFF"/>
-                    </a:solidFill>
-                  </a:tcPr>
-                </a:tc>
-                <a:tc>
-                  <a:txBody>
-                    <a:bodyPr wrap="square"/>
-                    <a:lstStyle/>
-                    <a:p>
-                      <a:pPr algn="ctr"/>
-                      <a:r>
-                        <a:rPr sz="700" b="0">
-                          <a:solidFill>
-                            <a:srgbClr val="555555"/>
-                          </a:solidFill>
-                          <a:latin typeface="Calibri"/>
-                        </a:rPr>
-                        <a:t>20/04/2026</a:t>
-                      </a:r>
-                    </a:p>
-                  </a:txBody>
-                  <a:tcPr>
-                    <a:solidFill>
-                      <a:srgbClr val="FFFFFF"/>
-                    </a:solidFill>
-                  </a:tcPr>
-                </a:tc>
-                <a:tc>
-                  <a:txBody>
-                    <a:bodyPr wrap="square"/>
-                    <a:lstStyle/>
-                    <a:p>
-                      <a:pPr algn="ctr"/>
-                      <a:r>
-                        <a:rPr sz="700" b="0">
-                          <a:solidFill>
-                            <a:srgbClr val="555555"/>
-                          </a:solidFill>
-                          <a:latin typeface="Calibri"/>
-                        </a:rPr>
-                        <a:t>20/07/2026</a:t>
-                      </a:r>
-                    </a:p>
-                  </a:txBody>
-                  <a:tcPr>
-                    <a:solidFill>
-                      <a:srgbClr val="FFFFFF"/>
-                    </a:solidFill>
-                  </a:tcPr>
-                </a:tc>
-                <a:tc>
-                  <a:txBody>
-                    <a:bodyPr wrap="square"/>
-                    <a:lstStyle/>
-                    <a:p>
-                      <a:pPr algn="ctr"/>
-                      <a:r>
-                        <a:rPr sz="700" b="1">
-                          <a:solidFill>
-                            <a:srgbClr val="1A2340"/>
-                          </a:solidFill>
-                          <a:latin typeface="Calibri"/>
-                        </a:rPr>
-                        <a:t>74%</a:t>
-                      </a:r>
-                    </a:p>
-                  </a:txBody>
-                  <a:tcPr>
-                    <a:solidFill>
-                      <a:srgbClr val="FFFFFF"/>
-                    </a:solidFill>
-                  </a:tcPr>
-                </a:tc>
-                <a:tc>
-                  <a:txBody>
-                    <a:bodyPr wrap="square"/>
-                    <a:lstStyle/>
-                    <a:p>
-                      <a:pPr algn="ctr"/>
-                      <a:r>
-                        <a:rPr sz="700" b="0">
-                          <a:solidFill>
-                            <a:srgbClr val="555555"/>
-                          </a:solidFill>
-                          <a:latin typeface="Calibri"/>
-                        </a:rPr>
-                        <a:t>76%</a:t>
-                      </a:r>
-                    </a:p>
-                  </a:txBody>
-                  <a:tcPr>
-                    <a:solidFill>
-                      <a:srgbClr val="FFFFFF"/>
-                    </a:solidFill>
-                  </a:tcPr>
-                </a:tc>
-                <a:tc>
-                  <a:txBody>
-                    <a:bodyPr wrap="square"/>
-                    <a:lstStyle/>
-                    <a:p>
-                      <a:pPr algn="r"/>
-                      <a:r>
-                        <a:rPr sz="700" b="1">
-                          <a:solidFill>
-                            <a:srgbClr val="F59E0B"/>
-                          </a:solidFill>
-                          <a:latin typeface="Calibri"/>
-                        </a:rPr>
-                        <a:t>74%</a:t>
-                      </a:r>
-                    </a:p>
-                  </a:txBody>
-                  <a:tcPr>
-                    <a:gradFill>
-                      <a:gsLst>
-                        <a:gs pos="0">
-                          <a:srgbClr val="F59E0B"/>
+                          <a:srgbClr val="22C55E"/>
                         </a:gs>
                         <a:gs pos="74000">
-                          <a:srgbClr val="F59E0B"/>
+                          <a:srgbClr val="22C55E"/>
                         </a:gs>
                         <a:gs pos="74500">
                           <a:srgbClr val="E2E2E2"/>
@@ -9171,17 +9743,17 @@
                       <a:r>
                         <a:rPr sz="700" b="1">
                           <a:solidFill>
-                            <a:srgbClr val="F59E0B"/>
-                          </a:solidFill>
-                          <a:latin typeface="Calibri"/>
-                        </a:rPr>
-                        <a:t>Riesgo de atraso</a:t>
-                      </a:r>
-                    </a:p>
-                  </a:txBody>
-                  <a:tcPr>
-                    <a:solidFill>
-                      <a:srgbClr val="FFFFFF"/>
+                            <a:srgbClr val="22C55E"/>
+                          </a:solidFill>
+                          <a:latin typeface="Calibri"/>
+                        </a:rPr>
+                        <a:t>A tiempo</a:t>
+                      </a:r>
+                    </a:p>
+                  </a:txBody>
+                  <a:tcPr>
+                    <a:solidFill>
+                      <a:srgbClr val="F5F7FA"/>
                     </a:solidFill>
                   </a:tcPr>
                 </a:tc>
@@ -9206,7 +9778,7 @@
                   </a:txBody>
                   <a:tcPr>
                     <a:solidFill>
-                      <a:srgbClr val="F5F7FA"/>
+                      <a:srgbClr val="FFFFFF"/>
                     </a:solidFill>
                   </a:tcPr>
                 </a:tc>
@@ -9223,13 +9795,13 @@
                           </a:solidFill>
                           <a:latin typeface="Calibri"/>
                         </a:rPr>
-                        <a:t>Contabilidad || Integración Mecanica-SAE (Fase 2)</a:t>
-                      </a:r>
-                    </a:p>
-                  </a:txBody>
-                  <a:tcPr>
-                    <a:solidFill>
-                      <a:srgbClr val="F5F7FA"/>
+                        <a:t>Operaciones Fleet || Adcontent - Sfleet</a:t>
+                      </a:r>
+                    </a:p>
+                  </a:txBody>
+                  <a:tcPr>
+                    <a:solidFill>
+                      <a:srgbClr val="FFFFFF"/>
                     </a:solidFill>
                   </a:tcPr>
                 </a:tc>
@@ -9246,13 +9818,13 @@
                           </a:solidFill>
                           <a:latin typeface="Calibri"/>
                         </a:rPr>
-                        <a:t>21/04/2026</a:t>
-                      </a:r>
-                    </a:p>
-                  </a:txBody>
-                  <a:tcPr>
-                    <a:solidFill>
-                      <a:srgbClr val="F5F7FA"/>
+                        <a:t>15/06/2026</a:t>
+                      </a:r>
+                    </a:p>
+                  </a:txBody>
+                  <a:tcPr>
+                    <a:solidFill>
+                      <a:srgbClr val="FFFFFF"/>
                     </a:solidFill>
                   </a:tcPr>
                 </a:tc>
@@ -9269,13 +9841,13 @@
                           </a:solidFill>
                           <a:latin typeface="Calibri"/>
                         </a:rPr>
-                        <a:t>12/06/2026</a:t>
-                      </a:r>
-                    </a:p>
-                  </a:txBody>
-                  <a:tcPr>
-                    <a:solidFill>
-                      <a:srgbClr val="F5F7FA"/>
+                        <a:t>08/02/2027</a:t>
+                      </a:r>
+                    </a:p>
+                  </a:txBody>
+                  <a:tcPr>
+                    <a:solidFill>
+                      <a:srgbClr val="FFFFFF"/>
                     </a:solidFill>
                   </a:tcPr>
                 </a:tc>
@@ -9292,13 +9864,13 @@
                           </a:solidFill>
                           <a:latin typeface="Calibri"/>
                         </a:rPr>
-                        <a:t>99%</a:t>
-                      </a:r>
-                    </a:p>
-                  </a:txBody>
-                  <a:tcPr>
-                    <a:solidFill>
-                      <a:srgbClr val="F5F7FA"/>
+                        <a:t>4%</a:t>
+                      </a:r>
+                    </a:p>
+                  </a:txBody>
+                  <a:tcPr>
+                    <a:solidFill>
+                      <a:srgbClr val="FFFFFF"/>
                     </a:solidFill>
                   </a:tcPr>
                 </a:tc>
@@ -9315,13 +9887,13 @@
                           </a:solidFill>
                           <a:latin typeface="Calibri"/>
                         </a:rPr>
-                        <a:t>100%</a:t>
-                      </a:r>
-                    </a:p>
-                  </a:txBody>
-                  <a:tcPr>
-                    <a:solidFill>
-                      <a:srgbClr val="F5F7FA"/>
+                        <a:t>8%</a:t>
+                      </a:r>
+                    </a:p>
+                  </a:txBody>
+                  <a:tcPr>
+                    <a:solidFill>
+                      <a:srgbClr val="FFFFFF"/>
                     </a:solidFill>
                   </a:tcPr>
                 </a:tc>
@@ -9334,11 +9906,11 @@
                       <a:r>
                         <a:rPr sz="700" b="1">
                           <a:solidFill>
-                            <a:srgbClr val="EF4444"/>
-                          </a:solidFill>
-                          <a:latin typeface="Calibri"/>
-                        </a:rPr>
-                        <a:t>99%</a:t>
+                            <a:srgbClr val="F59E0B"/>
+                          </a:solidFill>
+                          <a:latin typeface="Calibri"/>
+                        </a:rPr>
+                        <a:t>4%</a:t>
                       </a:r>
                     </a:p>
                   </a:txBody>
@@ -9346,12 +9918,12 @@
                     <a:gradFill>
                       <a:gsLst>
                         <a:gs pos="0">
-                          <a:srgbClr val="EF4444"/>
+                          <a:srgbClr val="F59E0B"/>
                         </a:gs>
-                        <a:gs pos="99000">
-                          <a:srgbClr val="EF4444"/>
+                        <a:gs pos="4000">
+                          <a:srgbClr val="F59E0B"/>
                         </a:gs>
-                        <a:gs pos="99500">
+                        <a:gs pos="4500">
                           <a:srgbClr val="E2E2E2"/>
                         </a:gs>
                         <a:gs pos="100000">
@@ -9371,211 +9943,11 @@
                       <a:r>
                         <a:rPr sz="700" b="1">
                           <a:solidFill>
-                            <a:srgbClr val="EF4444"/>
-                          </a:solidFill>
-                          <a:latin typeface="Calibri"/>
-                        </a:rPr>
-                        <a:t>Atrasado</a:t>
-                      </a:r>
-                    </a:p>
-                  </a:txBody>
-                  <a:tcPr>
-                    <a:solidFill>
-                      <a:srgbClr val="F5F7FA"/>
-                    </a:solidFill>
-                  </a:tcPr>
-                </a:tc>
-              </a:tr>
-              <a:tr h="196596">
-                <a:tc>
-                  <a:txBody>
-                    <a:bodyPr wrap="square"/>
-                    <a:lstStyle/>
-                    <a:p>
-                      <a:pPr algn="ctr"/>
-                      <a:r>
-                        <a:rPr sz="700" b="1">
-                          <a:solidFill>
-                            <a:srgbClr val="1A2340"/>
-                          </a:solidFill>
-                          <a:latin typeface="Calibri"/>
-                        </a:rPr>
-                        <a:t>Proyecto</a:t>
-                      </a:r>
-                    </a:p>
-                  </a:txBody>
-                  <a:tcPr>
-                    <a:solidFill>
-                      <a:srgbClr val="FFFFFF"/>
-                    </a:solidFill>
-                  </a:tcPr>
-                </a:tc>
-                <a:tc>
-                  <a:txBody>
-                    <a:bodyPr wrap="square"/>
-                    <a:lstStyle/>
-                    <a:p>
-                      <a:pPr algn="l"/>
-                      <a:r>
-                        <a:rPr sz="700" b="0">
-                          <a:solidFill>
-                            <a:srgbClr val="1A2340"/>
-                          </a:solidFill>
-                          <a:latin typeface="Calibri"/>
-                        </a:rPr>
-                        <a:t>Capital Humano || BUK Personalizados Fase 2</a:t>
-                      </a:r>
-                    </a:p>
-                  </a:txBody>
-                  <a:tcPr>
-                    <a:solidFill>
-                      <a:srgbClr val="FFFFFF"/>
-                    </a:solidFill>
-                  </a:tcPr>
-                </a:tc>
-                <a:tc>
-                  <a:txBody>
-                    <a:bodyPr wrap="square"/>
-                    <a:lstStyle/>
-                    <a:p>
-                      <a:pPr algn="ctr"/>
-                      <a:r>
-                        <a:rPr sz="700" b="0">
-                          <a:solidFill>
-                            <a:srgbClr val="555555"/>
-                          </a:solidFill>
-                          <a:latin typeface="Calibri"/>
-                        </a:rPr>
-                        <a:t>08/06/2026</a:t>
-                      </a:r>
-                    </a:p>
-                  </a:txBody>
-                  <a:tcPr>
-                    <a:solidFill>
-                      <a:srgbClr val="FFFFFF"/>
-                    </a:solidFill>
-                  </a:tcPr>
-                </a:tc>
-                <a:tc>
-                  <a:txBody>
-                    <a:bodyPr wrap="square"/>
-                    <a:lstStyle/>
-                    <a:p>
-                      <a:pPr algn="ctr"/>
-                      <a:r>
-                        <a:rPr sz="700" b="0">
-                          <a:solidFill>
-                            <a:srgbClr val="555555"/>
-                          </a:solidFill>
-                          <a:latin typeface="Calibri"/>
-                        </a:rPr>
-                        <a:t>11/08/2026</a:t>
-                      </a:r>
-                    </a:p>
-                  </a:txBody>
-                  <a:tcPr>
-                    <a:solidFill>
-                      <a:srgbClr val="FFFFFF"/>
-                    </a:solidFill>
-                  </a:tcPr>
-                </a:tc>
-                <a:tc>
-                  <a:txBody>
-                    <a:bodyPr wrap="square"/>
-                    <a:lstStyle/>
-                    <a:p>
-                      <a:pPr algn="ctr"/>
-                      <a:r>
-                        <a:rPr sz="700" b="1">
-                          <a:solidFill>
-                            <a:srgbClr val="1A2340"/>
-                          </a:solidFill>
-                          <a:latin typeface="Calibri"/>
-                        </a:rPr>
-                        <a:t>39%</a:t>
-                      </a:r>
-                    </a:p>
-                  </a:txBody>
-                  <a:tcPr>
-                    <a:solidFill>
-                      <a:srgbClr val="FFFFFF"/>
-                    </a:solidFill>
-                  </a:tcPr>
-                </a:tc>
-                <a:tc>
-                  <a:txBody>
-                    <a:bodyPr wrap="square"/>
-                    <a:lstStyle/>
-                    <a:p>
-                      <a:pPr algn="ctr"/>
-                      <a:r>
-                        <a:rPr sz="700" b="0">
-                          <a:solidFill>
-                            <a:srgbClr val="555555"/>
-                          </a:solidFill>
-                          <a:latin typeface="Calibri"/>
-                        </a:rPr>
-                        <a:t>32%</a:t>
-                      </a:r>
-                    </a:p>
-                  </a:txBody>
-                  <a:tcPr>
-                    <a:solidFill>
-                      <a:srgbClr val="FFFFFF"/>
-                    </a:solidFill>
-                  </a:tcPr>
-                </a:tc>
-                <a:tc>
-                  <a:txBody>
-                    <a:bodyPr wrap="square"/>
-                    <a:lstStyle/>
-                    <a:p>
-                      <a:pPr algn="r"/>
-                      <a:r>
-                        <a:rPr sz="700" b="1">
-                          <a:solidFill>
-                            <a:srgbClr val="22C55E"/>
-                          </a:solidFill>
-                          <a:latin typeface="Calibri"/>
-                        </a:rPr>
-                        <a:t>39%</a:t>
-                      </a:r>
-                    </a:p>
-                  </a:txBody>
-                  <a:tcPr>
-                    <a:gradFill>
-                      <a:gsLst>
-                        <a:gs pos="0">
-                          <a:srgbClr val="22C55E"/>
-                        </a:gs>
-                        <a:gs pos="39000">
-                          <a:srgbClr val="22C55E"/>
-                        </a:gs>
-                        <a:gs pos="39500">
-                          <a:srgbClr val="E2E2E2"/>
-                        </a:gs>
-                        <a:gs pos="100000">
-                          <a:srgbClr val="E2E2E2"/>
-                        </a:gs>
-                      </a:gsLst>
-                      <a:lin ang="0" scaled="0"/>
-                    </a:gradFill>
-                  </a:tcPr>
-                </a:tc>
-                <a:tc>
-                  <a:txBody>
-                    <a:bodyPr wrap="square"/>
-                    <a:lstStyle/>
-                    <a:p>
-                      <a:pPr algn="ctr"/>
-                      <a:r>
-                        <a:rPr sz="700" b="1">
-                          <a:solidFill>
-                            <a:srgbClr val="22C55E"/>
-                          </a:solidFill>
-                          <a:latin typeface="Calibri"/>
-                        </a:rPr>
-                        <a:t>A tiempo</a:t>
+                            <a:srgbClr val="F59E0B"/>
+                          </a:solidFill>
+                          <a:latin typeface="Calibri"/>
+                        </a:rPr>
+                        <a:t>Riesgo de atraso</a:t>
                       </a:r>
                     </a:p>
                   </a:txBody>
@@ -9658,7 +10030,7 @@
               <a:rPr lang="es-MX" b="1" dirty="0">
                 <a:latin typeface="Aptos (cuerpo)"/>
               </a:rPr>
-              <a:t>Eventualidades de proyectos con atraso</a:t>
+              <a:t>Eventualidades de proyectos con retraso</a:t>
             </a:r>
             <a:endParaRPr lang="es-MX" b="1" dirty="0">
               <a:highlight>
@@ -9726,12 +10098,14 @@
                         <a:buNone/>
                       </a:pPr>
                       <a:r>
-                        <a:rPr lang="es-MX" sz="1100" b="1" u="none" strike="noStrike" kern="1200">
+                        <a:rPr lang="es-MX" sz="1100" u="none" strike="noStrike" kern="1200">
                           <a:solidFill>
                             <a:schemeClr val="tx1"/>
                           </a:solidFill>
                           <a:effectLst/>
                           <a:latin typeface="Aptos (cuerpo)"/>
+                          <a:ea typeface="+mn-ea"/>
+                          <a:cs typeface="+mn-cs"/>
                         </a:rPr>
                         <a:t>No</a:t>
                       </a:r>
@@ -9743,24 +10117,36 @@
                         <a:schemeClr val="tx1"/>
                       </a:solidFill>
                       <a:prstDash val="solid"/>
+                      <a:round/>
+                      <a:headEnd type="none" w="med" len="med"/>
+                      <a:tailEnd type="none" w="med" len="med"/>
                     </a:lnL>
                     <a:lnR w="12700" cap="flat" cmpd="sng" algn="ctr">
                       <a:solidFill>
                         <a:schemeClr val="tx1"/>
                       </a:solidFill>
                       <a:prstDash val="solid"/>
+                      <a:round/>
+                      <a:headEnd type="none" w="med" len="med"/>
+                      <a:tailEnd type="none" w="med" len="med"/>
                     </a:lnR>
                     <a:lnT w="12700" cap="flat" cmpd="sng" algn="ctr">
                       <a:solidFill>
                         <a:schemeClr val="tx1"/>
                       </a:solidFill>
                       <a:prstDash val="solid"/>
+                      <a:round/>
+                      <a:headEnd type="none" w="med" len="med"/>
+                      <a:tailEnd type="none" w="med" len="med"/>
                     </a:lnT>
                     <a:lnB w="12700" cap="flat" cmpd="sng" algn="ctr">
                       <a:solidFill>
                         <a:schemeClr val="tx1"/>
                       </a:solidFill>
                       <a:prstDash val="solid"/>
+                      <a:round/>
+                      <a:headEnd type="none" w="med" len="med"/>
+                      <a:tailEnd type="none" w="med" len="med"/>
                     </a:lnB>
                     <a:noFill/>
                   </a:tcPr>
@@ -9774,12 +10160,14 @@
                         <a:buNone/>
                       </a:pPr>
                       <a:r>
-                        <a:rPr lang="es-MX" sz="1100" b="1" u="none" strike="noStrike" kern="1200">
+                        <a:rPr lang="es-MX" sz="1100" u="none" strike="noStrike" kern="1200">
                           <a:solidFill>
                             <a:schemeClr val="tx1"/>
                           </a:solidFill>
                           <a:effectLst/>
                           <a:latin typeface="Aptos (cuerpo)"/>
+                          <a:ea typeface="+mn-ea"/>
+                          <a:cs typeface="+mn-cs"/>
                         </a:rPr>
                         <a:t>Proyecto</a:t>
                       </a:r>
@@ -9791,24 +10179,36 @@
                         <a:schemeClr val="tx1"/>
                       </a:solidFill>
                       <a:prstDash val="solid"/>
+                      <a:round/>
+                      <a:headEnd type="none" w="med" len="med"/>
+                      <a:tailEnd type="none" w="med" len="med"/>
                     </a:lnL>
                     <a:lnR w="12700" cap="flat" cmpd="sng" algn="ctr">
                       <a:solidFill>
                         <a:schemeClr val="tx1"/>
                       </a:solidFill>
                       <a:prstDash val="solid"/>
+                      <a:round/>
+                      <a:headEnd type="none" w="med" len="med"/>
+                      <a:tailEnd type="none" w="med" len="med"/>
                     </a:lnR>
                     <a:lnT w="12700" cap="flat" cmpd="sng" algn="ctr">
                       <a:solidFill>
                         <a:schemeClr val="tx1"/>
                       </a:solidFill>
                       <a:prstDash val="solid"/>
+                      <a:round/>
+                      <a:headEnd type="none" w="med" len="med"/>
+                      <a:tailEnd type="none" w="med" len="med"/>
                     </a:lnT>
                     <a:lnB w="12700" cap="flat" cmpd="sng" algn="ctr">
                       <a:solidFill>
                         <a:schemeClr val="tx1"/>
                       </a:solidFill>
                       <a:prstDash val="solid"/>
+                      <a:round/>
+                      <a:headEnd type="none" w="med" len="med"/>
+                      <a:tailEnd type="none" w="med" len="med"/>
                     </a:lnB>
                     <a:noFill/>
                   </a:tcPr>
@@ -9818,16 +10218,18 @@
                     <a:bodyPr/>
                     <a:lstStyle/>
                     <a:p>
-                      <a:pPr marL="0" algn="ctr" defTabSz="457200" rtl="0" eaLnBrk="1" fontAlgn="b" latinLnBrk="0" hangingPunct="1">
+                      <a:pPr algn="ctr" fontAlgn="b">
                         <a:buNone/>
                       </a:pPr>
                       <a:r>
-                        <a:rPr lang="es-MX" sz="1100" b="1" u="none" strike="noStrike" kern="1200">
+                        <a:rPr lang="es-MX" sz="1100" u="none" strike="noStrike" kern="1200">
                           <a:solidFill>
                             <a:schemeClr val="tx1"/>
                           </a:solidFill>
                           <a:effectLst/>
                           <a:latin typeface="Aptos (cuerpo)"/>
+                          <a:ea typeface="+mn-ea"/>
+                          <a:cs typeface="+mn-cs"/>
                         </a:rPr>
                         <a:t>Eventualidades</a:t>
                       </a:r>
@@ -9839,40 +10241,57 @@
                         <a:schemeClr val="tx1"/>
                       </a:solidFill>
                       <a:prstDash val="solid"/>
+                      <a:round/>
+                      <a:headEnd type="none" w="med" len="med"/>
+                      <a:tailEnd type="none" w="med" len="med"/>
                     </a:lnL>
                     <a:lnR w="12700" cap="flat" cmpd="sng" algn="ctr">
                       <a:solidFill>
                         <a:schemeClr val="tx1"/>
                       </a:solidFill>
                       <a:prstDash val="solid"/>
+                      <a:round/>
+                      <a:headEnd type="none" w="med" len="med"/>
+                      <a:tailEnd type="none" w="med" len="med"/>
                     </a:lnR>
                     <a:lnT w="12700" cap="flat" cmpd="sng" algn="ctr">
                       <a:solidFill>
                         <a:schemeClr val="tx1"/>
                       </a:solidFill>
                       <a:prstDash val="solid"/>
+                      <a:round/>
+                      <a:headEnd type="none" w="med" len="med"/>
+                      <a:tailEnd type="none" w="med" len="med"/>
                     </a:lnT>
                     <a:lnB w="12700" cap="flat" cmpd="sng" algn="ctr">
                       <a:solidFill>
                         <a:schemeClr val="tx1"/>
                       </a:solidFill>
                       <a:prstDash val="solid"/>
+                      <a:round/>
+                      <a:headEnd type="none" w="med" len="med"/>
+                      <a:tailEnd type="none" w="med" len="med"/>
                     </a:lnB>
                     <a:noFill/>
                   </a:tcPr>
                 </a:tc>
+                <a:extLst>
+                  <a:ext uri="{0D108BD9-81ED-4DB2-BD59-A6C34878D82A}">
+                    <a16:rowId xmlns:a16="http://schemas.microsoft.com/office/drawing/2014/main" val="4174057675"/>
+                  </a:ext>
+                </a:extLst>
               </a:tr>
-              <a:tr h="420000">
+              <a:tr h="349144">
                 <a:tc>
                   <a:txBody>
                     <a:bodyPr/>
                     <a:lstStyle/>
                     <a:p>
-                      <a:pPr marL="0" algn="ctr" defTabSz="457200" rtl="0" eaLnBrk="1" fontAlgn="b" latinLnBrk="0" hangingPunct="1">
+                      <a:pPr algn="ctr" fontAlgn="b">
                         <a:buNone/>
                       </a:pPr>
                       <a:r>
-                        <a:rPr lang="es-MX" sz="1000" u="none" strike="noStrike" kern="1200">
+                        <a:rPr lang="es-MX" sz="1100" b="0" i="0" u="none" strike="noStrike">
                           <a:solidFill>
                             <a:schemeClr val="tx1"/>
                           </a:solidFill>
@@ -9889,24 +10308,36 @@
                         <a:schemeClr val="tx1"/>
                       </a:solidFill>
                       <a:prstDash val="solid"/>
+                      <a:round/>
+                      <a:headEnd type="none" w="med" len="med"/>
+                      <a:tailEnd type="none" w="med" len="med"/>
                     </a:lnL>
                     <a:lnR w="12700" cap="flat" cmpd="sng" algn="ctr">
                       <a:solidFill>
                         <a:schemeClr val="tx1"/>
                       </a:solidFill>
                       <a:prstDash val="solid"/>
+                      <a:round/>
+                      <a:headEnd type="none" w="med" len="med"/>
+                      <a:tailEnd type="none" w="med" len="med"/>
                     </a:lnR>
                     <a:lnT w="12700" cap="flat" cmpd="sng" algn="ctr">
                       <a:solidFill>
                         <a:schemeClr val="tx1"/>
                       </a:solidFill>
                       <a:prstDash val="solid"/>
+                      <a:round/>
+                      <a:headEnd type="none" w="med" len="med"/>
+                      <a:tailEnd type="none" w="med" len="med"/>
                     </a:lnT>
                     <a:lnB w="12700" cap="flat" cmpd="sng" algn="ctr">
                       <a:solidFill>
                         <a:schemeClr val="tx1"/>
                       </a:solidFill>
                       <a:prstDash val="solid"/>
+                      <a:round/>
+                      <a:headEnd type="none" w="med" len="med"/>
+                      <a:tailEnd type="none" w="med" len="med"/>
                     </a:lnB>
                     <a:noFill/>
                   </a:tcPr>
@@ -9916,19 +10347,40 @@
                     <a:bodyPr/>
                     <a:lstStyle/>
                     <a:p>
-                      <a:pPr marL="0" algn="l" defTabSz="457200" rtl="0" eaLnBrk="1" fontAlgn="b" latinLnBrk="0" hangingPunct="1">
+                      <a:pPr marL="0" marR="0" lvl="0" indent="0" algn="l" defTabSz="685800" rtl="0" eaLnBrk="1" fontAlgn="b" latinLnBrk="0" hangingPunct="1">
+                        <a:lnSpc>
+                          <a:spcPct val="100000"/>
+                        </a:lnSpc>
+                        <a:spcBef>
+                          <a:spcPts val="0"/>
+                        </a:spcBef>
+                        <a:spcAft>
+                          <a:spcPts val="0"/>
+                        </a:spcAft>
+                        <a:buClrTx/>
+                        <a:buSzTx/>
+                        <a:buFontTx/>
                         <a:buNone/>
+                        <a:tabLst/>
+                        <a:defRPr/>
                       </a:pPr>
                       <a:r>
-                        <a:rPr lang="es-MX" sz="1000" u="none" strike="noStrike" kern="1200">
+                        <a:rPr lang="es-MX" sz="1100" u="none" strike="noStrike">
                           <a:solidFill>
                             <a:schemeClr val="tx1"/>
                           </a:solidFill>
                           <a:effectLst/>
                           <a:latin typeface="Aptos (cuerpo)"/>
                         </a:rPr>
-                        <a:t>Tesoreria || Adcontent H2H</a:t>
-                      </a:r>
+                        <a:t>Cartera || Cambio de PAC de timbrado (ATEB)</a:t>
+                      </a:r>
+                      <a:endParaRPr lang="es-MX" sz="1100" b="0" i="0" u="none" strike="noStrike">
+                        <a:solidFill>
+                          <a:schemeClr val="tx1"/>
+                        </a:solidFill>
+                        <a:effectLst/>
+                        <a:latin typeface="Aptos (cuerpo)"/>
+                      </a:endParaRPr>
                     </a:p>
                   </a:txBody>
                   <a:tcPr marL="6244" marR="6244" marT="6244" marB="0" anchor="ctr">
@@ -9937,24 +10389,36 @@
                         <a:schemeClr val="tx1"/>
                       </a:solidFill>
                       <a:prstDash val="solid"/>
+                      <a:round/>
+                      <a:headEnd type="none" w="med" len="med"/>
+                      <a:tailEnd type="none" w="med" len="med"/>
                     </a:lnL>
                     <a:lnR w="12700" cap="flat" cmpd="sng" algn="ctr">
                       <a:solidFill>
                         <a:schemeClr val="tx1"/>
                       </a:solidFill>
                       <a:prstDash val="solid"/>
+                      <a:round/>
+                      <a:headEnd type="none" w="med" len="med"/>
+                      <a:tailEnd type="none" w="med" len="med"/>
                     </a:lnR>
                     <a:lnT w="12700" cap="flat" cmpd="sng" algn="ctr">
                       <a:solidFill>
                         <a:schemeClr val="tx1"/>
                       </a:solidFill>
                       <a:prstDash val="solid"/>
+                      <a:round/>
+                      <a:headEnd type="none" w="med" len="med"/>
+                      <a:tailEnd type="none" w="med" len="med"/>
                     </a:lnT>
                     <a:lnB w="12700" cap="flat" cmpd="sng" algn="ctr">
                       <a:solidFill>
                         <a:schemeClr val="tx1"/>
                       </a:solidFill>
                       <a:prstDash val="solid"/>
+                      <a:round/>
+                      <a:headEnd type="none" w="med" len="med"/>
+                      <a:tailEnd type="none" w="med" len="med"/>
                     </a:lnB>
                     <a:noFill/>
                   </a:tcPr>
@@ -9964,18 +10428,18 @@
                     <a:bodyPr/>
                     <a:lstStyle/>
                     <a:p>
-                      <a:pPr marL="0" algn="l" defTabSz="457200" rtl="0" eaLnBrk="1" fontAlgn="b" latinLnBrk="0" hangingPunct="1">
+                      <a:pPr algn="l" fontAlgn="b">
                         <a:buNone/>
                       </a:pPr>
                       <a:r>
-                        <a:rPr lang="es-MX" sz="1000" u="none" strike="noStrike" kern="1200">
+                        <a:rPr lang="es-MX" sz="1100" b="0" i="0" u="none" strike="noStrike">
                           <a:solidFill>
                             <a:schemeClr val="tx1"/>
                           </a:solidFill>
                           <a:effectLst/>
                           <a:latin typeface="Aptos (cuerpo)"/>
                         </a:rPr>
-                        <a:t>eventualdiad</a:t>
+                        <a:t>Pendiente de Firma de convenio de Lumo, Firma de AyO pendiente de firma de Representante Legal</a:t>
                       </a:r>
                     </a:p>
                   </a:txBody>
@@ -9985,40 +10449,57 @@
                         <a:schemeClr val="tx1"/>
                       </a:solidFill>
                       <a:prstDash val="solid"/>
+                      <a:round/>
+                      <a:headEnd type="none" w="med" len="med"/>
+                      <a:tailEnd type="none" w="med" len="med"/>
                     </a:lnL>
                     <a:lnR w="12700" cap="flat" cmpd="sng" algn="ctr">
                       <a:solidFill>
                         <a:schemeClr val="tx1"/>
                       </a:solidFill>
                       <a:prstDash val="solid"/>
+                      <a:round/>
+                      <a:headEnd type="none" w="med" len="med"/>
+                      <a:tailEnd type="none" w="med" len="med"/>
                     </a:lnR>
                     <a:lnT w="12700" cap="flat" cmpd="sng" algn="ctr">
                       <a:solidFill>
                         <a:schemeClr val="tx1"/>
                       </a:solidFill>
                       <a:prstDash val="solid"/>
+                      <a:round/>
+                      <a:headEnd type="none" w="med" len="med"/>
+                      <a:tailEnd type="none" w="med" len="med"/>
                     </a:lnT>
                     <a:lnB w="12700" cap="flat" cmpd="sng" algn="ctr">
                       <a:solidFill>
                         <a:schemeClr val="tx1"/>
                       </a:solidFill>
                       <a:prstDash val="solid"/>
+                      <a:round/>
+                      <a:headEnd type="none" w="med" len="med"/>
+                      <a:tailEnd type="none" w="med" len="med"/>
                     </a:lnB>
                     <a:noFill/>
                   </a:tcPr>
                 </a:tc>
+                <a:extLst>
+                  <a:ext uri="{0D108BD9-81ED-4DB2-BD59-A6C34878D82A}">
+                    <a16:rowId xmlns:a16="http://schemas.microsoft.com/office/drawing/2014/main" val="3248437908"/>
+                  </a:ext>
+                </a:extLst>
               </a:tr>
-              <a:tr h="420000">
+              <a:tr h="520594">
                 <a:tc>
                   <a:txBody>
                     <a:bodyPr/>
                     <a:lstStyle/>
                     <a:p>
-                      <a:pPr marL="0" algn="ctr" defTabSz="457200" rtl="0" eaLnBrk="1" fontAlgn="b" latinLnBrk="0" hangingPunct="1">
+                      <a:pPr algn="ctr" fontAlgn="b">
                         <a:buNone/>
                       </a:pPr>
                       <a:r>
-                        <a:rPr lang="es-MX" sz="1000" u="none" strike="noStrike" kern="1200">
+                        <a:rPr lang="es-ES" sz="1100" b="0" i="0" u="none" strike="noStrike">
                           <a:solidFill>
                             <a:schemeClr val="tx1"/>
                           </a:solidFill>
@@ -10027,6 +10508,13 @@
                         </a:rPr>
                         <a:t>2</a:t>
                       </a:r>
+                      <a:endParaRPr lang="es-MX" sz="1100" b="0" i="0" u="none" strike="noStrike">
+                        <a:solidFill>
+                          <a:schemeClr val="tx1"/>
+                        </a:solidFill>
+                        <a:effectLst/>
+                        <a:latin typeface="Aptos (cuerpo)"/>
+                      </a:endParaRPr>
                     </a:p>
                   </a:txBody>
                   <a:tcPr marL="6244" marR="6244" marT="6244" marB="0" anchor="ctr">
@@ -10035,24 +10523,36 @@
                         <a:schemeClr val="tx1"/>
                       </a:solidFill>
                       <a:prstDash val="solid"/>
+                      <a:round/>
+                      <a:headEnd type="none" w="med" len="med"/>
+                      <a:tailEnd type="none" w="med" len="med"/>
                     </a:lnL>
                     <a:lnR w="12700" cap="flat" cmpd="sng" algn="ctr">
                       <a:solidFill>
                         <a:schemeClr val="tx1"/>
                       </a:solidFill>
                       <a:prstDash val="solid"/>
+                      <a:round/>
+                      <a:headEnd type="none" w="med" len="med"/>
+                      <a:tailEnd type="none" w="med" len="med"/>
                     </a:lnR>
                     <a:lnT w="12700" cap="flat" cmpd="sng" algn="ctr">
                       <a:solidFill>
                         <a:schemeClr val="tx1"/>
                       </a:solidFill>
                       <a:prstDash val="solid"/>
+                      <a:round/>
+                      <a:headEnd type="none" w="med" len="med"/>
+                      <a:tailEnd type="none" w="med" len="med"/>
                     </a:lnT>
                     <a:lnB w="12700" cap="flat" cmpd="sng" algn="ctr">
                       <a:solidFill>
                         <a:schemeClr val="tx1"/>
                       </a:solidFill>
                       <a:prstDash val="solid"/>
+                      <a:round/>
+                      <a:headEnd type="none" w="med" len="med"/>
+                      <a:tailEnd type="none" w="med" len="med"/>
                     </a:lnB>
                     <a:noFill/>
                   </a:tcPr>
@@ -10062,18 +10562,20 @@
                     <a:bodyPr/>
                     <a:lstStyle/>
                     <a:p>
-                      <a:pPr marL="0" algn="l" defTabSz="457200" rtl="0" eaLnBrk="1" fontAlgn="b" latinLnBrk="0" hangingPunct="1">
+                      <a:pPr algn="l" fontAlgn="b">
                         <a:buNone/>
                       </a:pPr>
                       <a:r>
-                        <a:rPr lang="es-MX" sz="1000" u="none" strike="noStrike" kern="1200">
+                        <a:rPr lang="es-MX" sz="1100" b="0" i="0" u="none" strike="noStrike" kern="1200" dirty="0">
                           <a:solidFill>
                             <a:schemeClr val="tx1"/>
                           </a:solidFill>
                           <a:effectLst/>
                           <a:latin typeface="Aptos (cuerpo)"/>
-                        </a:rPr>
-                        <a:t>Operaciones Fleet || Data Lab</a:t>
+                          <a:ea typeface="+mn-ea"/>
+                          <a:cs typeface="+mn-cs"/>
+                        </a:rPr>
+                        <a:t>Contabilidad || Integración Mecánica – SAE (Fase 1-2)</a:t>
                       </a:r>
                     </a:p>
                   </a:txBody>
@@ -10083,24 +10585,36 @@
                         <a:schemeClr val="tx1"/>
                       </a:solidFill>
                       <a:prstDash val="solid"/>
+                      <a:round/>
+                      <a:headEnd type="none" w="med" len="med"/>
+                      <a:tailEnd type="none" w="med" len="med"/>
                     </a:lnL>
                     <a:lnR w="12700" cap="flat" cmpd="sng" algn="ctr">
                       <a:solidFill>
                         <a:schemeClr val="tx1"/>
                       </a:solidFill>
                       <a:prstDash val="solid"/>
+                      <a:round/>
+                      <a:headEnd type="none" w="med" len="med"/>
+                      <a:tailEnd type="none" w="med" len="med"/>
                     </a:lnR>
                     <a:lnT w="12700" cap="flat" cmpd="sng" algn="ctr">
                       <a:solidFill>
                         <a:schemeClr val="tx1"/>
                       </a:solidFill>
                       <a:prstDash val="solid"/>
+                      <a:round/>
+                      <a:headEnd type="none" w="med" len="med"/>
+                      <a:tailEnd type="none" w="med" len="med"/>
                     </a:lnT>
                     <a:lnB w="12700" cap="flat" cmpd="sng" algn="ctr">
                       <a:solidFill>
                         <a:schemeClr val="tx1"/>
                       </a:solidFill>
                       <a:prstDash val="solid"/>
+                      <a:round/>
+                      <a:headEnd type="none" w="med" len="med"/>
+                      <a:tailEnd type="none" w="med" len="med"/>
                     </a:lnB>
                     <a:noFill/>
                   </a:tcPr>
@@ -10110,19 +10624,65 @@
                     <a:bodyPr/>
                     <a:lstStyle/>
                     <a:p>
-                      <a:pPr marL="0" algn="l" defTabSz="457200" rtl="0" eaLnBrk="1" fontAlgn="b" latinLnBrk="0" hangingPunct="1">
+                      <a:pPr marL="0" lvl="0" indent="0" algn="l">
+                        <a:lnSpc>
+                          <a:spcPct val="100000"/>
+                        </a:lnSpc>
+                        <a:spcBef>
+                          <a:spcPts val="0"/>
+                        </a:spcBef>
+                        <a:spcAft>
+                          <a:spcPts val="0"/>
+                        </a:spcAft>
                         <a:buNone/>
                       </a:pPr>
                       <a:r>
-                        <a:rPr lang="es-MX" sz="1000" u="none" strike="noStrike" kern="1200">
+                        <a:rPr lang="es-MX" sz="1100" b="0" i="0" u="none" strike="noStrike" kern="1200" noProof="0">
                           <a:solidFill>
                             <a:schemeClr val="tx1"/>
                           </a:solidFill>
                           <a:effectLst/>
                           <a:latin typeface="Aptos (cuerpo)"/>
-                        </a:rPr>
-                        <a:t>dasdasdasdasd</a:t>
-                      </a:r>
+                          <a:ea typeface="+mn-ea"/>
+                          <a:cs typeface="+mn-cs"/>
+                        </a:rPr>
+                        <a:t>Se tuvieron imprevistos en la carga del catálogo de refacciones en Mecanica Mx</a:t>
+                      </a:r>
+                    </a:p>
+                    <a:p>
+                      <a:pPr marL="0" lvl="0" indent="0" algn="l">
+                        <a:lnSpc>
+                          <a:spcPct val="100000"/>
+                        </a:lnSpc>
+                        <a:spcBef>
+                          <a:spcPts val="0"/>
+                        </a:spcBef>
+                        <a:spcAft>
+                          <a:spcPts val="0"/>
+                        </a:spcAft>
+                        <a:buNone/>
+                      </a:pPr>
+                      <a:r>
+                        <a:rPr lang="es-MX" sz="1100" b="0" i="0" u="none" strike="noStrike" kern="1200" noProof="0">
+                          <a:solidFill>
+                            <a:schemeClr val="tx1"/>
+                          </a:solidFill>
+                          <a:effectLst/>
+                          <a:latin typeface="Aptos (cuerpo)"/>
+                          <a:ea typeface="+mn-ea"/>
+                          <a:cs typeface="+mn-cs"/>
+                        </a:rPr>
+                        <a:t>Actualización del catálogo de proveedores.</a:t>
+                      </a:r>
+                      <a:endParaRPr lang="es-MX" sz="1100" b="0" i="0" u="none" strike="noStrike" kern="1200">
+                        <a:solidFill>
+                          <a:schemeClr val="tx1"/>
+                        </a:solidFill>
+                        <a:effectLst/>
+                        <a:latin typeface="Aptos (cuerpo)"/>
+                        <a:ea typeface="+mn-ea"/>
+                        <a:cs typeface="+mn-cs"/>
+                      </a:endParaRPr>
                     </a:p>
                   </a:txBody>
                   <a:tcPr marL="6244" marR="6244" marT="6244" marB="0" anchor="ctr">
@@ -10131,40 +10691,57 @@
                         <a:schemeClr val="tx1"/>
                       </a:solidFill>
                       <a:prstDash val="solid"/>
+                      <a:round/>
+                      <a:headEnd type="none" w="med" len="med"/>
+                      <a:tailEnd type="none" w="med" len="med"/>
                     </a:lnL>
                     <a:lnR w="12700" cap="flat" cmpd="sng" algn="ctr">
                       <a:solidFill>
                         <a:schemeClr val="tx1"/>
                       </a:solidFill>
                       <a:prstDash val="solid"/>
+                      <a:round/>
+                      <a:headEnd type="none" w="med" len="med"/>
+                      <a:tailEnd type="none" w="med" len="med"/>
                     </a:lnR>
                     <a:lnT w="12700" cap="flat" cmpd="sng" algn="ctr">
                       <a:solidFill>
                         <a:schemeClr val="tx1"/>
                       </a:solidFill>
                       <a:prstDash val="solid"/>
+                      <a:round/>
+                      <a:headEnd type="none" w="med" len="med"/>
+                      <a:tailEnd type="none" w="med" len="med"/>
                     </a:lnT>
                     <a:lnB w="12700" cap="flat" cmpd="sng" algn="ctr">
                       <a:solidFill>
                         <a:schemeClr val="tx1"/>
                       </a:solidFill>
                       <a:prstDash val="solid"/>
+                      <a:round/>
+                      <a:headEnd type="none" w="med" len="med"/>
+                      <a:tailEnd type="none" w="med" len="med"/>
                     </a:lnB>
                     <a:noFill/>
                   </a:tcPr>
                 </a:tc>
+                <a:extLst>
+                  <a:ext uri="{0D108BD9-81ED-4DB2-BD59-A6C34878D82A}">
+                    <a16:rowId xmlns:a16="http://schemas.microsoft.com/office/drawing/2014/main" val="1382980361"/>
+                  </a:ext>
+                </a:extLst>
               </a:tr>
-              <a:tr h="420000">
+              <a:tr h="718457">
                 <a:tc>
                   <a:txBody>
                     <a:bodyPr/>
                     <a:lstStyle/>
                     <a:p>
-                      <a:pPr marL="0" algn="ctr" defTabSz="457200" rtl="0" eaLnBrk="1" fontAlgn="b" latinLnBrk="0" hangingPunct="1">
+                      <a:pPr algn="ctr" fontAlgn="b">
                         <a:buNone/>
                       </a:pPr>
                       <a:r>
-                        <a:rPr lang="es-MX" sz="1000" u="none" strike="noStrike" kern="1200">
+                        <a:rPr lang="es-MX" sz="1100" b="0" i="0" u="none" strike="noStrike">
                           <a:solidFill>
                             <a:schemeClr val="tx1"/>
                           </a:solidFill>
@@ -10181,24 +10758,36 @@
                         <a:schemeClr val="tx1"/>
                       </a:solidFill>
                       <a:prstDash val="solid"/>
+                      <a:round/>
+                      <a:headEnd type="none" w="med" len="med"/>
+                      <a:tailEnd type="none" w="med" len="med"/>
                     </a:lnL>
                     <a:lnR w="12700" cap="flat" cmpd="sng" algn="ctr">
                       <a:solidFill>
                         <a:schemeClr val="tx1"/>
                       </a:solidFill>
                       <a:prstDash val="solid"/>
+                      <a:round/>
+                      <a:headEnd type="none" w="med" len="med"/>
+                      <a:tailEnd type="none" w="med" len="med"/>
                     </a:lnR>
                     <a:lnT w="12700" cap="flat" cmpd="sng" algn="ctr">
                       <a:solidFill>
                         <a:schemeClr val="tx1"/>
                       </a:solidFill>
                       <a:prstDash val="solid"/>
+                      <a:round/>
+                      <a:headEnd type="none" w="med" len="med"/>
+                      <a:tailEnd type="none" w="med" len="med"/>
                     </a:lnT>
                     <a:lnB w="12700" cap="flat" cmpd="sng" algn="ctr">
                       <a:solidFill>
                         <a:schemeClr val="tx1"/>
                       </a:solidFill>
                       <a:prstDash val="solid"/>
+                      <a:round/>
+                      <a:headEnd type="none" w="med" len="med"/>
+                      <a:tailEnd type="none" w="med" len="med"/>
                     </a:lnB>
                     <a:noFill/>
                   </a:tcPr>
@@ -10208,19 +10797,26 @@
                     <a:bodyPr/>
                     <a:lstStyle/>
                     <a:p>
-                      <a:pPr marL="0" algn="l" defTabSz="457200" rtl="0" eaLnBrk="1" fontAlgn="b" latinLnBrk="0" hangingPunct="1">
+                      <a:pPr lvl="0" algn="l">
                         <a:buNone/>
                       </a:pPr>
                       <a:r>
-                        <a:rPr lang="es-MX" sz="1000" u="none" strike="noStrike" kern="1200">
+                        <a:rPr lang="es-MX" sz="1100" u="none" strike="noStrike">
                           <a:solidFill>
                             <a:schemeClr val="tx1"/>
                           </a:solidFill>
                           <a:effectLst/>
                           <a:latin typeface="Aptos (cuerpo)"/>
                         </a:rPr>
-                        <a:t>Operaciones Fleet || Nueva Instancia</a:t>
-                      </a:r>
+                        <a:t>TRIM || MarketPlace || Caddi</a:t>
+                      </a:r>
+                      <a:endParaRPr lang="es-MX" sz="1100" b="0" i="0" u="none" strike="noStrike">
+                        <a:solidFill>
+                          <a:schemeClr val="tx1"/>
+                        </a:solidFill>
+                        <a:effectLst/>
+                        <a:latin typeface="Aptos (cuerpo)"/>
+                      </a:endParaRPr>
                     </a:p>
                   </a:txBody>
                   <a:tcPr marL="6244" marR="6244" marT="6244" marB="0" anchor="ctr">
@@ -10229,24 +10825,36 @@
                         <a:schemeClr val="tx1"/>
                       </a:solidFill>
                       <a:prstDash val="solid"/>
+                      <a:round/>
+                      <a:headEnd type="none" w="med" len="med"/>
+                      <a:tailEnd type="none" w="med" len="med"/>
                     </a:lnL>
                     <a:lnR w="12700" cap="flat" cmpd="sng" algn="ctr">
                       <a:solidFill>
                         <a:schemeClr val="tx1"/>
                       </a:solidFill>
                       <a:prstDash val="solid"/>
+                      <a:round/>
+                      <a:headEnd type="none" w="med" len="med"/>
+                      <a:tailEnd type="none" w="med" len="med"/>
                     </a:lnR>
                     <a:lnT w="12700" cap="flat" cmpd="sng" algn="ctr">
                       <a:solidFill>
                         <a:schemeClr val="tx1"/>
                       </a:solidFill>
                       <a:prstDash val="solid"/>
+                      <a:round/>
+                      <a:headEnd type="none" w="med" len="med"/>
+                      <a:tailEnd type="none" w="med" len="med"/>
                     </a:lnT>
                     <a:lnB w="12700" cap="flat" cmpd="sng" algn="ctr">
                       <a:solidFill>
                         <a:schemeClr val="tx1"/>
                       </a:solidFill>
                       <a:prstDash val="solid"/>
+                      <a:round/>
+                      <a:headEnd type="none" w="med" len="med"/>
+                      <a:tailEnd type="none" w="med" len="med"/>
                     </a:lnB>
                     <a:noFill/>
                   </a:tcPr>
@@ -10256,19 +10864,85 @@
                     <a:bodyPr/>
                     <a:lstStyle/>
                     <a:p>
-                      <a:pPr marL="0" algn="l" defTabSz="457200" rtl="0" eaLnBrk="1" fontAlgn="b" latinLnBrk="0" hangingPunct="1">
+                      <a:pPr marL="0" lvl="0" indent="0" algn="l">
+                        <a:lnSpc>
+                          <a:spcPct val="100000"/>
+                        </a:lnSpc>
+                        <a:spcBef>
+                          <a:spcPts val="0"/>
+                        </a:spcBef>
+                        <a:spcAft>
+                          <a:spcPts val="0"/>
+                        </a:spcAft>
                         <a:buNone/>
                       </a:pPr>
                       <a:r>
-                        <a:rPr lang="es-MX" sz="1000" u="none" strike="noStrike" kern="1200">
+                        <a:rPr lang="es-MX" sz="800" b="0" i="0" u="none" strike="noStrike" noProof="0">
+                          <a:solidFill>
+                            <a:schemeClr val="tx1"/>
+                          </a:solidFill>
+                          <a:effectLst/>
+                          <a:latin typeface="Segoe UI"/>
+                          <a:cs typeface="Segoe UI"/>
+                        </a:rPr>
+                        <a:t>E</a:t>
+                      </a:r>
+                      <a:r>
+                        <a:rPr lang="es-MX" sz="1100" u="none" strike="noStrike" kern="1200" noProof="0">
                           <a:solidFill>
                             <a:schemeClr val="tx1"/>
                           </a:solidFill>
                           <a:effectLst/>
                           <a:latin typeface="Aptos (cuerpo)"/>
-                        </a:rPr>
-                        <a:t>ggdgsefreheh</a:t>
-                      </a:r>
+                          <a:ea typeface="+mn-ea"/>
+                          <a:cs typeface="+mn-cs"/>
+                        </a:rPr>
+                        <a:t>xistió un retraso en la carga del código AMI en Intelimotor.</a:t>
+                      </a:r>
+                      <a:endParaRPr lang="es-ES" sz="1100" u="none" strike="noStrike" kern="1200" noProof="0">
+                        <a:solidFill>
+                          <a:schemeClr val="tx1"/>
+                        </a:solidFill>
+                        <a:effectLst/>
+                        <a:latin typeface="Aptos (cuerpo)"/>
+                        <a:ea typeface="+mn-ea"/>
+                        <a:cs typeface="+mn-cs"/>
+                      </a:endParaRPr>
+                    </a:p>
+                    <a:p>
+                      <a:pPr marL="0" lvl="0" indent="0" algn="l">
+                        <a:lnSpc>
+                          <a:spcPct val="100000"/>
+                        </a:lnSpc>
+                        <a:spcBef>
+                          <a:spcPts val="0"/>
+                        </a:spcBef>
+                        <a:spcAft>
+                          <a:spcPts val="0"/>
+                        </a:spcAft>
+                        <a:buNone/>
+                      </a:pPr>
+                      <a:r>
+                        <a:rPr lang="es-MX" sz="1100" u="none" strike="noStrike" kern="1200" noProof="0">
+                          <a:solidFill>
+                            <a:schemeClr val="tx1"/>
+                          </a:solidFill>
+                          <a:effectLst/>
+                          <a:latin typeface="Aptos (cuerpo)"/>
+                          <a:ea typeface="+mn-ea"/>
+                          <a:cs typeface="+mn-cs"/>
+                        </a:rPr>
+                        <a:t>Seguros Ana tardó en realizar la validación de los XML de prueba.</a:t>
+                      </a:r>
+                      <a:endParaRPr lang="es-MX" sz="1100" u="none" strike="noStrike" kern="1200">
+                        <a:solidFill>
+                          <a:schemeClr val="tx1"/>
+                        </a:solidFill>
+                        <a:effectLst/>
+                        <a:latin typeface="Aptos (cuerpo)"/>
+                        <a:ea typeface="+mn-ea"/>
+                        <a:cs typeface="+mn-cs"/>
+                      </a:endParaRPr>
                     </a:p>
                   </a:txBody>
                   <a:tcPr marL="6244" marR="6244" marT="6244" marB="0" anchor="ctr">
@@ -10277,40 +10951,57 @@
                         <a:schemeClr val="tx1"/>
                       </a:solidFill>
                       <a:prstDash val="solid"/>
+                      <a:round/>
+                      <a:headEnd type="none" w="med" len="med"/>
+                      <a:tailEnd type="none" w="med" len="med"/>
                     </a:lnL>
                     <a:lnR w="12700" cap="flat" cmpd="sng" algn="ctr">
                       <a:solidFill>
                         <a:schemeClr val="tx1"/>
                       </a:solidFill>
                       <a:prstDash val="solid"/>
+                      <a:round/>
+                      <a:headEnd type="none" w="med" len="med"/>
+                      <a:tailEnd type="none" w="med" len="med"/>
                     </a:lnR>
                     <a:lnT w="12700" cap="flat" cmpd="sng" algn="ctr">
                       <a:solidFill>
                         <a:schemeClr val="tx1"/>
                       </a:solidFill>
                       <a:prstDash val="solid"/>
+                      <a:round/>
+                      <a:headEnd type="none" w="med" len="med"/>
+                      <a:tailEnd type="none" w="med" len="med"/>
                     </a:lnT>
                     <a:lnB w="12700" cap="flat" cmpd="sng" algn="ctr">
                       <a:solidFill>
                         <a:schemeClr val="tx1"/>
                       </a:solidFill>
                       <a:prstDash val="solid"/>
+                      <a:round/>
+                      <a:headEnd type="none" w="med" len="med"/>
+                      <a:tailEnd type="none" w="med" len="med"/>
                     </a:lnB>
                     <a:noFill/>
                   </a:tcPr>
                 </a:tc>
+                <a:extLst>
+                  <a:ext uri="{0D108BD9-81ED-4DB2-BD59-A6C34878D82A}">
+                    <a16:rowId xmlns:a16="http://schemas.microsoft.com/office/drawing/2014/main" val="2986911556"/>
+                  </a:ext>
+                </a:extLst>
               </a:tr>
-              <a:tr h="420000">
+              <a:tr h="594360">
                 <a:tc>
                   <a:txBody>
                     <a:bodyPr/>
                     <a:lstStyle/>
                     <a:p>
-                      <a:pPr marL="0" algn="ctr" defTabSz="457200" rtl="0" eaLnBrk="1" fontAlgn="b" latinLnBrk="0" hangingPunct="1">
+                      <a:pPr algn="ctr" fontAlgn="b">
                         <a:buNone/>
                       </a:pPr>
                       <a:r>
-                        <a:rPr lang="es-MX" sz="1000" u="none" strike="noStrike" kern="1200">
+                        <a:rPr lang="es-ES" sz="1100" b="0" i="0" u="none" strike="noStrike">
                           <a:solidFill>
                             <a:schemeClr val="tx1"/>
                           </a:solidFill>
@@ -10319,6 +11010,13 @@
                         </a:rPr>
                         <a:t>4</a:t>
                       </a:r>
+                      <a:endParaRPr lang="es-MX" sz="1100" b="0" i="0" u="none" strike="noStrike">
+                        <a:solidFill>
+                          <a:schemeClr val="tx1"/>
+                        </a:solidFill>
+                        <a:effectLst/>
+                        <a:latin typeface="Aptos (cuerpo)"/>
+                      </a:endParaRPr>
                     </a:p>
                   </a:txBody>
                   <a:tcPr marL="6244" marR="6244" marT="6244" marB="0" anchor="ctr">
@@ -10327,24 +11025,36 @@
                         <a:schemeClr val="tx1"/>
                       </a:solidFill>
                       <a:prstDash val="solid"/>
+                      <a:round/>
+                      <a:headEnd type="none" w="med" len="med"/>
+                      <a:tailEnd type="none" w="med" len="med"/>
                     </a:lnL>
                     <a:lnR w="12700" cap="flat" cmpd="sng" algn="ctr">
                       <a:solidFill>
                         <a:schemeClr val="tx1"/>
                       </a:solidFill>
                       <a:prstDash val="solid"/>
+                      <a:round/>
+                      <a:headEnd type="none" w="med" len="med"/>
+                      <a:tailEnd type="none" w="med" len="med"/>
                     </a:lnR>
                     <a:lnT w="12700" cap="flat" cmpd="sng" algn="ctr">
                       <a:solidFill>
                         <a:schemeClr val="tx1"/>
                       </a:solidFill>
                       <a:prstDash val="solid"/>
+                      <a:round/>
+                      <a:headEnd type="none" w="med" len="med"/>
+                      <a:tailEnd type="none" w="med" len="med"/>
                     </a:lnT>
                     <a:lnB w="12700" cap="flat" cmpd="sng" algn="ctr">
                       <a:solidFill>
                         <a:schemeClr val="tx1"/>
                       </a:solidFill>
                       <a:prstDash val="solid"/>
+                      <a:round/>
+                      <a:headEnd type="none" w="med" len="med"/>
+                      <a:tailEnd type="none" w="med" len="med"/>
                     </a:lnB>
                     <a:noFill/>
                   </a:tcPr>
@@ -10354,18 +11064,18 @@
                     <a:bodyPr/>
                     <a:lstStyle/>
                     <a:p>
-                      <a:pPr marL="0" algn="l" defTabSz="457200" rtl="0" eaLnBrk="1" fontAlgn="b" latinLnBrk="0" hangingPunct="1">
+                      <a:pPr algn="l" fontAlgn="b">
                         <a:buNone/>
                       </a:pPr>
                       <a:r>
-                        <a:rPr lang="es-MX" sz="1000" u="none" strike="noStrike" kern="1200">
+                        <a:rPr lang="es-MX" sz="1100" b="0" i="0" u="none" strike="noStrike">
                           <a:solidFill>
                             <a:schemeClr val="tx1"/>
                           </a:solidFill>
                           <a:effectLst/>
                           <a:latin typeface="Aptos (cuerpo)"/>
                         </a:rPr>
-                        <a:t>Capital Humano || BUK Campos Personalizados</a:t>
+                        <a:t>Operaciones Fleet || Desarrollos</a:t>
                       </a:r>
                     </a:p>
                   </a:txBody>
@@ -10375,24 +11085,36 @@
                         <a:schemeClr val="tx1"/>
                       </a:solidFill>
                       <a:prstDash val="solid"/>
+                      <a:round/>
+                      <a:headEnd type="none" w="med" len="med"/>
+                      <a:tailEnd type="none" w="med" len="med"/>
                     </a:lnL>
                     <a:lnR w="12700" cap="flat" cmpd="sng" algn="ctr">
                       <a:solidFill>
                         <a:schemeClr val="tx1"/>
                       </a:solidFill>
                       <a:prstDash val="solid"/>
+                      <a:round/>
+                      <a:headEnd type="none" w="med" len="med"/>
+                      <a:tailEnd type="none" w="med" len="med"/>
                     </a:lnR>
                     <a:lnT w="12700" cap="flat" cmpd="sng" algn="ctr">
                       <a:solidFill>
                         <a:schemeClr val="tx1"/>
                       </a:solidFill>
                       <a:prstDash val="solid"/>
+                      <a:round/>
+                      <a:headEnd type="none" w="med" len="med"/>
+                      <a:tailEnd type="none" w="med" len="med"/>
                     </a:lnT>
                     <a:lnB w="12700" cap="flat" cmpd="sng" algn="ctr">
                       <a:solidFill>
                         <a:schemeClr val="tx1"/>
                       </a:solidFill>
                       <a:prstDash val="solid"/>
+                      <a:round/>
+                      <a:headEnd type="none" w="med" len="med"/>
+                      <a:tailEnd type="none" w="med" len="med"/>
                     </a:lnB>
                     <a:noFill/>
                   </a:tcPr>
@@ -10402,19 +11124,27 @@
                     <a:bodyPr/>
                     <a:lstStyle/>
                     <a:p>
-                      <a:pPr marL="0" algn="l" defTabSz="457200" rtl="0" eaLnBrk="1" fontAlgn="b" latinLnBrk="0" hangingPunct="1">
+                      <a:pPr marL="0" indent="0" algn="l" fontAlgn="b">
+                        <a:buFont typeface="Arial" panose="020B0604020202020204" pitchFamily="34" charset="0"/>
                         <a:buNone/>
                       </a:pPr>
                       <a:r>
-                        <a:rPr lang="es-MX" sz="1000" u="none" strike="noStrike" kern="1200">
+                        <a:rPr lang="es-ES" sz="1100" b="0" i="0" u="none" strike="noStrike">
                           <a:solidFill>
                             <a:schemeClr val="tx1"/>
                           </a:solidFill>
                           <a:effectLst/>
                           <a:latin typeface="Aptos (cuerpo)"/>
                         </a:rPr>
-                        <a:t>fsdgshsdh</a:t>
-                      </a:r>
+                        <a:t>Por cargas de trabajo el usuario no ha podido concluir con las pruebas de certificación de Roles y Permisos</a:t>
+                      </a:r>
+                      <a:endParaRPr lang="es-MX" sz="1100" b="0" i="0" u="none" strike="noStrike">
+                        <a:solidFill>
+                          <a:schemeClr val="tx1"/>
+                        </a:solidFill>
+                        <a:effectLst/>
+                        <a:latin typeface="Aptos (cuerpo)"/>
+                      </a:endParaRPr>
                     </a:p>
                   </a:txBody>
                   <a:tcPr marL="6244" marR="6244" marT="6244" marB="0" anchor="ctr">
@@ -10423,40 +11153,57 @@
                         <a:schemeClr val="tx1"/>
                       </a:solidFill>
                       <a:prstDash val="solid"/>
+                      <a:round/>
+                      <a:headEnd type="none" w="med" len="med"/>
+                      <a:tailEnd type="none" w="med" len="med"/>
                     </a:lnL>
                     <a:lnR w="12700" cap="flat" cmpd="sng" algn="ctr">
                       <a:solidFill>
                         <a:schemeClr val="tx1"/>
                       </a:solidFill>
                       <a:prstDash val="solid"/>
+                      <a:round/>
+                      <a:headEnd type="none" w="med" len="med"/>
+                      <a:tailEnd type="none" w="med" len="med"/>
                     </a:lnR>
                     <a:lnT w="12700" cap="flat" cmpd="sng" algn="ctr">
                       <a:solidFill>
                         <a:schemeClr val="tx1"/>
                       </a:solidFill>
                       <a:prstDash val="solid"/>
+                      <a:round/>
+                      <a:headEnd type="none" w="med" len="med"/>
+                      <a:tailEnd type="none" w="med" len="med"/>
                     </a:lnT>
                     <a:lnB w="12700" cap="flat" cmpd="sng" algn="ctr">
                       <a:solidFill>
                         <a:schemeClr val="tx1"/>
                       </a:solidFill>
                       <a:prstDash val="solid"/>
+                      <a:round/>
+                      <a:headEnd type="none" w="med" len="med"/>
+                      <a:tailEnd type="none" w="med" len="med"/>
                     </a:lnB>
                     <a:noFill/>
                   </a:tcPr>
                 </a:tc>
+                <a:extLst>
+                  <a:ext uri="{0D108BD9-81ED-4DB2-BD59-A6C34878D82A}">
+                    <a16:rowId xmlns:a16="http://schemas.microsoft.com/office/drawing/2014/main" val="1272086280"/>
+                  </a:ext>
+                </a:extLst>
               </a:tr>
-              <a:tr h="420000">
+              <a:tr h="594360">
                 <a:tc>
                   <a:txBody>
                     <a:bodyPr/>
                     <a:lstStyle/>
                     <a:p>
-                      <a:pPr marL="0" algn="ctr" defTabSz="457200" rtl="0" eaLnBrk="1" fontAlgn="b" latinLnBrk="0" hangingPunct="1">
+                      <a:pPr algn="ctr" fontAlgn="b">
                         <a:buNone/>
                       </a:pPr>
                       <a:r>
-                        <a:rPr lang="es-MX" sz="1000" u="none" strike="noStrike" kern="1200">
+                        <a:rPr lang="es-MX" sz="1100" b="0" i="0" u="none" strike="noStrike">
                           <a:solidFill>
                             <a:schemeClr val="tx1"/>
                           </a:solidFill>
@@ -10473,24 +11220,36 @@
                         <a:schemeClr val="tx1"/>
                       </a:solidFill>
                       <a:prstDash val="solid"/>
+                      <a:round/>
+                      <a:headEnd type="none" w="med" len="med"/>
+                      <a:tailEnd type="none" w="med" len="med"/>
                     </a:lnL>
                     <a:lnR w="12700" cap="flat" cmpd="sng" algn="ctr">
                       <a:solidFill>
                         <a:schemeClr val="tx1"/>
                       </a:solidFill>
                       <a:prstDash val="solid"/>
+                      <a:round/>
+                      <a:headEnd type="none" w="med" len="med"/>
+                      <a:tailEnd type="none" w="med" len="med"/>
                     </a:lnR>
                     <a:lnT w="12700" cap="flat" cmpd="sng" algn="ctr">
                       <a:solidFill>
                         <a:schemeClr val="tx1"/>
                       </a:solidFill>
                       <a:prstDash val="solid"/>
+                      <a:round/>
+                      <a:headEnd type="none" w="med" len="med"/>
+                      <a:tailEnd type="none" w="med" len="med"/>
                     </a:lnT>
                     <a:lnB w="12700" cap="flat" cmpd="sng" algn="ctr">
                       <a:solidFill>
                         <a:schemeClr val="tx1"/>
                       </a:solidFill>
                       <a:prstDash val="solid"/>
+                      <a:round/>
+                      <a:headEnd type="none" w="med" len="med"/>
+                      <a:tailEnd type="none" w="med" len="med"/>
                     </a:lnB>
                     <a:noFill/>
                   </a:tcPr>
@@ -10500,18 +11259,18 @@
                     <a:bodyPr/>
                     <a:lstStyle/>
                     <a:p>
-                      <a:pPr marL="0" algn="l" defTabSz="457200" rtl="0" eaLnBrk="1" fontAlgn="b" latinLnBrk="0" hangingPunct="1">
+                      <a:pPr algn="l" fontAlgn="b">
                         <a:buNone/>
                       </a:pPr>
                       <a:r>
-                        <a:rPr lang="es-MX" sz="1000" u="none" strike="noStrike" kern="1200">
+                        <a:rPr lang="es-MX" sz="1100" b="0" i="0" u="none" strike="noStrike">
                           <a:solidFill>
                             <a:schemeClr val="tx1"/>
                           </a:solidFill>
                           <a:effectLst/>
                           <a:latin typeface="Aptos (cuerpo)"/>
                         </a:rPr>
-                        <a:t>Talleres || Integración Mecanica Mx - SAE</a:t>
+                        <a:t>Tesorería || Adcontent H2H</a:t>
                       </a:r>
                     </a:p>
                   </a:txBody>
@@ -10521,24 +11280,36 @@
                         <a:schemeClr val="tx1"/>
                       </a:solidFill>
                       <a:prstDash val="solid"/>
+                      <a:round/>
+                      <a:headEnd type="none" w="med" len="med"/>
+                      <a:tailEnd type="none" w="med" len="med"/>
                     </a:lnL>
                     <a:lnR w="12700" cap="flat" cmpd="sng" algn="ctr">
                       <a:solidFill>
                         <a:schemeClr val="tx1"/>
                       </a:solidFill>
                       <a:prstDash val="solid"/>
+                      <a:round/>
+                      <a:headEnd type="none" w="med" len="med"/>
+                      <a:tailEnd type="none" w="med" len="med"/>
                     </a:lnR>
                     <a:lnT w="12700" cap="flat" cmpd="sng" algn="ctr">
                       <a:solidFill>
                         <a:schemeClr val="tx1"/>
                       </a:solidFill>
                       <a:prstDash val="solid"/>
+                      <a:round/>
+                      <a:headEnd type="none" w="med" len="med"/>
+                      <a:tailEnd type="none" w="med" len="med"/>
                     </a:lnT>
                     <a:lnB w="12700" cap="flat" cmpd="sng" algn="ctr">
                       <a:solidFill>
                         <a:schemeClr val="tx1"/>
                       </a:solidFill>
                       <a:prstDash val="solid"/>
+                      <a:round/>
+                      <a:headEnd type="none" w="med" len="med"/>
+                      <a:tailEnd type="none" w="med" len="med"/>
                     </a:lnB>
                     <a:noFill/>
                   </a:tcPr>
@@ -10548,18 +11319,19 @@
                     <a:bodyPr/>
                     <a:lstStyle/>
                     <a:p>
-                      <a:pPr marL="0" algn="l" defTabSz="457200" rtl="0" eaLnBrk="1" fontAlgn="b" latinLnBrk="0" hangingPunct="1">
+                      <a:pPr marL="0" indent="0" algn="l" fontAlgn="b">
+                        <a:buFont typeface="Arial" panose="020B0604020202020204" pitchFamily="34" charset="0"/>
                         <a:buNone/>
                       </a:pPr>
                       <a:r>
-                        <a:rPr lang="es-MX" sz="1000" u="none" strike="noStrike" kern="1200">
+                        <a:rPr lang="es-MX" sz="1100" b="0" i="0" u="none" strike="noStrike" dirty="0">
                           <a:solidFill>
                             <a:schemeClr val="tx1"/>
                           </a:solidFill>
                           <a:effectLst/>
                           <a:latin typeface="Aptos (cuerpo)"/>
                         </a:rPr>
-                        <a:t>asasfagdgdsgg</a:t>
+                        <a:t>Pendiente Autorización de Dirección de Finanzas</a:t>
                       </a:r>
                     </a:p>
                   </a:txBody>
@@ -10569,28 +11341,45 @@
                         <a:schemeClr val="tx1"/>
                       </a:solidFill>
                       <a:prstDash val="solid"/>
+                      <a:round/>
+                      <a:headEnd type="none" w="med" len="med"/>
+                      <a:tailEnd type="none" w="med" len="med"/>
                     </a:lnL>
                     <a:lnR w="12700" cap="flat" cmpd="sng" algn="ctr">
                       <a:solidFill>
                         <a:schemeClr val="tx1"/>
                       </a:solidFill>
                       <a:prstDash val="solid"/>
+                      <a:round/>
+                      <a:headEnd type="none" w="med" len="med"/>
+                      <a:tailEnd type="none" w="med" len="med"/>
                     </a:lnR>
                     <a:lnT w="12700" cap="flat" cmpd="sng" algn="ctr">
                       <a:solidFill>
                         <a:schemeClr val="tx1"/>
                       </a:solidFill>
                       <a:prstDash val="solid"/>
+                      <a:round/>
+                      <a:headEnd type="none" w="med" len="med"/>
+                      <a:tailEnd type="none" w="med" len="med"/>
                     </a:lnT>
                     <a:lnB w="12700" cap="flat" cmpd="sng" algn="ctr">
                       <a:solidFill>
                         <a:schemeClr val="tx1"/>
                       </a:solidFill>
                       <a:prstDash val="solid"/>
+                      <a:round/>
+                      <a:headEnd type="none" w="med" len="med"/>
+                      <a:tailEnd type="none" w="med" len="med"/>
                     </a:lnB>
                     <a:noFill/>
                   </a:tcPr>
                 </a:tc>
+                <a:extLst>
+                  <a:ext uri="{0D108BD9-81ED-4DB2-BD59-A6C34878D82A}">
+                    <a16:rowId xmlns:a16="http://schemas.microsoft.com/office/drawing/2014/main" val="2497780819"/>
+                  </a:ext>
+                </a:extLst>
               </a:tr>
             </a:tbl>
           </a:graphicData>

</xml_diff>

<commit_message>
reporte: actualizar cierre_base.pptx (bajo demanda, modulo imc)
</commit_message>
<xml_diff>
--- a/cierre_base.pptx
+++ b/cierre_base.pptx
@@ -5353,7 +5353,7 @@
                 </a:solidFill>
                 <a:latin typeface="Arial Nova Light"/>
               </a:rPr>
-              <a:t>Cierre semanal del 9 de Julio al 16 de Julio</a:t>
+              <a:t>Cierre semanal del 23 de Julio al 30 de Julio</a:t>
             </a:r>
             <a:endParaRPr lang="es-MX" sz="1400" b="1" dirty="0">
               <a:solidFill>
@@ -5469,7 +5469,7 @@
                 </a:solidFill>
                 <a:latin typeface="Calibri"/>
               </a:rPr>
-              <a:t>18</a:t>
+              <a:t>12</a:t>
             </a:r>
           </a:p>
         </p:txBody>
@@ -5584,7 +5584,7 @@
                 </a:solidFill>
                 <a:latin typeface="Calibri"/>
               </a:rPr>
-              <a:t>9</a:t>
+              <a:t>6</a:t>
             </a:r>
           </a:p>
         </p:txBody>
@@ -5814,7 +5814,7 @@
                 </a:solidFill>
                 <a:latin typeface="Calibri"/>
               </a:rPr>
-              <a:t>2</a:t>
+              <a:t>0</a:t>
             </a:r>
           </a:p>
         </p:txBody>
@@ -5929,7 +5929,7 @@
                 </a:solidFill>
                 <a:latin typeface="Calibri"/>
               </a:rPr>
-              <a:t>4</a:t>
+              <a:t>3</a:t>
             </a:r>
           </a:p>
         </p:txBody>
@@ -6229,7 +6229,7 @@
                 </a:solidFill>
                 <a:latin typeface="Calibri"/>
               </a:rPr>
-              <a:t>ÁREA DE IMPLEMENTACIÓN</a:t>
+              <a:t>IMC — ÁREA DE IMPLEMENTACIÓN</a:t>
             </a:r>
           </a:p>
         </p:txBody>
@@ -6264,7 +6264,7 @@
                 </a:solidFill>
                 <a:latin typeface="Calibri"/>
               </a:rPr>
-              <a:t>Cierre semanal del 9 de Julio al 16 de Julio</a:t>
+              <a:t>Cierre semanal del 23 de Julio al 30 de Julio</a:t>
             </a:r>
           </a:p>
         </p:txBody>
@@ -6807,7 +6807,7 @@
                 </a:solidFill>
                 <a:latin typeface="Calibri"/>
               </a:rPr>
-              <a:t>78%</a:t>
+              <a:t>100%</a:t>
             </a:r>
           </a:p>
         </p:txBody>
@@ -6842,7 +6842,7 @@
                 </a:solidFill>
                 <a:latin typeface="Calibri"/>
               </a:rPr>
-              <a:t>95%</a:t>
+              <a:t>100%</a:t>
             </a:r>
           </a:p>
         </p:txBody>
@@ -6873,11 +6873,11 @@
             <a:r>
               <a:rPr sz="700" b="1">
                 <a:solidFill>
-                  <a:srgbClr val="EF4444"/>
+                  <a:srgbClr val="22C55E"/>
                 </a:solidFill>
                 <a:latin typeface="Calibri"/>
               </a:rPr>
-              <a:t>Atrasado</a:t>
+              <a:t>Terminado</a:t>
             </a:r>
           </a:p>
         </p:txBody>
@@ -6900,7 +6900,7 @@
           </a:prstGeom>
           <a:pattFill prst="smGrid">
             <a:fgClr>
-              <a:srgbClr val="EF4444"/>
+              <a:srgbClr val="22C55E"/>
             </a:fgClr>
             <a:bgClr>
               <a:srgbClr val="FFFFFF"/>
@@ -6942,7 +6942,7 @@
         <p:spPr>
           <a:xfrm>
             <a:off x="5806440" y="1432064"/>
-            <a:ext cx="1319479" cy="103098"/>
+            <a:ext cx="1691640" cy="103098"/>
           </a:xfrm>
           <a:prstGeom prst="roundRect">
             <a:avLst>
@@ -6950,14 +6950,14 @@
             </a:avLst>
           </a:prstGeom>
           <a:solidFill>
-            <a:srgbClr val="EF4444"/>
+            <a:srgbClr val="22C55E"/>
           </a:solidFill>
           <a:ln>
             <a:noFill/>
           </a:ln>
           <a:effectLst>
             <a:outerShdw blurRad="76200" dist="19050" dir="5400000" rotWithShape="0">
-              <a:srgbClr val="EF4444">
+              <a:srgbClr val="22C55E">
                 <a:alpha val="55000"/>
               </a:srgbClr>
             </a:outerShdw>
@@ -7011,11 +7011,11 @@
             <a:r>
               <a:rPr sz="800" b="1">
                 <a:solidFill>
-                  <a:srgbClr val="EF4444"/>
+                  <a:srgbClr val="22C55E"/>
                 </a:solidFill>
                 <a:latin typeface="Calibri"/>
               </a:rPr>
-              <a:t>78%</a:t>
+              <a:t>100%</a:t>
             </a:r>
           </a:p>
         </p:txBody>
@@ -7094,7 +7094,7 @@
                 </a:solidFill>
                 <a:latin typeface="Calibri"/>
               </a:rPr>
-              <a:t>Mejoras</a:t>
+              <a:t>Proyecto</a:t>
             </a:r>
           </a:p>
         </p:txBody>
@@ -7129,7 +7129,7 @@
                 </a:solidFill>
                 <a:latin typeface="Calibri"/>
               </a:rPr>
-              <a:t>Administración || AdContent - Catálogos</a:t>
+              <a:t>TRIM || Marketplace || Caddi</a:t>
             </a:r>
           </a:p>
         </p:txBody>
@@ -7164,7 +7164,7 @@
                 </a:solidFill>
                 <a:latin typeface="Calibri"/>
               </a:rPr>
-              <a:t>01/04/2026</a:t>
+              <a:t>07/08/2025</a:t>
             </a:r>
           </a:p>
         </p:txBody>
@@ -7199,7 +7199,7 @@
                 </a:solidFill>
                 <a:latin typeface="Calibri"/>
               </a:rPr>
-              <a:t>02/06/2026</a:t>
+              <a:t>04/08/2026</a:t>
             </a:r>
           </a:p>
         </p:txBody>
@@ -7269,7 +7269,7 @@
                 </a:solidFill>
                 <a:latin typeface="Calibri"/>
               </a:rPr>
-              <a:t>100%</a:t>
+              <a:t>98%</a:t>
             </a:r>
           </a:p>
         </p:txBody>
@@ -7521,7 +7521,7 @@
                 </a:solidFill>
                 <a:latin typeface="Calibri"/>
               </a:rPr>
-              <a:t>Mejoras</a:t>
+              <a:t>Proyecto</a:t>
             </a:r>
           </a:p>
         </p:txBody>
@@ -7556,7 +7556,7 @@
                 </a:solidFill>
                 <a:latin typeface="Calibri"/>
               </a:rPr>
-              <a:t>Capital Humano || BUK Soporte – Incidencia</a:t>
+              <a:t>Contabilidad || Integración Mecanica-SAE (Fase…</a:t>
             </a:r>
           </a:p>
         </p:txBody>
@@ -7591,7 +7591,7 @@
                 </a:solidFill>
                 <a:latin typeface="Calibri"/>
               </a:rPr>
-              <a:t>02/03/2026</a:t>
+              <a:t>14/08/2025</a:t>
             </a:r>
           </a:p>
         </p:txBody>
@@ -7626,7 +7626,7 @@
                 </a:solidFill>
                 <a:latin typeface="Calibri"/>
               </a:rPr>
-              <a:t>29/05/2026</a:t>
+              <a:t>02/06/2026</a:t>
             </a:r>
           </a:p>
         </p:txBody>
@@ -7661,7 +7661,7 @@
                 </a:solidFill>
                 <a:latin typeface="Calibri"/>
               </a:rPr>
-              <a:t>100%</a:t>
+              <a:t>96%</a:t>
             </a:r>
           </a:p>
         </p:txBody>
@@ -7727,11 +7727,11 @@
             <a:r>
               <a:rPr sz="700" b="1">
                 <a:solidFill>
-                  <a:srgbClr val="22C55E"/>
+                  <a:srgbClr val="EF4444"/>
                 </a:solidFill>
                 <a:latin typeface="Calibri"/>
               </a:rPr>
-              <a:t>Terminado</a:t>
+              <a:t>Atrasado</a:t>
             </a:r>
           </a:p>
         </p:txBody>
@@ -7754,7 +7754,7 @@
           </a:prstGeom>
           <a:pattFill prst="smGrid">
             <a:fgClr>
-              <a:srgbClr val="22C55E"/>
+              <a:srgbClr val="EF4444"/>
             </a:fgClr>
             <a:bgClr>
               <a:srgbClr val="FFFFFF"/>
@@ -7796,7 +7796,7 @@
         <p:spPr>
           <a:xfrm>
             <a:off x="5806440" y="1806968"/>
-            <a:ext cx="1691640" cy="103098"/>
+            <a:ext cx="1623974" cy="103098"/>
           </a:xfrm>
           <a:prstGeom prst="roundRect">
             <a:avLst>
@@ -7804,14 +7804,14 @@
             </a:avLst>
           </a:prstGeom>
           <a:solidFill>
-            <a:srgbClr val="22C55E"/>
+            <a:srgbClr val="EF4444"/>
           </a:solidFill>
           <a:ln>
             <a:noFill/>
           </a:ln>
           <a:effectLst>
             <a:outerShdw blurRad="76200" dist="19050" dir="5400000" rotWithShape="0">
-              <a:srgbClr val="22C55E">
+              <a:srgbClr val="EF4444">
                 <a:alpha val="55000"/>
               </a:srgbClr>
             </a:outerShdw>
@@ -7865,11 +7865,11 @@
             <a:r>
               <a:rPr sz="800" b="1">
                 <a:solidFill>
-                  <a:srgbClr val="22C55E"/>
+                  <a:srgbClr val="EF4444"/>
                 </a:solidFill>
                 <a:latin typeface="Calibri"/>
               </a:rPr>
-              <a:t>100%</a:t>
+              <a:t>96%</a:t>
             </a:r>
           </a:p>
         </p:txBody>
@@ -7983,7 +7983,7 @@
                 </a:solidFill>
                 <a:latin typeface="Calibri"/>
               </a:rPr>
-              <a:t>Capital Humano || BUK Campos Personalizados</a:t>
+              <a:t>Operaciones Fleet || Desarrollos</a:t>
             </a:r>
           </a:p>
         </p:txBody>
@@ -8018,7 +8018,7 @@
                 </a:solidFill>
                 <a:latin typeface="Calibri"/>
               </a:rPr>
-              <a:t>26/02/2026</a:t>
+              <a:t>08/08/2025</a:t>
             </a:r>
           </a:p>
         </p:txBody>
@@ -8053,7 +8053,7 @@
                 </a:solidFill>
                 <a:latin typeface="Calibri"/>
               </a:rPr>
-              <a:t>25/05/2026</a:t>
+              <a:t>05/06/2026</a:t>
             </a:r>
           </a:p>
         </p:txBody>
@@ -8410,7 +8410,7 @@
                 </a:solidFill>
                 <a:latin typeface="Calibri"/>
               </a:rPr>
-              <a:t>TRIM || Marketplace || Caddi</a:t>
+              <a:t>Operaciones Fleet || Lobby Fix</a:t>
             </a:r>
           </a:p>
         </p:txBody>
@@ -8445,7 +8445,7 @@
                 </a:solidFill>
                 <a:latin typeface="Calibri"/>
               </a:rPr>
-              <a:t>07/08/2025</a:t>
+              <a:t>11/11/2025</a:t>
             </a:r>
           </a:p>
         </p:txBody>
@@ -8480,7 +8480,7 @@
                 </a:solidFill>
                 <a:latin typeface="Calibri"/>
               </a:rPr>
-              <a:t>04/08/2026</a:t>
+              <a:t>29/06/2026</a:t>
             </a:r>
           </a:p>
         </p:txBody>
@@ -8515,7 +8515,7 @@
                 </a:solidFill>
                 <a:latin typeface="Calibri"/>
               </a:rPr>
-              <a:t>99%</a:t>
+              <a:t>100%</a:t>
             </a:r>
           </a:p>
         </p:txBody>
@@ -8550,7 +8550,7 @@
                 </a:solidFill>
                 <a:latin typeface="Calibri"/>
               </a:rPr>
-              <a:t>94%</a:t>
+              <a:t>100%</a:t>
             </a:r>
           </a:p>
         </p:txBody>
@@ -8585,7 +8585,7 @@
                 </a:solidFill>
                 <a:latin typeface="Calibri"/>
               </a:rPr>
-              <a:t>A tiempo</a:t>
+              <a:t>Terminado</a:t>
             </a:r>
           </a:p>
         </p:txBody>
@@ -8650,7 +8650,7 @@
         <p:spPr>
           <a:xfrm>
             <a:off x="5806440" y="2181872"/>
-            <a:ext cx="1674723" cy="103098"/>
+            <a:ext cx="1691640" cy="103098"/>
           </a:xfrm>
           <a:prstGeom prst="roundRect">
             <a:avLst>
@@ -8723,7 +8723,7 @@
                 </a:solidFill>
                 <a:latin typeface="Calibri"/>
               </a:rPr>
-              <a:t>99%</a:t>
+              <a:t>100%</a:t>
             </a:r>
           </a:p>
         </p:txBody>
@@ -8802,7 +8802,7 @@
                 </a:solidFill>
                 <a:latin typeface="Calibri"/>
               </a:rPr>
-              <a:t>Proyecto</a:t>
+              <a:t>Mejoras</a:t>
             </a:r>
           </a:p>
         </p:txBody>
@@ -8837,7 +8837,7 @@
                 </a:solidFill>
                 <a:latin typeface="Calibri"/>
               </a:rPr>
-              <a:t>Contabilidad || Integración Mecanica-SAE (Fase…</a:t>
+              <a:t>Operaciones Fleet || Nexcar || Desarrollos</a:t>
             </a:r>
           </a:p>
         </p:txBody>
@@ -8872,7 +8872,7 @@
                 </a:solidFill>
                 <a:latin typeface="Calibri"/>
               </a:rPr>
-              <a:t>14/08/2025</a:t>
+              <a:t>05/03/2026</a:t>
             </a:r>
           </a:p>
         </p:txBody>
@@ -8907,7 +8907,7 @@
                 </a:solidFill>
                 <a:latin typeface="Calibri"/>
               </a:rPr>
-              <a:t>02/06/2026</a:t>
+              <a:t>10/07/2026</a:t>
             </a:r>
           </a:p>
         </p:txBody>
@@ -8942,7 +8942,7 @@
                 </a:solidFill>
                 <a:latin typeface="Calibri"/>
               </a:rPr>
-              <a:t>96%</a:t>
+              <a:t>100%</a:t>
             </a:r>
           </a:p>
         </p:txBody>
@@ -9008,11 +9008,11 @@
             <a:r>
               <a:rPr sz="700" b="1">
                 <a:solidFill>
-                  <a:srgbClr val="EF4444"/>
+                  <a:srgbClr val="22C55E"/>
                 </a:solidFill>
                 <a:latin typeface="Calibri"/>
               </a:rPr>
-              <a:t>Atrasado</a:t>
+              <a:t>Terminado</a:t>
             </a:r>
           </a:p>
         </p:txBody>
@@ -9035,7 +9035,7 @@
           </a:prstGeom>
           <a:pattFill prst="smGrid">
             <a:fgClr>
-              <a:srgbClr val="EF4444"/>
+              <a:srgbClr val="22C55E"/>
             </a:fgClr>
             <a:bgClr>
               <a:srgbClr val="FFFFFF"/>
@@ -9077,7 +9077,7 @@
         <p:spPr>
           <a:xfrm>
             <a:off x="5806440" y="2369324"/>
-            <a:ext cx="1623974" cy="103098"/>
+            <a:ext cx="1691640" cy="103098"/>
           </a:xfrm>
           <a:prstGeom prst="roundRect">
             <a:avLst>
@@ -9085,14 +9085,14 @@
             </a:avLst>
           </a:prstGeom>
           <a:solidFill>
-            <a:srgbClr val="EF4444"/>
+            <a:srgbClr val="22C55E"/>
           </a:solidFill>
           <a:ln>
             <a:noFill/>
           </a:ln>
           <a:effectLst>
             <a:outerShdw blurRad="76200" dist="19050" dir="5400000" rotWithShape="0">
-              <a:srgbClr val="EF4444">
+              <a:srgbClr val="22C55E">
                 <a:alpha val="55000"/>
               </a:srgbClr>
             </a:outerShdw>
@@ -9146,11 +9146,11 @@
             <a:r>
               <a:rPr sz="800" b="1">
                 <a:solidFill>
-                  <a:srgbClr val="EF4444"/>
+                  <a:srgbClr val="22C55E"/>
                 </a:solidFill>
                 <a:latin typeface="Calibri"/>
               </a:rPr>
-              <a:t>96%</a:t>
+              <a:t>100%</a:t>
             </a:r>
           </a:p>
         </p:txBody>
@@ -9229,7 +9229,7 @@
                 </a:solidFill>
                 <a:latin typeface="Calibri"/>
               </a:rPr>
-              <a:t>Mejoras</a:t>
+              <a:t>Proyecto</a:t>
             </a:r>
           </a:p>
         </p:txBody>
@@ -9264,7 +9264,7 @@
                 </a:solidFill>
                 <a:latin typeface="Calibri"/>
               </a:rPr>
-              <a:t>Operaciones Fleet || Desarrollos</a:t>
+              <a:t>Operaciones Fleet || Nueva Instancia</a:t>
             </a:r>
           </a:p>
         </p:txBody>
@@ -9334,7 +9334,7 @@
                 </a:solidFill>
                 <a:latin typeface="Calibri"/>
               </a:rPr>
-              <a:t>05/06/2026</a:t>
+              <a:t>01/06/2026</a:t>
             </a:r>
           </a:p>
         </p:txBody>
@@ -9691,7 +9691,7 @@
                 </a:solidFill>
                 <a:latin typeface="Calibri"/>
               </a:rPr>
-              <a:t>Operaciones Fleet || Lobby Fix</a:t>
+              <a:t>Talleres || Integración Mecanica Mx - SAE</a:t>
             </a:r>
           </a:p>
         </p:txBody>
@@ -9726,7 +9726,7 @@
                 </a:solidFill>
                 <a:latin typeface="Calibri"/>
               </a:rPr>
-              <a:t>11/11/2025</a:t>
+              <a:t>20/04/2026</a:t>
             </a:r>
           </a:p>
         </p:txBody>
@@ -9761,7 +9761,7 @@
                 </a:solidFill>
                 <a:latin typeface="Calibri"/>
               </a:rPr>
-              <a:t>29/06/2026</a:t>
+              <a:t>20/07/2026</a:t>
             </a:r>
           </a:p>
         </p:txBody>
@@ -9796,7 +9796,7 @@
                 </a:solidFill>
                 <a:latin typeface="Calibri"/>
               </a:rPr>
-              <a:t>100%</a:t>
+              <a:t>91%</a:t>
             </a:r>
           </a:p>
         </p:txBody>
@@ -9862,11 +9862,11 @@
             <a:r>
               <a:rPr sz="700" b="1">
                 <a:solidFill>
-                  <a:srgbClr val="22C55E"/>
+                  <a:srgbClr val="EF4444"/>
                 </a:solidFill>
                 <a:latin typeface="Calibri"/>
               </a:rPr>
-              <a:t>Terminado</a:t>
+              <a:t>Atrasado</a:t>
             </a:r>
           </a:p>
         </p:txBody>
@@ -9889,7 +9889,7 @@
           </a:prstGeom>
           <a:pattFill prst="smGrid">
             <a:fgClr>
-              <a:srgbClr val="22C55E"/>
+              <a:srgbClr val="EF4444"/>
             </a:fgClr>
             <a:bgClr>
               <a:srgbClr val="FFFFFF"/>
@@ -9931,7 +9931,7 @@
         <p:spPr>
           <a:xfrm>
             <a:off x="5806440" y="2744228"/>
-            <a:ext cx="1691640" cy="103098"/>
+            <a:ext cx="1539392" cy="103098"/>
           </a:xfrm>
           <a:prstGeom prst="roundRect">
             <a:avLst>
@@ -9939,14 +9939,14 @@
             </a:avLst>
           </a:prstGeom>
           <a:solidFill>
-            <a:srgbClr val="22C55E"/>
+            <a:srgbClr val="EF4444"/>
           </a:solidFill>
           <a:ln>
             <a:noFill/>
           </a:ln>
           <a:effectLst>
             <a:outerShdw blurRad="76200" dist="19050" dir="5400000" rotWithShape="0">
-              <a:srgbClr val="22C55E">
+              <a:srgbClr val="EF4444">
                 <a:alpha val="55000"/>
               </a:srgbClr>
             </a:outerShdw>
@@ -10000,11 +10000,11 @@
             <a:r>
               <a:rPr sz="800" b="1">
                 <a:solidFill>
-                  <a:srgbClr val="22C55E"/>
+                  <a:srgbClr val="EF4444"/>
                 </a:solidFill>
                 <a:latin typeface="Calibri"/>
               </a:rPr>
-              <a:t>100%</a:t>
+              <a:t>91%</a:t>
             </a:r>
           </a:p>
         </p:txBody>
@@ -10118,7 +10118,7 @@
                 </a:solidFill>
                 <a:latin typeface="Calibri"/>
               </a:rPr>
-              <a:t>Operaciones Fleet || Nexcar || Desarrollos</a:t>
+              <a:t>Contabilidad || Integración Mecanica-SAE (Fase…</a:t>
             </a:r>
           </a:p>
         </p:txBody>
@@ -10153,7 +10153,7 @@
                 </a:solidFill>
                 <a:latin typeface="Calibri"/>
               </a:rPr>
-              <a:t>05/03/2026</a:t>
+              <a:t>21/04/2026</a:t>
             </a:r>
           </a:p>
         </p:txBody>
@@ -10188,7 +10188,7 @@
                 </a:solidFill>
                 <a:latin typeface="Calibri"/>
               </a:rPr>
-              <a:t>10/07/2026</a:t>
+              <a:t>12/06/2026</a:t>
             </a:r>
           </a:p>
         </p:txBody>
@@ -10223,7 +10223,7 @@
                 </a:solidFill>
                 <a:latin typeface="Calibri"/>
               </a:rPr>
-              <a:t>100%</a:t>
+              <a:t>99%</a:t>
             </a:r>
           </a:p>
         </p:txBody>
@@ -10289,11 +10289,11 @@
             <a:r>
               <a:rPr sz="700" b="1">
                 <a:solidFill>
-                  <a:srgbClr val="22C55E"/>
+                  <a:srgbClr val="EF4444"/>
                 </a:solidFill>
                 <a:latin typeface="Calibri"/>
               </a:rPr>
-              <a:t>Terminado</a:t>
+              <a:t>Atrasado</a:t>
             </a:r>
           </a:p>
         </p:txBody>
@@ -10316,7 +10316,7 @@
           </a:prstGeom>
           <a:pattFill prst="smGrid">
             <a:fgClr>
-              <a:srgbClr val="22C55E"/>
+              <a:srgbClr val="EF4444"/>
             </a:fgClr>
             <a:bgClr>
               <a:srgbClr val="FFFFFF"/>
@@ -10358,7 +10358,7 @@
         <p:spPr>
           <a:xfrm>
             <a:off x="5806440" y="2931680"/>
-            <a:ext cx="1691640" cy="103098"/>
+            <a:ext cx="1674723" cy="103098"/>
           </a:xfrm>
           <a:prstGeom prst="roundRect">
             <a:avLst>
@@ -10366,14 +10366,14 @@
             </a:avLst>
           </a:prstGeom>
           <a:solidFill>
-            <a:srgbClr val="22C55E"/>
+            <a:srgbClr val="EF4444"/>
           </a:solidFill>
           <a:ln>
             <a:noFill/>
           </a:ln>
           <a:effectLst>
             <a:outerShdw blurRad="76200" dist="19050" dir="5400000" rotWithShape="0">
-              <a:srgbClr val="22C55E">
+              <a:srgbClr val="EF4444">
                 <a:alpha val="55000"/>
               </a:srgbClr>
             </a:outerShdw>
@@ -10427,11 +10427,11 @@
             <a:r>
               <a:rPr sz="800" b="1">
                 <a:solidFill>
-                  <a:srgbClr val="22C55E"/>
+                  <a:srgbClr val="EF4444"/>
                 </a:solidFill>
                 <a:latin typeface="Calibri"/>
               </a:rPr>
-              <a:t>100%</a:t>
+              <a:t>99%</a:t>
             </a:r>
           </a:p>
         </p:txBody>
@@ -10545,7 +10545,7 @@
                 </a:solidFill>
                 <a:latin typeface="Calibri"/>
               </a:rPr>
-              <a:t>Operaciones Fleet || Data Lab</a:t>
+              <a:t>DTI || Integración de sistemas</a:t>
             </a:r>
           </a:p>
         </p:txBody>
@@ -10580,7 +10580,7 @@
                 </a:solidFill>
                 <a:latin typeface="Calibri"/>
               </a:rPr>
-              <a:t>20/01/2026</a:t>
+              <a:t>01/06/2026</a:t>
             </a:r>
           </a:p>
         </p:txBody>
@@ -10615,7 +10615,7 @@
                 </a:solidFill>
                 <a:latin typeface="Calibri"/>
               </a:rPr>
-              <a:t>22/06/2026</a:t>
+              <a:t>09/10/2026</a:t>
             </a:r>
           </a:p>
         </p:txBody>
@@ -10650,7 +10650,7 @@
                 </a:solidFill>
                 <a:latin typeface="Calibri"/>
               </a:rPr>
-              <a:t>100%</a:t>
+              <a:t>46%</a:t>
             </a:r>
           </a:p>
         </p:txBody>
@@ -10685,7 +10685,7 @@
                 </a:solidFill>
                 <a:latin typeface="Calibri"/>
               </a:rPr>
-              <a:t>100%</a:t>
+              <a:t>46%</a:t>
             </a:r>
           </a:p>
         </p:txBody>
@@ -10720,7 +10720,7 @@
                 </a:solidFill>
                 <a:latin typeface="Calibri"/>
               </a:rPr>
-              <a:t>Terminado</a:t>
+              <a:t>A tiempo</a:t>
             </a:r>
           </a:p>
         </p:txBody>
@@ -10785,7 +10785,7 @@
         <p:spPr>
           <a:xfrm>
             <a:off x="5806440" y="3119132"/>
-            <a:ext cx="1691640" cy="103098"/>
+            <a:ext cx="778154" cy="103098"/>
           </a:xfrm>
           <a:prstGeom prst="roundRect">
             <a:avLst>
@@ -10858,7 +10858,7 @@
                 </a:solidFill>
                 <a:latin typeface="Calibri"/>
               </a:rPr>
-              <a:t>100%</a:t>
+              <a:t>46%</a:t>
             </a:r>
           </a:p>
         </p:txBody>
@@ -10937,7 +10937,7 @@
                 </a:solidFill>
                 <a:latin typeface="Calibri"/>
               </a:rPr>
-              <a:t>Proyecto</a:t>
+              <a:t>Mejoras</a:t>
             </a:r>
           </a:p>
         </p:txBody>
@@ -10972,7 +10972,7 @@
                 </a:solidFill>
                 <a:latin typeface="Calibri"/>
               </a:rPr>
-              <a:t>Cartera || Cambio de Pac de Timbrado</a:t>
+              <a:t>Capital Humano || BUK Personalizados Fase 2</a:t>
             </a:r>
           </a:p>
         </p:txBody>
@@ -11007,7 +11007,7 @@
                 </a:solidFill>
                 <a:latin typeface="Calibri"/>
               </a:rPr>
-              <a:t>07/07/2025</a:t>
+              <a:t>08/06/2026</a:t>
             </a:r>
           </a:p>
         </p:txBody>
@@ -11042,7 +11042,7 @@
                 </a:solidFill>
                 <a:latin typeface="Calibri"/>
               </a:rPr>
-              <a:t>25/02/2026</a:t>
+              <a:t>06/08/2026</a:t>
             </a:r>
           </a:p>
         </p:txBody>
@@ -11077,7 +11077,7 @@
                 </a:solidFill>
                 <a:latin typeface="Calibri"/>
               </a:rPr>
-              <a:t>100%</a:t>
+              <a:t>91%</a:t>
             </a:r>
           </a:p>
         </p:txBody>
@@ -11112,7 +11112,7 @@
                 </a:solidFill>
                 <a:latin typeface="Calibri"/>
               </a:rPr>
-              <a:t>100%</a:t>
+              <a:t>89%</a:t>
             </a:r>
           </a:p>
         </p:txBody>
@@ -11147,7 +11147,7 @@
                 </a:solidFill>
                 <a:latin typeface="Calibri"/>
               </a:rPr>
-              <a:t>Terminado</a:t>
+              <a:t>A tiempo</a:t>
             </a:r>
           </a:p>
         </p:txBody>
@@ -11212,7 +11212,7 @@
         <p:spPr>
           <a:xfrm>
             <a:off x="5806440" y="3306584"/>
-            <a:ext cx="1691640" cy="103098"/>
+            <a:ext cx="1539392" cy="103098"/>
           </a:xfrm>
           <a:prstGeom prst="roundRect">
             <a:avLst>
@@ -11285,7 +11285,7 @@
                 </a:solidFill>
                 <a:latin typeface="Calibri"/>
               </a:rPr>
-              <a:t>100%</a:t>
+              <a:t>91%</a:t>
             </a:r>
           </a:p>
         </p:txBody>
@@ -11364,7 +11364,7 @@
                 </a:solidFill>
                 <a:latin typeface="Calibri"/>
               </a:rPr>
-              <a:t>Proyecto</a:t>
+              <a:t>Mejoras</a:t>
             </a:r>
           </a:p>
         </p:txBody>
@@ -11399,7 +11399,7 @@
                 </a:solidFill>
                 <a:latin typeface="Calibri"/>
               </a:rPr>
-              <a:t>Operaciones Fleet || Nueva Instancia</a:t>
+              <a:t>Operaciones Fleet || Adcontent - Sfleet</a:t>
             </a:r>
           </a:p>
         </p:txBody>
@@ -11434,7 +11434,7 @@
                 </a:solidFill>
                 <a:latin typeface="Calibri"/>
               </a:rPr>
-              <a:t>08/08/2025</a:t>
+              <a:t>15/06/2026</a:t>
             </a:r>
           </a:p>
         </p:txBody>
@@ -11469,7 +11469,7 @@
                 </a:solidFill>
                 <a:latin typeface="Calibri"/>
               </a:rPr>
-              <a:t>01/06/2026</a:t>
+              <a:t>17/05/2027</a:t>
             </a:r>
           </a:p>
         </p:txBody>
@@ -11504,7 +11504,7 @@
                 </a:solidFill>
                 <a:latin typeface="Calibri"/>
               </a:rPr>
-              <a:t>100%</a:t>
+              <a:t>17%</a:t>
             </a:r>
           </a:p>
         </p:txBody>
@@ -11539,7 +11539,7 @@
                 </a:solidFill>
                 <a:latin typeface="Calibri"/>
               </a:rPr>
-              <a:t>100%</a:t>
+              <a:t>13%</a:t>
             </a:r>
           </a:p>
         </p:txBody>
@@ -11574,7 +11574,7 @@
                 </a:solidFill>
                 <a:latin typeface="Calibri"/>
               </a:rPr>
-              <a:t>Terminado</a:t>
+              <a:t>A tiempo</a:t>
             </a:r>
           </a:p>
         </p:txBody>
@@ -11639,7 +11639,7 @@
         <p:spPr>
           <a:xfrm>
             <a:off x="5806440" y="3494036"/>
-            <a:ext cx="1691640" cy="103098"/>
+            <a:ext cx="287578" cy="103098"/>
           </a:xfrm>
           <a:prstGeom prst="roundRect">
             <a:avLst>
@@ -11712,2569 +11712,7 @@
                 </a:solidFill>
                 <a:latin typeface="Calibri"/>
               </a:rPr>
-              <a:t>100%</a:t>
-            </a:r>
-          </a:p>
-        </p:txBody>
-      </p:sp>
-      <p:sp>
-        <p:nvSpPr>
-          <p:cNvPr id="167" name="Rectangle 166"/>
-          <p:cNvSpPr/>
-          <p:nvPr/>
-        </p:nvSpPr>
-        <p:spPr>
-          <a:xfrm>
-            <a:off x="73152" y="3639312"/>
-            <a:ext cx="8741664" cy="187452"/>
-          </a:xfrm>
-          <a:prstGeom prst="rect">
-            <a:avLst/>
-          </a:prstGeom>
-          <a:solidFill>
-            <a:srgbClr val="F5F7FA"/>
-          </a:solidFill>
-          <a:ln>
-            <a:noFill/>
-          </a:ln>
-          <a:effectLst/>
-        </p:spPr>
-        <p:style>
-          <a:lnRef idx="1">
-            <a:schemeClr val="accent1"/>
-          </a:lnRef>
-          <a:fillRef idx="3">
-            <a:schemeClr val="accent1"/>
-          </a:fillRef>
-          <a:effectRef idx="2">
-            <a:schemeClr val="accent1"/>
-          </a:effectRef>
-          <a:fontRef idx="minor">
-            <a:schemeClr val="lt1"/>
-          </a:fontRef>
-        </p:style>
-        <p:txBody>
-          <a:bodyPr rtlCol="0" anchor="ctr"/>
-          <a:lstStyle/>
-          <a:p>
-            <a:pPr algn="ctr"/>
-          </a:p>
-        </p:txBody>
-      </p:sp>
-      <p:sp>
-        <p:nvSpPr>
-          <p:cNvPr id="168" name="TextBox 167"/>
-          <p:cNvSpPr txBox="1"/>
-          <p:nvPr/>
-        </p:nvSpPr>
-        <p:spPr>
-          <a:xfrm>
-            <a:off x="91440" y="3639312"/>
-            <a:ext cx="722375" cy="187452"/>
-          </a:xfrm>
-          <a:prstGeom prst="rect">
-            <a:avLst/>
-          </a:prstGeom>
-          <a:noFill/>
-        </p:spPr>
-        <p:txBody>
-          <a:bodyPr wrap="none" lIns="0" rIns="0" tIns="0" bIns="0" anchor="ctr">
-            <a:spAutoFit/>
-          </a:bodyPr>
-          <a:lstStyle/>
-          <a:p>
-            <a:pPr algn="ctr"/>
-            <a:r>
-              <a:rPr sz="700" b="1">
-                <a:solidFill>
-                  <a:srgbClr val="1A2340"/>
-                </a:solidFill>
-                <a:latin typeface="Calibri"/>
-              </a:rPr>
-              <a:t>Mejoras</a:t>
-            </a:r>
-          </a:p>
-        </p:txBody>
-      </p:sp>
-      <p:sp>
-        <p:nvSpPr>
-          <p:cNvPr id="169" name="TextBox 168"/>
-          <p:cNvSpPr txBox="1"/>
-          <p:nvPr/>
-        </p:nvSpPr>
-        <p:spPr>
-          <a:xfrm>
-            <a:off x="850392" y="3639312"/>
-            <a:ext cx="2432304" cy="187452"/>
-          </a:xfrm>
-          <a:prstGeom prst="rect">
-            <a:avLst/>
-          </a:prstGeom>
-          <a:noFill/>
-        </p:spPr>
-        <p:txBody>
-          <a:bodyPr wrap="none" lIns="0" rIns="0" tIns="0" bIns="0" anchor="ctr">
-            <a:spAutoFit/>
-          </a:bodyPr>
-          <a:lstStyle/>
-          <a:p>
-            <a:pPr algn="l"/>
-            <a:r>
-              <a:rPr sz="700" b="0">
-                <a:solidFill>
-                  <a:srgbClr val="1A2340"/>
-                </a:solidFill>
-                <a:latin typeface="Calibri"/>
-              </a:rPr>
-              <a:t>Tesoreria || Adcontent H2H</a:t>
-            </a:r>
-          </a:p>
-        </p:txBody>
-      </p:sp>
-      <p:sp>
-        <p:nvSpPr>
-          <p:cNvPr id="170" name="TextBox 169"/>
-          <p:cNvSpPr txBox="1"/>
-          <p:nvPr/>
-        </p:nvSpPr>
-        <p:spPr>
-          <a:xfrm>
-            <a:off x="3319272" y="3639312"/>
-            <a:ext cx="630936" cy="187452"/>
-          </a:xfrm>
-          <a:prstGeom prst="rect">
-            <a:avLst/>
-          </a:prstGeom>
-          <a:noFill/>
-        </p:spPr>
-        <p:txBody>
-          <a:bodyPr wrap="none" lIns="0" rIns="0" tIns="0" bIns="0" anchor="ctr">
-            <a:spAutoFit/>
-          </a:bodyPr>
-          <a:lstStyle/>
-          <a:p>
-            <a:pPr algn="ctr"/>
-            <a:r>
-              <a:rPr sz="700" b="0">
-                <a:solidFill>
-                  <a:srgbClr val="555555"/>
-                </a:solidFill>
-                <a:latin typeface="Calibri"/>
-              </a:rPr>
-              <a:t>07/04/2026</a:t>
-            </a:r>
-          </a:p>
-        </p:txBody>
-      </p:sp>
-      <p:sp>
-        <p:nvSpPr>
-          <p:cNvPr id="171" name="TextBox 170"/>
-          <p:cNvSpPr txBox="1"/>
-          <p:nvPr/>
-        </p:nvSpPr>
-        <p:spPr>
-          <a:xfrm>
-            <a:off x="3986783" y="3639312"/>
-            <a:ext cx="630936" cy="187452"/>
-          </a:xfrm>
-          <a:prstGeom prst="rect">
-            <a:avLst/>
-          </a:prstGeom>
-          <a:noFill/>
-        </p:spPr>
-        <p:txBody>
-          <a:bodyPr wrap="none" lIns="0" rIns="0" tIns="0" bIns="0" anchor="ctr">
-            <a:spAutoFit/>
-          </a:bodyPr>
-          <a:lstStyle/>
-          <a:p>
-            <a:pPr algn="ctr"/>
-            <a:r>
-              <a:rPr sz="700" b="0">
-                <a:solidFill>
-                  <a:srgbClr val="555555"/>
-                </a:solidFill>
-                <a:latin typeface="Calibri"/>
-              </a:rPr>
-              <a:t>26/08/2026</a:t>
-            </a:r>
-          </a:p>
-        </p:txBody>
-      </p:sp>
-      <p:sp>
-        <p:nvSpPr>
-          <p:cNvPr id="172" name="TextBox 171"/>
-          <p:cNvSpPr txBox="1"/>
-          <p:nvPr/>
-        </p:nvSpPr>
-        <p:spPr>
-          <a:xfrm>
-            <a:off x="4654296" y="3639312"/>
-            <a:ext cx="493775" cy="187452"/>
-          </a:xfrm>
-          <a:prstGeom prst="rect">
-            <a:avLst/>
-          </a:prstGeom>
-          <a:noFill/>
-        </p:spPr>
-        <p:txBody>
-          <a:bodyPr wrap="none" lIns="0" rIns="0" tIns="0" bIns="0" anchor="ctr">
-            <a:spAutoFit/>
-          </a:bodyPr>
-          <a:lstStyle/>
-          <a:p>
-            <a:pPr algn="ctr"/>
-            <a:r>
-              <a:rPr sz="700" b="1">
-                <a:solidFill>
-                  <a:srgbClr val="1A2340"/>
-                </a:solidFill>
-                <a:latin typeface="Calibri"/>
-              </a:rPr>
-              <a:t>22%</a:t>
-            </a:r>
-          </a:p>
-        </p:txBody>
-      </p:sp>
-      <p:sp>
-        <p:nvSpPr>
-          <p:cNvPr id="173" name="TextBox 172"/>
-          <p:cNvSpPr txBox="1"/>
-          <p:nvPr/>
-        </p:nvSpPr>
-        <p:spPr>
-          <a:xfrm>
-            <a:off x="5184648" y="3639312"/>
-            <a:ext cx="557784" cy="187452"/>
-          </a:xfrm>
-          <a:prstGeom prst="rect">
-            <a:avLst/>
-          </a:prstGeom>
-          <a:noFill/>
-        </p:spPr>
-        <p:txBody>
-          <a:bodyPr wrap="none" lIns="0" rIns="0" tIns="0" bIns="0" anchor="ctr">
-            <a:spAutoFit/>
-          </a:bodyPr>
-          <a:lstStyle/>
-          <a:p>
-            <a:pPr algn="ctr"/>
-            <a:r>
-              <a:rPr sz="700" b="0">
-                <a:solidFill>
-                  <a:srgbClr val="555555"/>
-                </a:solidFill>
-                <a:latin typeface="Calibri"/>
-              </a:rPr>
-              <a:t>70%</a:t>
-            </a:r>
-          </a:p>
-        </p:txBody>
-      </p:sp>
-      <p:sp>
-        <p:nvSpPr>
-          <p:cNvPr id="174" name="TextBox 173"/>
-          <p:cNvSpPr txBox="1"/>
-          <p:nvPr/>
-        </p:nvSpPr>
-        <p:spPr>
-          <a:xfrm>
-            <a:off x="7991856" y="3639312"/>
-            <a:ext cx="804672" cy="187452"/>
-          </a:xfrm>
-          <a:prstGeom prst="rect">
-            <a:avLst/>
-          </a:prstGeom>
-          <a:noFill/>
-        </p:spPr>
-        <p:txBody>
-          <a:bodyPr wrap="none" lIns="0" rIns="0" tIns="0" bIns="0" anchor="ctr">
-            <a:spAutoFit/>
-          </a:bodyPr>
-          <a:lstStyle/>
-          <a:p>
-            <a:pPr algn="ctr"/>
-            <a:r>
-              <a:rPr sz="700" b="1">
-                <a:solidFill>
-                  <a:srgbClr val="EF4444"/>
-                </a:solidFill>
-                <a:latin typeface="Calibri"/>
-              </a:rPr>
-              <a:t>Atrasado</a:t>
-            </a:r>
-          </a:p>
-        </p:txBody>
-      </p:sp>
-      <p:sp>
-        <p:nvSpPr>
-          <p:cNvPr id="175" name="Rounded Rectangle 174"/>
-          <p:cNvSpPr/>
-          <p:nvPr/>
-        </p:nvSpPr>
-        <p:spPr>
-          <a:xfrm>
-            <a:off x="5806440" y="3681488"/>
-            <a:ext cx="1691640" cy="103098"/>
-          </a:xfrm>
-          <a:prstGeom prst="roundRect">
-            <a:avLst>
-              <a:gd name="adj" fmla="val 50000"/>
-            </a:avLst>
-          </a:prstGeom>
-          <a:pattFill prst="smGrid">
-            <a:fgClr>
-              <a:srgbClr val="EF4444"/>
-            </a:fgClr>
-            <a:bgClr>
-              <a:srgbClr val="FFFFFF"/>
-            </a:bgClr>
-          </a:pattFill>
-          <a:ln>
-            <a:noFill/>
-          </a:ln>
-          <a:effectLst/>
-        </p:spPr>
-        <p:style>
-          <a:lnRef idx="1">
-            <a:schemeClr val="accent1"/>
-          </a:lnRef>
-          <a:fillRef idx="3">
-            <a:schemeClr val="accent1"/>
-          </a:fillRef>
-          <a:effectRef idx="2">
-            <a:schemeClr val="accent1"/>
-          </a:effectRef>
-          <a:fontRef idx="minor">
-            <a:schemeClr val="lt1"/>
-          </a:fontRef>
-        </p:style>
-        <p:txBody>
-          <a:bodyPr rtlCol="0" anchor="ctr"/>
-          <a:lstStyle/>
-          <a:p>
-            <a:pPr algn="ctr"/>
-          </a:p>
-        </p:txBody>
-      </p:sp>
-      <p:sp>
-        <p:nvSpPr>
-          <p:cNvPr id="176" name="Rounded Rectangle 175"/>
-          <p:cNvSpPr/>
-          <p:nvPr/>
-        </p:nvSpPr>
-        <p:spPr>
-          <a:xfrm>
-            <a:off x="5806440" y="3681488"/>
-            <a:ext cx="372160" cy="103098"/>
-          </a:xfrm>
-          <a:prstGeom prst="roundRect">
-            <a:avLst>
-              <a:gd name="adj" fmla="val 50000"/>
-            </a:avLst>
-          </a:prstGeom>
-          <a:solidFill>
-            <a:srgbClr val="EF4444"/>
-          </a:solidFill>
-          <a:ln>
-            <a:noFill/>
-          </a:ln>
-          <a:effectLst>
-            <a:outerShdw blurRad="76200" dist="19050" dir="5400000" rotWithShape="0">
-              <a:srgbClr val="EF4444">
-                <a:alpha val="55000"/>
-              </a:srgbClr>
-            </a:outerShdw>
-          </a:effectLst>
-        </p:spPr>
-        <p:style>
-          <a:lnRef idx="1">
-            <a:schemeClr val="accent1"/>
-          </a:lnRef>
-          <a:fillRef idx="3">
-            <a:schemeClr val="accent1"/>
-          </a:fillRef>
-          <a:effectRef idx="2">
-            <a:schemeClr val="accent1"/>
-          </a:effectRef>
-          <a:fontRef idx="minor">
-            <a:schemeClr val="lt1"/>
-          </a:fontRef>
-        </p:style>
-        <p:txBody>
-          <a:bodyPr rtlCol="0" anchor="ctr"/>
-          <a:lstStyle/>
-          <a:p>
-            <a:pPr algn="ctr"/>
-          </a:p>
-        </p:txBody>
-      </p:sp>
-      <p:sp>
-        <p:nvSpPr>
-          <p:cNvPr id="177" name="TextBox 176"/>
-          <p:cNvSpPr txBox="1"/>
-          <p:nvPr/>
-        </p:nvSpPr>
-        <p:spPr>
-          <a:xfrm>
-            <a:off x="7543800" y="3649484"/>
-            <a:ext cx="457200" cy="167106"/>
-          </a:xfrm>
-          <a:prstGeom prst="rect">
-            <a:avLst/>
-          </a:prstGeom>
-          <a:noFill/>
-        </p:spPr>
-        <p:txBody>
-          <a:bodyPr wrap="none" lIns="0" rIns="0" tIns="0" bIns="0">
-            <a:spAutoFit/>
-          </a:bodyPr>
-          <a:lstStyle/>
-          <a:p>
-            <a:pPr algn="l"/>
-            <a:r>
-              <a:rPr sz="800" b="1">
-                <a:solidFill>
-                  <a:srgbClr val="EF4444"/>
-                </a:solidFill>
-                <a:latin typeface="Calibri"/>
-              </a:rPr>
-              <a:t>22%</a:t>
-            </a:r>
-          </a:p>
-        </p:txBody>
-      </p:sp>
-      <p:sp>
-        <p:nvSpPr>
-          <p:cNvPr id="178" name="Rectangle 177"/>
-          <p:cNvSpPr/>
-          <p:nvPr/>
-        </p:nvSpPr>
-        <p:spPr>
-          <a:xfrm>
-            <a:off x="73152" y="3826764"/>
-            <a:ext cx="8741664" cy="187452"/>
-          </a:xfrm>
-          <a:prstGeom prst="rect">
-            <a:avLst/>
-          </a:prstGeom>
-          <a:solidFill>
-            <a:srgbClr val="FFFFFF"/>
-          </a:solidFill>
-          <a:ln>
-            <a:noFill/>
-          </a:ln>
-          <a:effectLst/>
-        </p:spPr>
-        <p:style>
-          <a:lnRef idx="1">
-            <a:schemeClr val="accent1"/>
-          </a:lnRef>
-          <a:fillRef idx="3">
-            <a:schemeClr val="accent1"/>
-          </a:fillRef>
-          <a:effectRef idx="2">
-            <a:schemeClr val="accent1"/>
-          </a:effectRef>
-          <a:fontRef idx="minor">
-            <a:schemeClr val="lt1"/>
-          </a:fontRef>
-        </p:style>
-        <p:txBody>
-          <a:bodyPr rtlCol="0" anchor="ctr"/>
-          <a:lstStyle/>
-          <a:p>
-            <a:pPr algn="ctr"/>
-          </a:p>
-        </p:txBody>
-      </p:sp>
-      <p:sp>
-        <p:nvSpPr>
-          <p:cNvPr id="179" name="TextBox 178"/>
-          <p:cNvSpPr txBox="1"/>
-          <p:nvPr/>
-        </p:nvSpPr>
-        <p:spPr>
-          <a:xfrm>
-            <a:off x="91440" y="3826764"/>
-            <a:ext cx="722375" cy="187452"/>
-          </a:xfrm>
-          <a:prstGeom prst="rect">
-            <a:avLst/>
-          </a:prstGeom>
-          <a:noFill/>
-        </p:spPr>
-        <p:txBody>
-          <a:bodyPr wrap="none" lIns="0" rIns="0" tIns="0" bIns="0" anchor="ctr">
-            <a:spAutoFit/>
-          </a:bodyPr>
-          <a:lstStyle/>
-          <a:p>
-            <a:pPr algn="ctr"/>
-            <a:r>
-              <a:rPr sz="700" b="1">
-                <a:solidFill>
-                  <a:srgbClr val="1A2340"/>
-                </a:solidFill>
-                <a:latin typeface="Calibri"/>
-              </a:rPr>
-              <a:t>Proyecto</a:t>
-            </a:r>
-          </a:p>
-        </p:txBody>
-      </p:sp>
-      <p:sp>
-        <p:nvSpPr>
-          <p:cNvPr id="180" name="TextBox 179"/>
-          <p:cNvSpPr txBox="1"/>
-          <p:nvPr/>
-        </p:nvSpPr>
-        <p:spPr>
-          <a:xfrm>
-            <a:off x="850392" y="3826764"/>
-            <a:ext cx="2432304" cy="187452"/>
-          </a:xfrm>
-          <a:prstGeom prst="rect">
-            <a:avLst/>
-          </a:prstGeom>
-          <a:noFill/>
-        </p:spPr>
-        <p:txBody>
-          <a:bodyPr wrap="none" lIns="0" rIns="0" tIns="0" bIns="0" anchor="ctr">
-            <a:spAutoFit/>
-          </a:bodyPr>
-          <a:lstStyle/>
-          <a:p>
-            <a:pPr algn="l"/>
-            <a:r>
-              <a:rPr sz="700" b="0">
-                <a:solidFill>
-                  <a:srgbClr val="1A2340"/>
-                </a:solidFill>
-                <a:latin typeface="Calibri"/>
-              </a:rPr>
-              <a:t>Talleres || Integración Mecanica Mx - SAE</a:t>
-            </a:r>
-          </a:p>
-        </p:txBody>
-      </p:sp>
-      <p:sp>
-        <p:nvSpPr>
-          <p:cNvPr id="181" name="TextBox 180"/>
-          <p:cNvSpPr txBox="1"/>
-          <p:nvPr/>
-        </p:nvSpPr>
-        <p:spPr>
-          <a:xfrm>
-            <a:off x="3319272" y="3826764"/>
-            <a:ext cx="630936" cy="187452"/>
-          </a:xfrm>
-          <a:prstGeom prst="rect">
-            <a:avLst/>
-          </a:prstGeom>
-          <a:noFill/>
-        </p:spPr>
-        <p:txBody>
-          <a:bodyPr wrap="none" lIns="0" rIns="0" tIns="0" bIns="0" anchor="ctr">
-            <a:spAutoFit/>
-          </a:bodyPr>
-          <a:lstStyle/>
-          <a:p>
-            <a:pPr algn="ctr"/>
-            <a:r>
-              <a:rPr sz="700" b="0">
-                <a:solidFill>
-                  <a:srgbClr val="555555"/>
-                </a:solidFill>
-                <a:latin typeface="Calibri"/>
-              </a:rPr>
-              <a:t>20/04/2026</a:t>
-            </a:r>
-          </a:p>
-        </p:txBody>
-      </p:sp>
-      <p:sp>
-        <p:nvSpPr>
-          <p:cNvPr id="182" name="TextBox 181"/>
-          <p:cNvSpPr txBox="1"/>
-          <p:nvPr/>
-        </p:nvSpPr>
-        <p:spPr>
-          <a:xfrm>
-            <a:off x="3986783" y="3826764"/>
-            <a:ext cx="630936" cy="187452"/>
-          </a:xfrm>
-          <a:prstGeom prst="rect">
-            <a:avLst/>
-          </a:prstGeom>
-          <a:noFill/>
-        </p:spPr>
-        <p:txBody>
-          <a:bodyPr wrap="none" lIns="0" rIns="0" tIns="0" bIns="0" anchor="ctr">
-            <a:spAutoFit/>
-          </a:bodyPr>
-          <a:lstStyle/>
-          <a:p>
-            <a:pPr algn="ctr"/>
-            <a:r>
-              <a:rPr sz="700" b="0">
-                <a:solidFill>
-                  <a:srgbClr val="555555"/>
-                </a:solidFill>
-                <a:latin typeface="Calibri"/>
-              </a:rPr>
-              <a:t>20/07/2026</a:t>
-            </a:r>
-          </a:p>
-        </p:txBody>
-      </p:sp>
-      <p:sp>
-        <p:nvSpPr>
-          <p:cNvPr id="183" name="TextBox 182"/>
-          <p:cNvSpPr txBox="1"/>
-          <p:nvPr/>
-        </p:nvSpPr>
-        <p:spPr>
-          <a:xfrm>
-            <a:off x="4654296" y="3826764"/>
-            <a:ext cx="493775" cy="187452"/>
-          </a:xfrm>
-          <a:prstGeom prst="rect">
-            <a:avLst/>
-          </a:prstGeom>
-          <a:noFill/>
-        </p:spPr>
-        <p:txBody>
-          <a:bodyPr wrap="none" lIns="0" rIns="0" tIns="0" bIns="0" anchor="ctr">
-            <a:spAutoFit/>
-          </a:bodyPr>
-          <a:lstStyle/>
-          <a:p>
-            <a:pPr algn="ctr"/>
-            <a:r>
-              <a:rPr sz="700" b="1">
-                <a:solidFill>
-                  <a:srgbClr val="1A2340"/>
-                </a:solidFill>
-                <a:latin typeface="Calibri"/>
-              </a:rPr>
-              <a:t>91%</a:t>
-            </a:r>
-          </a:p>
-        </p:txBody>
-      </p:sp>
-      <p:sp>
-        <p:nvSpPr>
-          <p:cNvPr id="184" name="TextBox 183"/>
-          <p:cNvSpPr txBox="1"/>
-          <p:nvPr/>
-        </p:nvSpPr>
-        <p:spPr>
-          <a:xfrm>
-            <a:off x="5184648" y="3826764"/>
-            <a:ext cx="557784" cy="187452"/>
-          </a:xfrm>
-          <a:prstGeom prst="rect">
-            <a:avLst/>
-          </a:prstGeom>
-          <a:noFill/>
-        </p:spPr>
-        <p:txBody>
-          <a:bodyPr wrap="none" lIns="0" rIns="0" tIns="0" bIns="0" anchor="ctr">
-            <a:spAutoFit/>
-          </a:bodyPr>
-          <a:lstStyle/>
-          <a:p>
-            <a:pPr algn="ctr"/>
-            <a:r>
-              <a:rPr sz="700" b="0">
-                <a:solidFill>
-                  <a:srgbClr val="555555"/>
-                </a:solidFill>
-                <a:latin typeface="Calibri"/>
-              </a:rPr>
-              <a:t>94%</a:t>
-            </a:r>
-          </a:p>
-        </p:txBody>
-      </p:sp>
-      <p:sp>
-        <p:nvSpPr>
-          <p:cNvPr id="185" name="TextBox 184"/>
-          <p:cNvSpPr txBox="1"/>
-          <p:nvPr/>
-        </p:nvSpPr>
-        <p:spPr>
-          <a:xfrm>
-            <a:off x="7991856" y="3826764"/>
-            <a:ext cx="804672" cy="187452"/>
-          </a:xfrm>
-          <a:prstGeom prst="rect">
-            <a:avLst/>
-          </a:prstGeom>
-          <a:noFill/>
-        </p:spPr>
-        <p:txBody>
-          <a:bodyPr wrap="none" lIns="0" rIns="0" tIns="0" bIns="0" anchor="ctr">
-            <a:spAutoFit/>
-          </a:bodyPr>
-          <a:lstStyle/>
-          <a:p>
-            <a:pPr algn="ctr"/>
-            <a:r>
-              <a:rPr sz="700" b="1">
-                <a:solidFill>
-                  <a:srgbClr val="F59E0B"/>
-                </a:solidFill>
-                <a:latin typeface="Calibri"/>
-              </a:rPr>
-              <a:t>Riesgo de atraso</a:t>
-            </a:r>
-          </a:p>
-        </p:txBody>
-      </p:sp>
-      <p:sp>
-        <p:nvSpPr>
-          <p:cNvPr id="186" name="Rounded Rectangle 185"/>
-          <p:cNvSpPr/>
-          <p:nvPr/>
-        </p:nvSpPr>
-        <p:spPr>
-          <a:xfrm>
-            <a:off x="5806440" y="3868940"/>
-            <a:ext cx="1691640" cy="103098"/>
-          </a:xfrm>
-          <a:prstGeom prst="roundRect">
-            <a:avLst>
-              <a:gd name="adj" fmla="val 50000"/>
-            </a:avLst>
-          </a:prstGeom>
-          <a:pattFill prst="smGrid">
-            <a:fgClr>
-              <a:srgbClr val="F59E0B"/>
-            </a:fgClr>
-            <a:bgClr>
-              <a:srgbClr val="FFFFFF"/>
-            </a:bgClr>
-          </a:pattFill>
-          <a:ln>
-            <a:noFill/>
-          </a:ln>
-          <a:effectLst/>
-        </p:spPr>
-        <p:style>
-          <a:lnRef idx="1">
-            <a:schemeClr val="accent1"/>
-          </a:lnRef>
-          <a:fillRef idx="3">
-            <a:schemeClr val="accent1"/>
-          </a:fillRef>
-          <a:effectRef idx="2">
-            <a:schemeClr val="accent1"/>
-          </a:effectRef>
-          <a:fontRef idx="minor">
-            <a:schemeClr val="lt1"/>
-          </a:fontRef>
-        </p:style>
-        <p:txBody>
-          <a:bodyPr rtlCol="0" anchor="ctr"/>
-          <a:lstStyle/>
-          <a:p>
-            <a:pPr algn="ctr"/>
-          </a:p>
-        </p:txBody>
-      </p:sp>
-      <p:sp>
-        <p:nvSpPr>
-          <p:cNvPr id="187" name="Rounded Rectangle 186"/>
-          <p:cNvSpPr/>
-          <p:nvPr/>
-        </p:nvSpPr>
-        <p:spPr>
-          <a:xfrm>
-            <a:off x="5806440" y="3868940"/>
-            <a:ext cx="1539392" cy="103098"/>
-          </a:xfrm>
-          <a:prstGeom prst="roundRect">
-            <a:avLst>
-              <a:gd name="adj" fmla="val 50000"/>
-            </a:avLst>
-          </a:prstGeom>
-          <a:solidFill>
-            <a:srgbClr val="F59E0B"/>
-          </a:solidFill>
-          <a:ln>
-            <a:noFill/>
-          </a:ln>
-          <a:effectLst>
-            <a:outerShdw blurRad="76200" dist="19050" dir="5400000" rotWithShape="0">
-              <a:srgbClr val="F59E0B">
-                <a:alpha val="55000"/>
-              </a:srgbClr>
-            </a:outerShdw>
-          </a:effectLst>
-        </p:spPr>
-        <p:style>
-          <a:lnRef idx="1">
-            <a:schemeClr val="accent1"/>
-          </a:lnRef>
-          <a:fillRef idx="3">
-            <a:schemeClr val="accent1"/>
-          </a:fillRef>
-          <a:effectRef idx="2">
-            <a:schemeClr val="accent1"/>
-          </a:effectRef>
-          <a:fontRef idx="minor">
-            <a:schemeClr val="lt1"/>
-          </a:fontRef>
-        </p:style>
-        <p:txBody>
-          <a:bodyPr rtlCol="0" anchor="ctr"/>
-          <a:lstStyle/>
-          <a:p>
-            <a:pPr algn="ctr"/>
-          </a:p>
-        </p:txBody>
-      </p:sp>
-      <p:sp>
-        <p:nvSpPr>
-          <p:cNvPr id="188" name="TextBox 187"/>
-          <p:cNvSpPr txBox="1"/>
-          <p:nvPr/>
-        </p:nvSpPr>
-        <p:spPr>
-          <a:xfrm>
-            <a:off x="7543800" y="3836936"/>
-            <a:ext cx="457200" cy="167106"/>
-          </a:xfrm>
-          <a:prstGeom prst="rect">
-            <a:avLst/>
-          </a:prstGeom>
-          <a:noFill/>
-        </p:spPr>
-        <p:txBody>
-          <a:bodyPr wrap="none" lIns="0" rIns="0" tIns="0" bIns="0">
-            <a:spAutoFit/>
-          </a:bodyPr>
-          <a:lstStyle/>
-          <a:p>
-            <a:pPr algn="l"/>
-            <a:r>
-              <a:rPr sz="800" b="1">
-                <a:solidFill>
-                  <a:srgbClr val="F59E0B"/>
-                </a:solidFill>
-                <a:latin typeface="Calibri"/>
-              </a:rPr>
-              <a:t>91%</a:t>
-            </a:r>
-          </a:p>
-        </p:txBody>
-      </p:sp>
-      <p:sp>
-        <p:nvSpPr>
-          <p:cNvPr id="189" name="Rectangle 188"/>
-          <p:cNvSpPr/>
-          <p:nvPr/>
-        </p:nvSpPr>
-        <p:spPr>
-          <a:xfrm>
-            <a:off x="73152" y="4014215"/>
-            <a:ext cx="8741664" cy="187452"/>
-          </a:xfrm>
-          <a:prstGeom prst="rect">
-            <a:avLst/>
-          </a:prstGeom>
-          <a:solidFill>
-            <a:srgbClr val="F5F7FA"/>
-          </a:solidFill>
-          <a:ln>
-            <a:noFill/>
-          </a:ln>
-          <a:effectLst/>
-        </p:spPr>
-        <p:style>
-          <a:lnRef idx="1">
-            <a:schemeClr val="accent1"/>
-          </a:lnRef>
-          <a:fillRef idx="3">
-            <a:schemeClr val="accent1"/>
-          </a:fillRef>
-          <a:effectRef idx="2">
-            <a:schemeClr val="accent1"/>
-          </a:effectRef>
-          <a:fontRef idx="minor">
-            <a:schemeClr val="lt1"/>
-          </a:fontRef>
-        </p:style>
-        <p:txBody>
-          <a:bodyPr rtlCol="0" anchor="ctr"/>
-          <a:lstStyle/>
-          <a:p>
-            <a:pPr algn="ctr"/>
-          </a:p>
-        </p:txBody>
-      </p:sp>
-      <p:sp>
-        <p:nvSpPr>
-          <p:cNvPr id="190" name="TextBox 189"/>
-          <p:cNvSpPr txBox="1"/>
-          <p:nvPr/>
-        </p:nvSpPr>
-        <p:spPr>
-          <a:xfrm>
-            <a:off x="91440" y="4014215"/>
-            <a:ext cx="722375" cy="187452"/>
-          </a:xfrm>
-          <a:prstGeom prst="rect">
-            <a:avLst/>
-          </a:prstGeom>
-          <a:noFill/>
-        </p:spPr>
-        <p:txBody>
-          <a:bodyPr wrap="none" lIns="0" rIns="0" tIns="0" bIns="0" anchor="ctr">
-            <a:spAutoFit/>
-          </a:bodyPr>
-          <a:lstStyle/>
-          <a:p>
-            <a:pPr algn="ctr"/>
-            <a:r>
-              <a:rPr sz="700" b="1">
-                <a:solidFill>
-                  <a:srgbClr val="1A2340"/>
-                </a:solidFill>
-                <a:latin typeface="Calibri"/>
-              </a:rPr>
-              <a:t>Mejoras</a:t>
-            </a:r>
-          </a:p>
-        </p:txBody>
-      </p:sp>
-      <p:sp>
-        <p:nvSpPr>
-          <p:cNvPr id="191" name="TextBox 190"/>
-          <p:cNvSpPr txBox="1"/>
-          <p:nvPr/>
-        </p:nvSpPr>
-        <p:spPr>
-          <a:xfrm>
-            <a:off x="850392" y="4014215"/>
-            <a:ext cx="2432304" cy="187452"/>
-          </a:xfrm>
-          <a:prstGeom prst="rect">
-            <a:avLst/>
-          </a:prstGeom>
-          <a:noFill/>
-        </p:spPr>
-        <p:txBody>
-          <a:bodyPr wrap="none" lIns="0" rIns="0" tIns="0" bIns="0" anchor="ctr">
-            <a:spAutoFit/>
-          </a:bodyPr>
-          <a:lstStyle/>
-          <a:p>
-            <a:pPr algn="l"/>
-            <a:r>
-              <a:rPr sz="700" b="0">
-                <a:solidFill>
-                  <a:srgbClr val="1A2340"/>
-                </a:solidFill>
-                <a:latin typeface="Calibri"/>
-              </a:rPr>
-              <a:t>Contabilidad || Integración Mecanica-SAE (Fase…</a:t>
-            </a:r>
-          </a:p>
-        </p:txBody>
-      </p:sp>
-      <p:sp>
-        <p:nvSpPr>
-          <p:cNvPr id="192" name="TextBox 191"/>
-          <p:cNvSpPr txBox="1"/>
-          <p:nvPr/>
-        </p:nvSpPr>
-        <p:spPr>
-          <a:xfrm>
-            <a:off x="3319272" y="4014215"/>
-            <a:ext cx="630936" cy="187452"/>
-          </a:xfrm>
-          <a:prstGeom prst="rect">
-            <a:avLst/>
-          </a:prstGeom>
-          <a:noFill/>
-        </p:spPr>
-        <p:txBody>
-          <a:bodyPr wrap="none" lIns="0" rIns="0" tIns="0" bIns="0" anchor="ctr">
-            <a:spAutoFit/>
-          </a:bodyPr>
-          <a:lstStyle/>
-          <a:p>
-            <a:pPr algn="ctr"/>
-            <a:r>
-              <a:rPr sz="700" b="0">
-                <a:solidFill>
-                  <a:srgbClr val="555555"/>
-                </a:solidFill>
-                <a:latin typeface="Calibri"/>
-              </a:rPr>
-              <a:t>21/04/2026</a:t>
-            </a:r>
-          </a:p>
-        </p:txBody>
-      </p:sp>
-      <p:sp>
-        <p:nvSpPr>
-          <p:cNvPr id="193" name="TextBox 192"/>
-          <p:cNvSpPr txBox="1"/>
-          <p:nvPr/>
-        </p:nvSpPr>
-        <p:spPr>
-          <a:xfrm>
-            <a:off x="3986783" y="4014215"/>
-            <a:ext cx="630936" cy="187452"/>
-          </a:xfrm>
-          <a:prstGeom prst="rect">
-            <a:avLst/>
-          </a:prstGeom>
-          <a:noFill/>
-        </p:spPr>
-        <p:txBody>
-          <a:bodyPr wrap="none" lIns="0" rIns="0" tIns="0" bIns="0" anchor="ctr">
-            <a:spAutoFit/>
-          </a:bodyPr>
-          <a:lstStyle/>
-          <a:p>
-            <a:pPr algn="ctr"/>
-            <a:r>
-              <a:rPr sz="700" b="0">
-                <a:solidFill>
-                  <a:srgbClr val="555555"/>
-                </a:solidFill>
-                <a:latin typeface="Calibri"/>
-              </a:rPr>
-              <a:t>12/06/2026</a:t>
-            </a:r>
-          </a:p>
-        </p:txBody>
-      </p:sp>
-      <p:sp>
-        <p:nvSpPr>
-          <p:cNvPr id="194" name="TextBox 193"/>
-          <p:cNvSpPr txBox="1"/>
-          <p:nvPr/>
-        </p:nvSpPr>
-        <p:spPr>
-          <a:xfrm>
-            <a:off x="4654296" y="4014215"/>
-            <a:ext cx="493775" cy="187452"/>
-          </a:xfrm>
-          <a:prstGeom prst="rect">
-            <a:avLst/>
-          </a:prstGeom>
-          <a:noFill/>
-        </p:spPr>
-        <p:txBody>
-          <a:bodyPr wrap="none" lIns="0" rIns="0" tIns="0" bIns="0" anchor="ctr">
-            <a:spAutoFit/>
-          </a:bodyPr>
-          <a:lstStyle/>
-          <a:p>
-            <a:pPr algn="ctr"/>
-            <a:r>
-              <a:rPr sz="700" b="1">
-                <a:solidFill>
-                  <a:srgbClr val="1A2340"/>
-                </a:solidFill>
-                <a:latin typeface="Calibri"/>
-              </a:rPr>
-              <a:t>99%</a:t>
-            </a:r>
-          </a:p>
-        </p:txBody>
-      </p:sp>
-      <p:sp>
-        <p:nvSpPr>
-          <p:cNvPr id="195" name="TextBox 194"/>
-          <p:cNvSpPr txBox="1"/>
-          <p:nvPr/>
-        </p:nvSpPr>
-        <p:spPr>
-          <a:xfrm>
-            <a:off x="5184648" y="4014215"/>
-            <a:ext cx="557784" cy="187452"/>
-          </a:xfrm>
-          <a:prstGeom prst="rect">
-            <a:avLst/>
-          </a:prstGeom>
-          <a:noFill/>
-        </p:spPr>
-        <p:txBody>
-          <a:bodyPr wrap="none" lIns="0" rIns="0" tIns="0" bIns="0" anchor="ctr">
-            <a:spAutoFit/>
-          </a:bodyPr>
-          <a:lstStyle/>
-          <a:p>
-            <a:pPr algn="ctr"/>
-            <a:r>
-              <a:rPr sz="700" b="0">
-                <a:solidFill>
-                  <a:srgbClr val="555555"/>
-                </a:solidFill>
-                <a:latin typeface="Calibri"/>
-              </a:rPr>
-              <a:t>100%</a:t>
-            </a:r>
-          </a:p>
-        </p:txBody>
-      </p:sp>
-      <p:sp>
-        <p:nvSpPr>
-          <p:cNvPr id="196" name="TextBox 195"/>
-          <p:cNvSpPr txBox="1"/>
-          <p:nvPr/>
-        </p:nvSpPr>
-        <p:spPr>
-          <a:xfrm>
-            <a:off x="7991856" y="4014215"/>
-            <a:ext cx="804672" cy="187452"/>
-          </a:xfrm>
-          <a:prstGeom prst="rect">
-            <a:avLst/>
-          </a:prstGeom>
-          <a:noFill/>
-        </p:spPr>
-        <p:txBody>
-          <a:bodyPr wrap="none" lIns="0" rIns="0" tIns="0" bIns="0" anchor="ctr">
-            <a:spAutoFit/>
-          </a:bodyPr>
-          <a:lstStyle/>
-          <a:p>
-            <a:pPr algn="ctr"/>
-            <a:r>
-              <a:rPr sz="700" b="1">
-                <a:solidFill>
-                  <a:srgbClr val="EF4444"/>
-                </a:solidFill>
-                <a:latin typeface="Calibri"/>
-              </a:rPr>
-              <a:t>Atrasado</a:t>
-            </a:r>
-          </a:p>
-        </p:txBody>
-      </p:sp>
-      <p:sp>
-        <p:nvSpPr>
-          <p:cNvPr id="197" name="Rounded Rectangle 196"/>
-          <p:cNvSpPr/>
-          <p:nvPr/>
-        </p:nvSpPr>
-        <p:spPr>
-          <a:xfrm>
-            <a:off x="5806440" y="4056392"/>
-            <a:ext cx="1691640" cy="103098"/>
-          </a:xfrm>
-          <a:prstGeom prst="roundRect">
-            <a:avLst>
-              <a:gd name="adj" fmla="val 50000"/>
-            </a:avLst>
-          </a:prstGeom>
-          <a:pattFill prst="smGrid">
-            <a:fgClr>
-              <a:srgbClr val="EF4444"/>
-            </a:fgClr>
-            <a:bgClr>
-              <a:srgbClr val="FFFFFF"/>
-            </a:bgClr>
-          </a:pattFill>
-          <a:ln>
-            <a:noFill/>
-          </a:ln>
-          <a:effectLst/>
-        </p:spPr>
-        <p:style>
-          <a:lnRef idx="1">
-            <a:schemeClr val="accent1"/>
-          </a:lnRef>
-          <a:fillRef idx="3">
-            <a:schemeClr val="accent1"/>
-          </a:fillRef>
-          <a:effectRef idx="2">
-            <a:schemeClr val="accent1"/>
-          </a:effectRef>
-          <a:fontRef idx="minor">
-            <a:schemeClr val="lt1"/>
-          </a:fontRef>
-        </p:style>
-        <p:txBody>
-          <a:bodyPr rtlCol="0" anchor="ctr"/>
-          <a:lstStyle/>
-          <a:p>
-            <a:pPr algn="ctr"/>
-          </a:p>
-        </p:txBody>
-      </p:sp>
-      <p:sp>
-        <p:nvSpPr>
-          <p:cNvPr id="198" name="Rounded Rectangle 197"/>
-          <p:cNvSpPr/>
-          <p:nvPr/>
-        </p:nvSpPr>
-        <p:spPr>
-          <a:xfrm>
-            <a:off x="5806440" y="4056392"/>
-            <a:ext cx="1674723" cy="103098"/>
-          </a:xfrm>
-          <a:prstGeom prst="roundRect">
-            <a:avLst>
-              <a:gd name="adj" fmla="val 50000"/>
-            </a:avLst>
-          </a:prstGeom>
-          <a:solidFill>
-            <a:srgbClr val="EF4444"/>
-          </a:solidFill>
-          <a:ln>
-            <a:noFill/>
-          </a:ln>
-          <a:effectLst>
-            <a:outerShdw blurRad="76200" dist="19050" dir="5400000" rotWithShape="0">
-              <a:srgbClr val="EF4444">
-                <a:alpha val="55000"/>
-              </a:srgbClr>
-            </a:outerShdw>
-          </a:effectLst>
-        </p:spPr>
-        <p:style>
-          <a:lnRef idx="1">
-            <a:schemeClr val="accent1"/>
-          </a:lnRef>
-          <a:fillRef idx="3">
-            <a:schemeClr val="accent1"/>
-          </a:fillRef>
-          <a:effectRef idx="2">
-            <a:schemeClr val="accent1"/>
-          </a:effectRef>
-          <a:fontRef idx="minor">
-            <a:schemeClr val="lt1"/>
-          </a:fontRef>
-        </p:style>
-        <p:txBody>
-          <a:bodyPr rtlCol="0" anchor="ctr"/>
-          <a:lstStyle/>
-          <a:p>
-            <a:pPr algn="ctr"/>
-          </a:p>
-        </p:txBody>
-      </p:sp>
-      <p:sp>
-        <p:nvSpPr>
-          <p:cNvPr id="199" name="TextBox 198"/>
-          <p:cNvSpPr txBox="1"/>
-          <p:nvPr/>
-        </p:nvSpPr>
-        <p:spPr>
-          <a:xfrm>
-            <a:off x="7543800" y="4024388"/>
-            <a:ext cx="457200" cy="167106"/>
-          </a:xfrm>
-          <a:prstGeom prst="rect">
-            <a:avLst/>
-          </a:prstGeom>
-          <a:noFill/>
-        </p:spPr>
-        <p:txBody>
-          <a:bodyPr wrap="none" lIns="0" rIns="0" tIns="0" bIns="0">
-            <a:spAutoFit/>
-          </a:bodyPr>
-          <a:lstStyle/>
-          <a:p>
-            <a:pPr algn="l"/>
-            <a:r>
-              <a:rPr sz="800" b="1">
-                <a:solidFill>
-                  <a:srgbClr val="EF4444"/>
-                </a:solidFill>
-                <a:latin typeface="Calibri"/>
-              </a:rPr>
-              <a:t>99%</a:t>
-            </a:r>
-          </a:p>
-        </p:txBody>
-      </p:sp>
-      <p:sp>
-        <p:nvSpPr>
-          <p:cNvPr id="200" name="Rectangle 199"/>
-          <p:cNvSpPr/>
-          <p:nvPr/>
-        </p:nvSpPr>
-        <p:spPr>
-          <a:xfrm>
-            <a:off x="73152" y="4201668"/>
-            <a:ext cx="8741664" cy="187452"/>
-          </a:xfrm>
-          <a:prstGeom prst="rect">
-            <a:avLst/>
-          </a:prstGeom>
-          <a:solidFill>
-            <a:srgbClr val="FFFFFF"/>
-          </a:solidFill>
-          <a:ln>
-            <a:noFill/>
-          </a:ln>
-          <a:effectLst/>
-        </p:spPr>
-        <p:style>
-          <a:lnRef idx="1">
-            <a:schemeClr val="accent1"/>
-          </a:lnRef>
-          <a:fillRef idx="3">
-            <a:schemeClr val="accent1"/>
-          </a:fillRef>
-          <a:effectRef idx="2">
-            <a:schemeClr val="accent1"/>
-          </a:effectRef>
-          <a:fontRef idx="minor">
-            <a:schemeClr val="lt1"/>
-          </a:fontRef>
-        </p:style>
-        <p:txBody>
-          <a:bodyPr rtlCol="0" anchor="ctr"/>
-          <a:lstStyle/>
-          <a:p>
-            <a:pPr algn="ctr"/>
-          </a:p>
-        </p:txBody>
-      </p:sp>
-      <p:sp>
-        <p:nvSpPr>
-          <p:cNvPr id="201" name="TextBox 200"/>
-          <p:cNvSpPr txBox="1"/>
-          <p:nvPr/>
-        </p:nvSpPr>
-        <p:spPr>
-          <a:xfrm>
-            <a:off x="91440" y="4201668"/>
-            <a:ext cx="722375" cy="187452"/>
-          </a:xfrm>
-          <a:prstGeom prst="rect">
-            <a:avLst/>
-          </a:prstGeom>
-          <a:noFill/>
-        </p:spPr>
-        <p:txBody>
-          <a:bodyPr wrap="none" lIns="0" rIns="0" tIns="0" bIns="0" anchor="ctr">
-            <a:spAutoFit/>
-          </a:bodyPr>
-          <a:lstStyle/>
-          <a:p>
-            <a:pPr algn="ctr"/>
-            <a:r>
-              <a:rPr sz="700" b="1">
-                <a:solidFill>
-                  <a:srgbClr val="1A2340"/>
-                </a:solidFill>
-                <a:latin typeface="Calibri"/>
-              </a:rPr>
-              <a:t>Proyecto</a:t>
-            </a:r>
-          </a:p>
-        </p:txBody>
-      </p:sp>
-      <p:sp>
-        <p:nvSpPr>
-          <p:cNvPr id="202" name="TextBox 201"/>
-          <p:cNvSpPr txBox="1"/>
-          <p:nvPr/>
-        </p:nvSpPr>
-        <p:spPr>
-          <a:xfrm>
-            <a:off x="850392" y="4201668"/>
-            <a:ext cx="2432304" cy="187452"/>
-          </a:xfrm>
-          <a:prstGeom prst="rect">
-            <a:avLst/>
-          </a:prstGeom>
-          <a:noFill/>
-        </p:spPr>
-        <p:txBody>
-          <a:bodyPr wrap="none" lIns="0" rIns="0" tIns="0" bIns="0" anchor="ctr">
-            <a:spAutoFit/>
-          </a:bodyPr>
-          <a:lstStyle/>
-          <a:p>
-            <a:pPr algn="l"/>
-            <a:r>
-              <a:rPr sz="700" b="0">
-                <a:solidFill>
-                  <a:srgbClr val="1A2340"/>
-                </a:solidFill>
-                <a:latin typeface="Calibri"/>
-              </a:rPr>
-              <a:t>DTI || Integración de sistemas</a:t>
-            </a:r>
-          </a:p>
-        </p:txBody>
-      </p:sp>
-      <p:sp>
-        <p:nvSpPr>
-          <p:cNvPr id="203" name="TextBox 202"/>
-          <p:cNvSpPr txBox="1"/>
-          <p:nvPr/>
-        </p:nvSpPr>
-        <p:spPr>
-          <a:xfrm>
-            <a:off x="3319272" y="4201668"/>
-            <a:ext cx="630936" cy="187452"/>
-          </a:xfrm>
-          <a:prstGeom prst="rect">
-            <a:avLst/>
-          </a:prstGeom>
-          <a:noFill/>
-        </p:spPr>
-        <p:txBody>
-          <a:bodyPr wrap="none" lIns="0" rIns="0" tIns="0" bIns="0" anchor="ctr">
-            <a:spAutoFit/>
-          </a:bodyPr>
-          <a:lstStyle/>
-          <a:p>
-            <a:pPr algn="ctr"/>
-            <a:r>
-              <a:rPr sz="700" b="0">
-                <a:solidFill>
-                  <a:srgbClr val="555555"/>
-                </a:solidFill>
-                <a:latin typeface="Calibri"/>
-              </a:rPr>
-              <a:t>01/06/2026</a:t>
-            </a:r>
-          </a:p>
-        </p:txBody>
-      </p:sp>
-      <p:sp>
-        <p:nvSpPr>
-          <p:cNvPr id="204" name="TextBox 203"/>
-          <p:cNvSpPr txBox="1"/>
-          <p:nvPr/>
-        </p:nvSpPr>
-        <p:spPr>
-          <a:xfrm>
-            <a:off x="3986783" y="4201668"/>
-            <a:ext cx="630936" cy="187452"/>
-          </a:xfrm>
-          <a:prstGeom prst="rect">
-            <a:avLst/>
-          </a:prstGeom>
-          <a:noFill/>
-        </p:spPr>
-        <p:txBody>
-          <a:bodyPr wrap="none" lIns="0" rIns="0" tIns="0" bIns="0" anchor="ctr">
-            <a:spAutoFit/>
-          </a:bodyPr>
-          <a:lstStyle/>
-          <a:p>
-            <a:pPr algn="ctr"/>
-            <a:r>
-              <a:rPr sz="700" b="0">
-                <a:solidFill>
-                  <a:srgbClr val="555555"/>
-                </a:solidFill>
-                <a:latin typeface="Calibri"/>
-              </a:rPr>
-              <a:t>23/09/2026</a:t>
-            </a:r>
-          </a:p>
-        </p:txBody>
-      </p:sp>
-      <p:sp>
-        <p:nvSpPr>
-          <p:cNvPr id="205" name="TextBox 204"/>
-          <p:cNvSpPr txBox="1"/>
-          <p:nvPr/>
-        </p:nvSpPr>
-        <p:spPr>
-          <a:xfrm>
-            <a:off x="4654296" y="4201668"/>
-            <a:ext cx="493775" cy="187452"/>
-          </a:xfrm>
-          <a:prstGeom prst="rect">
-            <a:avLst/>
-          </a:prstGeom>
-          <a:noFill/>
-        </p:spPr>
-        <p:txBody>
-          <a:bodyPr wrap="none" lIns="0" rIns="0" tIns="0" bIns="0" anchor="ctr">
-            <a:spAutoFit/>
-          </a:bodyPr>
-          <a:lstStyle/>
-          <a:p>
-            <a:pPr algn="ctr"/>
-            <a:r>
-              <a:rPr sz="700" b="1">
-                <a:solidFill>
-                  <a:srgbClr val="1A2340"/>
-                </a:solidFill>
-                <a:latin typeface="Calibri"/>
-              </a:rPr>
-              <a:t>31%</a:t>
-            </a:r>
-          </a:p>
-        </p:txBody>
-      </p:sp>
-      <p:sp>
-        <p:nvSpPr>
-          <p:cNvPr id="206" name="TextBox 205"/>
-          <p:cNvSpPr txBox="1"/>
-          <p:nvPr/>
-        </p:nvSpPr>
-        <p:spPr>
-          <a:xfrm>
-            <a:off x="5184648" y="4201668"/>
-            <a:ext cx="557784" cy="187452"/>
-          </a:xfrm>
-          <a:prstGeom prst="rect">
-            <a:avLst/>
-          </a:prstGeom>
-          <a:noFill/>
-        </p:spPr>
-        <p:txBody>
-          <a:bodyPr wrap="none" lIns="0" rIns="0" tIns="0" bIns="0" anchor="ctr">
-            <a:spAutoFit/>
-          </a:bodyPr>
-          <a:lstStyle/>
-          <a:p>
-            <a:pPr algn="ctr"/>
-            <a:r>
-              <a:rPr sz="700" b="0">
-                <a:solidFill>
-                  <a:srgbClr val="555555"/>
-                </a:solidFill>
-                <a:latin typeface="Calibri"/>
-              </a:rPr>
-              <a:t>38%</a:t>
-            </a:r>
-          </a:p>
-        </p:txBody>
-      </p:sp>
-      <p:sp>
-        <p:nvSpPr>
-          <p:cNvPr id="207" name="TextBox 206"/>
-          <p:cNvSpPr txBox="1"/>
-          <p:nvPr/>
-        </p:nvSpPr>
-        <p:spPr>
-          <a:xfrm>
-            <a:off x="7991856" y="4201668"/>
-            <a:ext cx="804672" cy="187452"/>
-          </a:xfrm>
-          <a:prstGeom prst="rect">
-            <a:avLst/>
-          </a:prstGeom>
-          <a:noFill/>
-        </p:spPr>
-        <p:txBody>
-          <a:bodyPr wrap="none" lIns="0" rIns="0" tIns="0" bIns="0" anchor="ctr">
-            <a:spAutoFit/>
-          </a:bodyPr>
-          <a:lstStyle/>
-          <a:p>
-            <a:pPr algn="ctr"/>
-            <a:r>
-              <a:rPr sz="700" b="1">
-                <a:solidFill>
-                  <a:srgbClr val="F59E0B"/>
-                </a:solidFill>
-                <a:latin typeface="Calibri"/>
-              </a:rPr>
-              <a:t>Riesgo de atraso</a:t>
-            </a:r>
-          </a:p>
-        </p:txBody>
-      </p:sp>
-      <p:sp>
-        <p:nvSpPr>
-          <p:cNvPr id="208" name="Rounded Rectangle 207"/>
-          <p:cNvSpPr/>
-          <p:nvPr/>
-        </p:nvSpPr>
-        <p:spPr>
-          <a:xfrm>
-            <a:off x="5806440" y="4243844"/>
-            <a:ext cx="1691640" cy="103098"/>
-          </a:xfrm>
-          <a:prstGeom prst="roundRect">
-            <a:avLst>
-              <a:gd name="adj" fmla="val 50000"/>
-            </a:avLst>
-          </a:prstGeom>
-          <a:pattFill prst="smGrid">
-            <a:fgClr>
-              <a:srgbClr val="F59E0B"/>
-            </a:fgClr>
-            <a:bgClr>
-              <a:srgbClr val="FFFFFF"/>
-            </a:bgClr>
-          </a:pattFill>
-          <a:ln>
-            <a:noFill/>
-          </a:ln>
-          <a:effectLst/>
-        </p:spPr>
-        <p:style>
-          <a:lnRef idx="1">
-            <a:schemeClr val="accent1"/>
-          </a:lnRef>
-          <a:fillRef idx="3">
-            <a:schemeClr val="accent1"/>
-          </a:fillRef>
-          <a:effectRef idx="2">
-            <a:schemeClr val="accent1"/>
-          </a:effectRef>
-          <a:fontRef idx="minor">
-            <a:schemeClr val="lt1"/>
-          </a:fontRef>
-        </p:style>
-        <p:txBody>
-          <a:bodyPr rtlCol="0" anchor="ctr"/>
-          <a:lstStyle/>
-          <a:p>
-            <a:pPr algn="ctr"/>
-          </a:p>
-        </p:txBody>
-      </p:sp>
-      <p:sp>
-        <p:nvSpPr>
-          <p:cNvPr id="209" name="Rounded Rectangle 208"/>
-          <p:cNvSpPr/>
-          <p:nvPr/>
-        </p:nvSpPr>
-        <p:spPr>
-          <a:xfrm>
-            <a:off x="5806440" y="4243844"/>
-            <a:ext cx="524408" cy="103098"/>
-          </a:xfrm>
-          <a:prstGeom prst="roundRect">
-            <a:avLst>
-              <a:gd name="adj" fmla="val 50000"/>
-            </a:avLst>
-          </a:prstGeom>
-          <a:solidFill>
-            <a:srgbClr val="F59E0B"/>
-          </a:solidFill>
-          <a:ln>
-            <a:noFill/>
-          </a:ln>
-          <a:effectLst>
-            <a:outerShdw blurRad="76200" dist="19050" dir="5400000" rotWithShape="0">
-              <a:srgbClr val="F59E0B">
-                <a:alpha val="55000"/>
-              </a:srgbClr>
-            </a:outerShdw>
-          </a:effectLst>
-        </p:spPr>
-        <p:style>
-          <a:lnRef idx="1">
-            <a:schemeClr val="accent1"/>
-          </a:lnRef>
-          <a:fillRef idx="3">
-            <a:schemeClr val="accent1"/>
-          </a:fillRef>
-          <a:effectRef idx="2">
-            <a:schemeClr val="accent1"/>
-          </a:effectRef>
-          <a:fontRef idx="minor">
-            <a:schemeClr val="lt1"/>
-          </a:fontRef>
-        </p:style>
-        <p:txBody>
-          <a:bodyPr rtlCol="0" anchor="ctr"/>
-          <a:lstStyle/>
-          <a:p>
-            <a:pPr algn="ctr"/>
-          </a:p>
-        </p:txBody>
-      </p:sp>
-      <p:sp>
-        <p:nvSpPr>
-          <p:cNvPr id="210" name="TextBox 209"/>
-          <p:cNvSpPr txBox="1"/>
-          <p:nvPr/>
-        </p:nvSpPr>
-        <p:spPr>
-          <a:xfrm>
-            <a:off x="7543800" y="4211840"/>
-            <a:ext cx="457200" cy="167106"/>
-          </a:xfrm>
-          <a:prstGeom prst="rect">
-            <a:avLst/>
-          </a:prstGeom>
-          <a:noFill/>
-        </p:spPr>
-        <p:txBody>
-          <a:bodyPr wrap="none" lIns="0" rIns="0" tIns="0" bIns="0">
-            <a:spAutoFit/>
-          </a:bodyPr>
-          <a:lstStyle/>
-          <a:p>
-            <a:pPr algn="l"/>
-            <a:r>
-              <a:rPr sz="800" b="1">
-                <a:solidFill>
-                  <a:srgbClr val="F59E0B"/>
-                </a:solidFill>
-                <a:latin typeface="Calibri"/>
-              </a:rPr>
-              <a:t>31%</a:t>
-            </a:r>
-          </a:p>
-        </p:txBody>
-      </p:sp>
-      <p:sp>
-        <p:nvSpPr>
-          <p:cNvPr id="211" name="Rectangle 210"/>
-          <p:cNvSpPr/>
-          <p:nvPr/>
-        </p:nvSpPr>
-        <p:spPr>
-          <a:xfrm>
-            <a:off x="73152" y="4389120"/>
-            <a:ext cx="8741664" cy="187452"/>
-          </a:xfrm>
-          <a:prstGeom prst="rect">
-            <a:avLst/>
-          </a:prstGeom>
-          <a:solidFill>
-            <a:srgbClr val="F5F7FA"/>
-          </a:solidFill>
-          <a:ln>
-            <a:noFill/>
-          </a:ln>
-          <a:effectLst/>
-        </p:spPr>
-        <p:style>
-          <a:lnRef idx="1">
-            <a:schemeClr val="accent1"/>
-          </a:lnRef>
-          <a:fillRef idx="3">
-            <a:schemeClr val="accent1"/>
-          </a:fillRef>
-          <a:effectRef idx="2">
-            <a:schemeClr val="accent1"/>
-          </a:effectRef>
-          <a:fontRef idx="minor">
-            <a:schemeClr val="lt1"/>
-          </a:fontRef>
-        </p:style>
-        <p:txBody>
-          <a:bodyPr rtlCol="0" anchor="ctr"/>
-          <a:lstStyle/>
-          <a:p>
-            <a:pPr algn="ctr"/>
-          </a:p>
-        </p:txBody>
-      </p:sp>
-      <p:sp>
-        <p:nvSpPr>
-          <p:cNvPr id="212" name="TextBox 211"/>
-          <p:cNvSpPr txBox="1"/>
-          <p:nvPr/>
-        </p:nvSpPr>
-        <p:spPr>
-          <a:xfrm>
-            <a:off x="91440" y="4389120"/>
-            <a:ext cx="722375" cy="187452"/>
-          </a:xfrm>
-          <a:prstGeom prst="rect">
-            <a:avLst/>
-          </a:prstGeom>
-          <a:noFill/>
-        </p:spPr>
-        <p:txBody>
-          <a:bodyPr wrap="none" lIns="0" rIns="0" tIns="0" bIns="0" anchor="ctr">
-            <a:spAutoFit/>
-          </a:bodyPr>
-          <a:lstStyle/>
-          <a:p>
-            <a:pPr algn="ctr"/>
-            <a:r>
-              <a:rPr sz="700" b="1">
-                <a:solidFill>
-                  <a:srgbClr val="1A2340"/>
-                </a:solidFill>
-                <a:latin typeface="Calibri"/>
-              </a:rPr>
-              <a:t>Mejoras</a:t>
-            </a:r>
-          </a:p>
-        </p:txBody>
-      </p:sp>
-      <p:sp>
-        <p:nvSpPr>
-          <p:cNvPr id="213" name="TextBox 212"/>
-          <p:cNvSpPr txBox="1"/>
-          <p:nvPr/>
-        </p:nvSpPr>
-        <p:spPr>
-          <a:xfrm>
-            <a:off x="850392" y="4389120"/>
-            <a:ext cx="2432304" cy="187452"/>
-          </a:xfrm>
-          <a:prstGeom prst="rect">
-            <a:avLst/>
-          </a:prstGeom>
-          <a:noFill/>
-        </p:spPr>
-        <p:txBody>
-          <a:bodyPr wrap="none" lIns="0" rIns="0" tIns="0" bIns="0" anchor="ctr">
-            <a:spAutoFit/>
-          </a:bodyPr>
-          <a:lstStyle/>
-          <a:p>
-            <a:pPr algn="l"/>
-            <a:r>
-              <a:rPr sz="700" b="0">
-                <a:solidFill>
-                  <a:srgbClr val="1A2340"/>
-                </a:solidFill>
-                <a:latin typeface="Calibri"/>
-              </a:rPr>
-              <a:t>Capital Humano || BUK Personalizados Fase 2</a:t>
-            </a:r>
-          </a:p>
-        </p:txBody>
-      </p:sp>
-      <p:sp>
-        <p:nvSpPr>
-          <p:cNvPr id="214" name="TextBox 213"/>
-          <p:cNvSpPr txBox="1"/>
-          <p:nvPr/>
-        </p:nvSpPr>
-        <p:spPr>
-          <a:xfrm>
-            <a:off x="3319272" y="4389120"/>
-            <a:ext cx="630936" cy="187452"/>
-          </a:xfrm>
-          <a:prstGeom prst="rect">
-            <a:avLst/>
-          </a:prstGeom>
-          <a:noFill/>
-        </p:spPr>
-        <p:txBody>
-          <a:bodyPr wrap="none" lIns="0" rIns="0" tIns="0" bIns="0" anchor="ctr">
-            <a:spAutoFit/>
-          </a:bodyPr>
-          <a:lstStyle/>
-          <a:p>
-            <a:pPr algn="ctr"/>
-            <a:r>
-              <a:rPr sz="700" b="0">
-                <a:solidFill>
-                  <a:srgbClr val="555555"/>
-                </a:solidFill>
-                <a:latin typeface="Calibri"/>
-              </a:rPr>
-              <a:t>08/06/2026</a:t>
-            </a:r>
-          </a:p>
-        </p:txBody>
-      </p:sp>
-      <p:sp>
-        <p:nvSpPr>
-          <p:cNvPr id="215" name="TextBox 214"/>
-          <p:cNvSpPr txBox="1"/>
-          <p:nvPr/>
-        </p:nvSpPr>
-        <p:spPr>
-          <a:xfrm>
-            <a:off x="3986783" y="4389120"/>
-            <a:ext cx="630936" cy="187452"/>
-          </a:xfrm>
-          <a:prstGeom prst="rect">
-            <a:avLst/>
-          </a:prstGeom>
-          <a:noFill/>
-        </p:spPr>
-        <p:txBody>
-          <a:bodyPr wrap="none" lIns="0" rIns="0" tIns="0" bIns="0" anchor="ctr">
-            <a:spAutoFit/>
-          </a:bodyPr>
-          <a:lstStyle/>
-          <a:p>
-            <a:pPr algn="ctr"/>
-            <a:r>
-              <a:rPr sz="700" b="0">
-                <a:solidFill>
-                  <a:srgbClr val="555555"/>
-                </a:solidFill>
-                <a:latin typeface="Calibri"/>
-              </a:rPr>
-              <a:t>11/08/2026</a:t>
-            </a:r>
-          </a:p>
-        </p:txBody>
-      </p:sp>
-      <p:sp>
-        <p:nvSpPr>
-          <p:cNvPr id="216" name="TextBox 215"/>
-          <p:cNvSpPr txBox="1"/>
-          <p:nvPr/>
-        </p:nvSpPr>
-        <p:spPr>
-          <a:xfrm>
-            <a:off x="4654296" y="4389120"/>
-            <a:ext cx="493775" cy="187452"/>
-          </a:xfrm>
-          <a:prstGeom prst="rect">
-            <a:avLst/>
-          </a:prstGeom>
-          <a:noFill/>
-        </p:spPr>
-        <p:txBody>
-          <a:bodyPr wrap="none" lIns="0" rIns="0" tIns="0" bIns="0" anchor="ctr">
-            <a:spAutoFit/>
-          </a:bodyPr>
-          <a:lstStyle/>
-          <a:p>
-            <a:pPr algn="ctr"/>
-            <a:r>
-              <a:rPr sz="700" b="1">
-                <a:solidFill>
-                  <a:srgbClr val="1A2340"/>
-                </a:solidFill>
-                <a:latin typeface="Calibri"/>
-              </a:rPr>
-              <a:t>86%</a:t>
-            </a:r>
-          </a:p>
-        </p:txBody>
-      </p:sp>
-      <p:sp>
-        <p:nvSpPr>
-          <p:cNvPr id="217" name="TextBox 216"/>
-          <p:cNvSpPr txBox="1"/>
-          <p:nvPr/>
-        </p:nvSpPr>
-        <p:spPr>
-          <a:xfrm>
-            <a:off x="5184648" y="4389120"/>
-            <a:ext cx="557784" cy="187452"/>
-          </a:xfrm>
-          <a:prstGeom prst="rect">
-            <a:avLst/>
-          </a:prstGeom>
-          <a:noFill/>
-        </p:spPr>
-        <p:txBody>
-          <a:bodyPr wrap="none" lIns="0" rIns="0" tIns="0" bIns="0" anchor="ctr">
-            <a:spAutoFit/>
-          </a:bodyPr>
-          <a:lstStyle/>
-          <a:p>
-            <a:pPr algn="ctr"/>
-            <a:r>
-              <a:rPr sz="700" b="0">
-                <a:solidFill>
-                  <a:srgbClr val="555555"/>
-                </a:solidFill>
-                <a:latin typeface="Calibri"/>
-              </a:rPr>
-              <a:t>57%</a:t>
-            </a:r>
-          </a:p>
-        </p:txBody>
-      </p:sp>
-      <p:sp>
-        <p:nvSpPr>
-          <p:cNvPr id="218" name="TextBox 217"/>
-          <p:cNvSpPr txBox="1"/>
-          <p:nvPr/>
-        </p:nvSpPr>
-        <p:spPr>
-          <a:xfrm>
-            <a:off x="7991856" y="4389120"/>
-            <a:ext cx="804672" cy="187452"/>
-          </a:xfrm>
-          <a:prstGeom prst="rect">
-            <a:avLst/>
-          </a:prstGeom>
-          <a:noFill/>
-        </p:spPr>
-        <p:txBody>
-          <a:bodyPr wrap="none" lIns="0" rIns="0" tIns="0" bIns="0" anchor="ctr">
-            <a:spAutoFit/>
-          </a:bodyPr>
-          <a:lstStyle/>
-          <a:p>
-            <a:pPr algn="ctr"/>
-            <a:r>
-              <a:rPr sz="700" b="1">
-                <a:solidFill>
-                  <a:srgbClr val="22C55E"/>
-                </a:solidFill>
-                <a:latin typeface="Calibri"/>
-              </a:rPr>
-              <a:t>A tiempo</a:t>
-            </a:r>
-          </a:p>
-        </p:txBody>
-      </p:sp>
-      <p:sp>
-        <p:nvSpPr>
-          <p:cNvPr id="219" name="Rounded Rectangle 218"/>
-          <p:cNvSpPr/>
-          <p:nvPr/>
-        </p:nvSpPr>
-        <p:spPr>
-          <a:xfrm>
-            <a:off x="5806440" y="4431296"/>
-            <a:ext cx="1691640" cy="103098"/>
-          </a:xfrm>
-          <a:prstGeom prst="roundRect">
-            <a:avLst>
-              <a:gd name="adj" fmla="val 50000"/>
-            </a:avLst>
-          </a:prstGeom>
-          <a:pattFill prst="smGrid">
-            <a:fgClr>
-              <a:srgbClr val="22C55E"/>
-            </a:fgClr>
-            <a:bgClr>
-              <a:srgbClr val="FFFFFF"/>
-            </a:bgClr>
-          </a:pattFill>
-          <a:ln>
-            <a:noFill/>
-          </a:ln>
-          <a:effectLst/>
-        </p:spPr>
-        <p:style>
-          <a:lnRef idx="1">
-            <a:schemeClr val="accent1"/>
-          </a:lnRef>
-          <a:fillRef idx="3">
-            <a:schemeClr val="accent1"/>
-          </a:fillRef>
-          <a:effectRef idx="2">
-            <a:schemeClr val="accent1"/>
-          </a:effectRef>
-          <a:fontRef idx="minor">
-            <a:schemeClr val="lt1"/>
-          </a:fontRef>
-        </p:style>
-        <p:txBody>
-          <a:bodyPr rtlCol="0" anchor="ctr"/>
-          <a:lstStyle/>
-          <a:p>
-            <a:pPr algn="ctr"/>
-          </a:p>
-        </p:txBody>
-      </p:sp>
-      <p:sp>
-        <p:nvSpPr>
-          <p:cNvPr id="220" name="Rounded Rectangle 219"/>
-          <p:cNvSpPr/>
-          <p:nvPr/>
-        </p:nvSpPr>
-        <p:spPr>
-          <a:xfrm>
-            <a:off x="5806440" y="4431296"/>
-            <a:ext cx="1454810" cy="103098"/>
-          </a:xfrm>
-          <a:prstGeom prst="roundRect">
-            <a:avLst>
-              <a:gd name="adj" fmla="val 50000"/>
-            </a:avLst>
-          </a:prstGeom>
-          <a:solidFill>
-            <a:srgbClr val="22C55E"/>
-          </a:solidFill>
-          <a:ln>
-            <a:noFill/>
-          </a:ln>
-          <a:effectLst>
-            <a:outerShdw blurRad="76200" dist="19050" dir="5400000" rotWithShape="0">
-              <a:srgbClr val="22C55E">
-                <a:alpha val="55000"/>
-              </a:srgbClr>
-            </a:outerShdw>
-          </a:effectLst>
-        </p:spPr>
-        <p:style>
-          <a:lnRef idx="1">
-            <a:schemeClr val="accent1"/>
-          </a:lnRef>
-          <a:fillRef idx="3">
-            <a:schemeClr val="accent1"/>
-          </a:fillRef>
-          <a:effectRef idx="2">
-            <a:schemeClr val="accent1"/>
-          </a:effectRef>
-          <a:fontRef idx="minor">
-            <a:schemeClr val="lt1"/>
-          </a:fontRef>
-        </p:style>
-        <p:txBody>
-          <a:bodyPr rtlCol="0" anchor="ctr"/>
-          <a:lstStyle/>
-          <a:p>
-            <a:pPr algn="ctr"/>
-          </a:p>
-        </p:txBody>
-      </p:sp>
-      <p:sp>
-        <p:nvSpPr>
-          <p:cNvPr id="221" name="TextBox 220"/>
-          <p:cNvSpPr txBox="1"/>
-          <p:nvPr/>
-        </p:nvSpPr>
-        <p:spPr>
-          <a:xfrm>
-            <a:off x="7543800" y="4399292"/>
-            <a:ext cx="457200" cy="167106"/>
-          </a:xfrm>
-          <a:prstGeom prst="rect">
-            <a:avLst/>
-          </a:prstGeom>
-          <a:noFill/>
-        </p:spPr>
-        <p:txBody>
-          <a:bodyPr wrap="none" lIns="0" rIns="0" tIns="0" bIns="0">
-            <a:spAutoFit/>
-          </a:bodyPr>
-          <a:lstStyle/>
-          <a:p>
-            <a:pPr algn="l"/>
-            <a:r>
-              <a:rPr sz="800" b="1">
-                <a:solidFill>
-                  <a:srgbClr val="22C55E"/>
-                </a:solidFill>
-                <a:latin typeface="Calibri"/>
-              </a:rPr>
-              <a:t>86%</a:t>
-            </a:r>
-          </a:p>
-        </p:txBody>
-      </p:sp>
-      <p:sp>
-        <p:nvSpPr>
-          <p:cNvPr id="222" name="Rectangle 221"/>
-          <p:cNvSpPr/>
-          <p:nvPr/>
-        </p:nvSpPr>
-        <p:spPr>
-          <a:xfrm>
-            <a:off x="73152" y="4576572"/>
-            <a:ext cx="8741664" cy="187452"/>
-          </a:xfrm>
-          <a:prstGeom prst="rect">
-            <a:avLst/>
-          </a:prstGeom>
-          <a:solidFill>
-            <a:srgbClr val="FFFFFF"/>
-          </a:solidFill>
-          <a:ln>
-            <a:noFill/>
-          </a:ln>
-          <a:effectLst/>
-        </p:spPr>
-        <p:style>
-          <a:lnRef idx="1">
-            <a:schemeClr val="accent1"/>
-          </a:lnRef>
-          <a:fillRef idx="3">
-            <a:schemeClr val="accent1"/>
-          </a:fillRef>
-          <a:effectRef idx="2">
-            <a:schemeClr val="accent1"/>
-          </a:effectRef>
-          <a:fontRef idx="minor">
-            <a:schemeClr val="lt1"/>
-          </a:fontRef>
-        </p:style>
-        <p:txBody>
-          <a:bodyPr rtlCol="0" anchor="ctr"/>
-          <a:lstStyle/>
-          <a:p>
-            <a:pPr algn="ctr"/>
-          </a:p>
-        </p:txBody>
-      </p:sp>
-      <p:sp>
-        <p:nvSpPr>
-          <p:cNvPr id="223" name="TextBox 222"/>
-          <p:cNvSpPr txBox="1"/>
-          <p:nvPr/>
-        </p:nvSpPr>
-        <p:spPr>
-          <a:xfrm>
-            <a:off x="91440" y="4576572"/>
-            <a:ext cx="722375" cy="187452"/>
-          </a:xfrm>
-          <a:prstGeom prst="rect">
-            <a:avLst/>
-          </a:prstGeom>
-          <a:noFill/>
-        </p:spPr>
-        <p:txBody>
-          <a:bodyPr wrap="none" lIns="0" rIns="0" tIns="0" bIns="0" anchor="ctr">
-            <a:spAutoFit/>
-          </a:bodyPr>
-          <a:lstStyle/>
-          <a:p>
-            <a:pPr algn="ctr"/>
-            <a:r>
-              <a:rPr sz="700" b="1">
-                <a:solidFill>
-                  <a:srgbClr val="1A2340"/>
-                </a:solidFill>
-                <a:latin typeface="Calibri"/>
-              </a:rPr>
-              <a:t>Mejoras</a:t>
-            </a:r>
-          </a:p>
-        </p:txBody>
-      </p:sp>
-      <p:sp>
-        <p:nvSpPr>
-          <p:cNvPr id="224" name="TextBox 223"/>
-          <p:cNvSpPr txBox="1"/>
-          <p:nvPr/>
-        </p:nvSpPr>
-        <p:spPr>
-          <a:xfrm>
-            <a:off x="850392" y="4576572"/>
-            <a:ext cx="2432304" cy="187452"/>
-          </a:xfrm>
-          <a:prstGeom prst="rect">
-            <a:avLst/>
-          </a:prstGeom>
-          <a:noFill/>
-        </p:spPr>
-        <p:txBody>
-          <a:bodyPr wrap="none" lIns="0" rIns="0" tIns="0" bIns="0" anchor="ctr">
-            <a:spAutoFit/>
-          </a:bodyPr>
-          <a:lstStyle/>
-          <a:p>
-            <a:pPr algn="l"/>
-            <a:r>
-              <a:rPr sz="700" b="0">
-                <a:solidFill>
-                  <a:srgbClr val="1A2340"/>
-                </a:solidFill>
-                <a:latin typeface="Calibri"/>
-              </a:rPr>
-              <a:t>Operaciones Fleet || Adcontent - Sfleet</a:t>
-            </a:r>
-          </a:p>
-        </p:txBody>
-      </p:sp>
-      <p:sp>
-        <p:nvSpPr>
-          <p:cNvPr id="225" name="TextBox 224"/>
-          <p:cNvSpPr txBox="1"/>
-          <p:nvPr/>
-        </p:nvSpPr>
-        <p:spPr>
-          <a:xfrm>
-            <a:off x="3319272" y="4576572"/>
-            <a:ext cx="630936" cy="187452"/>
-          </a:xfrm>
-          <a:prstGeom prst="rect">
-            <a:avLst/>
-          </a:prstGeom>
-          <a:noFill/>
-        </p:spPr>
-        <p:txBody>
-          <a:bodyPr wrap="none" lIns="0" rIns="0" tIns="0" bIns="0" anchor="ctr">
-            <a:spAutoFit/>
-          </a:bodyPr>
-          <a:lstStyle/>
-          <a:p>
-            <a:pPr algn="ctr"/>
-            <a:r>
-              <a:rPr sz="700" b="0">
-                <a:solidFill>
-                  <a:srgbClr val="555555"/>
-                </a:solidFill>
-                <a:latin typeface="Calibri"/>
-              </a:rPr>
-              <a:t>15/06/2026</a:t>
-            </a:r>
-          </a:p>
-        </p:txBody>
-      </p:sp>
-      <p:sp>
-        <p:nvSpPr>
-          <p:cNvPr id="226" name="TextBox 225"/>
-          <p:cNvSpPr txBox="1"/>
-          <p:nvPr/>
-        </p:nvSpPr>
-        <p:spPr>
-          <a:xfrm>
-            <a:off x="3986783" y="4576572"/>
-            <a:ext cx="630936" cy="187452"/>
-          </a:xfrm>
-          <a:prstGeom prst="rect">
-            <a:avLst/>
-          </a:prstGeom>
-          <a:noFill/>
-        </p:spPr>
-        <p:txBody>
-          <a:bodyPr wrap="none" lIns="0" rIns="0" tIns="0" bIns="0" anchor="ctr">
-            <a:spAutoFit/>
-          </a:bodyPr>
-          <a:lstStyle/>
-          <a:p>
-            <a:pPr algn="ctr"/>
-            <a:r>
-              <a:rPr sz="700" b="0">
-                <a:solidFill>
-                  <a:srgbClr val="555555"/>
-                </a:solidFill>
-                <a:latin typeface="Calibri"/>
-              </a:rPr>
-              <a:t>12/02/2027</a:t>
-            </a:r>
-          </a:p>
-        </p:txBody>
-      </p:sp>
-      <p:sp>
-        <p:nvSpPr>
-          <p:cNvPr id="227" name="TextBox 226"/>
-          <p:cNvSpPr txBox="1"/>
-          <p:nvPr/>
-        </p:nvSpPr>
-        <p:spPr>
-          <a:xfrm>
-            <a:off x="4654296" y="4576572"/>
-            <a:ext cx="493775" cy="187452"/>
-          </a:xfrm>
-          <a:prstGeom prst="rect">
-            <a:avLst/>
-          </a:prstGeom>
-          <a:noFill/>
-        </p:spPr>
-        <p:txBody>
-          <a:bodyPr wrap="none" lIns="0" rIns="0" tIns="0" bIns="0" anchor="ctr">
-            <a:spAutoFit/>
-          </a:bodyPr>
-          <a:lstStyle/>
-          <a:p>
-            <a:pPr algn="ctr"/>
-            <a:r>
-              <a:rPr sz="700" b="1">
-                <a:solidFill>
-                  <a:srgbClr val="1A2340"/>
-                </a:solidFill>
-                <a:latin typeface="Calibri"/>
-              </a:rPr>
-              <a:t>12%</a:t>
-            </a:r>
-          </a:p>
-        </p:txBody>
-      </p:sp>
-      <p:sp>
-        <p:nvSpPr>
-          <p:cNvPr id="228" name="TextBox 227"/>
-          <p:cNvSpPr txBox="1"/>
-          <p:nvPr/>
-        </p:nvSpPr>
-        <p:spPr>
-          <a:xfrm>
-            <a:off x="5184648" y="4576572"/>
-            <a:ext cx="557784" cy="187452"/>
-          </a:xfrm>
-          <a:prstGeom prst="rect">
-            <a:avLst/>
-          </a:prstGeom>
-          <a:noFill/>
-        </p:spPr>
-        <p:txBody>
-          <a:bodyPr wrap="none" lIns="0" rIns="0" tIns="0" bIns="0" anchor="ctr">
-            <a:spAutoFit/>
-          </a:bodyPr>
-          <a:lstStyle/>
-          <a:p>
-            <a:pPr algn="ctr"/>
-            <a:r>
-              <a:rPr sz="700" b="0">
-                <a:solidFill>
-                  <a:srgbClr val="555555"/>
-                </a:solidFill>
-                <a:latin typeface="Calibri"/>
-              </a:rPr>
-              <a:t>12%</a:t>
-            </a:r>
-          </a:p>
-        </p:txBody>
-      </p:sp>
-      <p:sp>
-        <p:nvSpPr>
-          <p:cNvPr id="229" name="TextBox 228"/>
-          <p:cNvSpPr txBox="1"/>
-          <p:nvPr/>
-        </p:nvSpPr>
-        <p:spPr>
-          <a:xfrm>
-            <a:off x="7991856" y="4576572"/>
-            <a:ext cx="804672" cy="187452"/>
-          </a:xfrm>
-          <a:prstGeom prst="rect">
-            <a:avLst/>
-          </a:prstGeom>
-          <a:noFill/>
-        </p:spPr>
-        <p:txBody>
-          <a:bodyPr wrap="none" lIns="0" rIns="0" tIns="0" bIns="0" anchor="ctr">
-            <a:spAutoFit/>
-          </a:bodyPr>
-          <a:lstStyle/>
-          <a:p>
-            <a:pPr algn="ctr"/>
-            <a:r>
-              <a:rPr sz="700" b="1">
-                <a:solidFill>
-                  <a:srgbClr val="22C55E"/>
-                </a:solidFill>
-                <a:latin typeface="Calibri"/>
-              </a:rPr>
-              <a:t>A tiempo</a:t>
-            </a:r>
-          </a:p>
-        </p:txBody>
-      </p:sp>
-      <p:sp>
-        <p:nvSpPr>
-          <p:cNvPr id="230" name="Rounded Rectangle 229"/>
-          <p:cNvSpPr/>
-          <p:nvPr/>
-        </p:nvSpPr>
-        <p:spPr>
-          <a:xfrm>
-            <a:off x="5806440" y="4618748"/>
-            <a:ext cx="1691640" cy="103098"/>
-          </a:xfrm>
-          <a:prstGeom prst="roundRect">
-            <a:avLst>
-              <a:gd name="adj" fmla="val 50000"/>
-            </a:avLst>
-          </a:prstGeom>
-          <a:pattFill prst="smGrid">
-            <a:fgClr>
-              <a:srgbClr val="22C55E"/>
-            </a:fgClr>
-            <a:bgClr>
-              <a:srgbClr val="FFFFFF"/>
-            </a:bgClr>
-          </a:pattFill>
-          <a:ln>
-            <a:noFill/>
-          </a:ln>
-          <a:effectLst/>
-        </p:spPr>
-        <p:style>
-          <a:lnRef idx="1">
-            <a:schemeClr val="accent1"/>
-          </a:lnRef>
-          <a:fillRef idx="3">
-            <a:schemeClr val="accent1"/>
-          </a:fillRef>
-          <a:effectRef idx="2">
-            <a:schemeClr val="accent1"/>
-          </a:effectRef>
-          <a:fontRef idx="minor">
-            <a:schemeClr val="lt1"/>
-          </a:fontRef>
-        </p:style>
-        <p:txBody>
-          <a:bodyPr rtlCol="0" anchor="ctr"/>
-          <a:lstStyle/>
-          <a:p>
-            <a:pPr algn="ctr"/>
-          </a:p>
-        </p:txBody>
-      </p:sp>
-      <p:sp>
-        <p:nvSpPr>
-          <p:cNvPr id="231" name="Rounded Rectangle 230"/>
-          <p:cNvSpPr/>
-          <p:nvPr/>
-        </p:nvSpPr>
-        <p:spPr>
-          <a:xfrm>
-            <a:off x="5806440" y="4618748"/>
-            <a:ext cx="202996" cy="103098"/>
-          </a:xfrm>
-          <a:prstGeom prst="roundRect">
-            <a:avLst>
-              <a:gd name="adj" fmla="val 50000"/>
-            </a:avLst>
-          </a:prstGeom>
-          <a:solidFill>
-            <a:srgbClr val="22C55E"/>
-          </a:solidFill>
-          <a:ln>
-            <a:noFill/>
-          </a:ln>
-          <a:effectLst>
-            <a:outerShdw blurRad="76200" dist="19050" dir="5400000" rotWithShape="0">
-              <a:srgbClr val="22C55E">
-                <a:alpha val="55000"/>
-              </a:srgbClr>
-            </a:outerShdw>
-          </a:effectLst>
-        </p:spPr>
-        <p:style>
-          <a:lnRef idx="1">
-            <a:schemeClr val="accent1"/>
-          </a:lnRef>
-          <a:fillRef idx="3">
-            <a:schemeClr val="accent1"/>
-          </a:fillRef>
-          <a:effectRef idx="2">
-            <a:schemeClr val="accent1"/>
-          </a:effectRef>
-          <a:fontRef idx="minor">
-            <a:schemeClr val="lt1"/>
-          </a:fontRef>
-        </p:style>
-        <p:txBody>
-          <a:bodyPr rtlCol="0" anchor="ctr"/>
-          <a:lstStyle/>
-          <a:p>
-            <a:pPr algn="ctr"/>
-          </a:p>
-        </p:txBody>
-      </p:sp>
-      <p:sp>
-        <p:nvSpPr>
-          <p:cNvPr id="232" name="TextBox 231"/>
-          <p:cNvSpPr txBox="1"/>
-          <p:nvPr/>
-        </p:nvSpPr>
-        <p:spPr>
-          <a:xfrm>
-            <a:off x="7543800" y="4586744"/>
-            <a:ext cx="457200" cy="167106"/>
-          </a:xfrm>
-          <a:prstGeom prst="rect">
-            <a:avLst/>
-          </a:prstGeom>
-          <a:noFill/>
-        </p:spPr>
-        <p:txBody>
-          <a:bodyPr wrap="none" lIns="0" rIns="0" tIns="0" bIns="0">
-            <a:spAutoFit/>
-          </a:bodyPr>
-          <a:lstStyle/>
-          <a:p>
-            <a:pPr algn="l"/>
-            <a:r>
-              <a:rPr sz="800" b="1">
-                <a:solidFill>
-                  <a:srgbClr val="22C55E"/>
-                </a:solidFill>
-                <a:latin typeface="Calibri"/>
-              </a:rPr>
-              <a:t>12%</a:t>
+              <a:t>17%</a:t>
             </a:r>
           </a:p>
         </p:txBody>

</xml_diff>